<commit_message>
feat: add real presenter notes to the 8 kept slides
</commit_message>
<xml_diff>
--- a/docs/PropWeb_Pitch_v2.pptx
+++ b/docs/PropWeb_Pitch_v2.pptx
@@ -509,10 +509,8 @@
           <a:lstStyle/>
           <a:p>
             <a:r>
-              <a:rPr lang="en-US" dirty="0"/>
-              <a:t/>
-            </a:r>
-            <a:endParaRPr lang="en-US" dirty="0"/>
+              <a:t>Open cold: this is the one-line pitch. Say it, don't read it — "PropWeb is India's trust-first, AI-powered rental platform: verified owners meet verified tenants directly, no brokers, no fake listings, no spam calls." Pause after the tagline before moving to the problem slide — let the promise land before you justify it.</a:t>
+            </a:r>
           </a:p>
         </p:txBody>
       </p:sp>
@@ -597,10 +595,8 @@
           <a:lstStyle/>
           <a:p>
             <a:r>
-              <a:rPr lang="en-US" dirty="0"/>
-              <a:t/>
-            </a:r>
-            <a:endParaRPr lang="en-US" dirty="0"/>
+              <a:t>Walk both columns — don't just read the tenant side. The room already knows renting is broken; the point is naming both sides of the pain so the solution slide lands as a genuine two-sided fix, not a tenant-only app. If asked "isn't this just NoBroker," hold that for the next slide.</a:t>
+            </a:r>
           </a:p>
         </p:txBody>
       </p:sp>
@@ -685,10 +681,8 @@
           <a:lstStyle/>
           <a:p>
             <a:r>
-              <a:rPr lang="en-US" dirty="0"/>
-              <a:t/>
-            </a:r>
-            <a:endParaRPr lang="en-US" dirty="0"/>
+              <a:t>These four numbers carry the slide — let them breathe, don't rush to the NoBroker line. The NoBroker callout is the pre-emptive answer to "hasn't this already been solved" — say revenue and loss together, in the same breath: proof of demand, proof the trust layer is still broken.</a:t>
+            </a:r>
           </a:p>
         </p:txBody>
       </p:sp>
@@ -773,10 +767,8 @@
           <a:lstStyle/>
           <a:p>
             <a:r>
-              <a:rPr lang="en-US" dirty="0"/>
-              <a:t/>
-            </a:r>
-            <a:endParaRPr lang="en-US" dirty="0"/>
+              <a:t>Six pillars, but only two are truly new to the room: Pay-to-Connect and the Trust Score — spend your time there. Verified badges and matchmaking are easy to nod along to; the pay-to-connect economics are what actually kills fake enquiries, so be ready to defend the fee-amount question.</a:t>
+            </a:r>
           </a:p>
         </p:txBody>
       </p:sp>
@@ -861,10 +853,8 @@
           <a:lstStyle/>
           <a:p>
             <a:r>
-              <a:rPr lang="en-US" dirty="0"/>
-              <a:t/>
-            </a:r>
-            <a:endParaRPr lang="en-US" dirty="0"/>
+              <a:t>This is the natural hand-off to the live demo — after "Connect," say "and I can show you this right now" and switch to the demo app. Have it already loaded to the Koramangala search before this slide so the transition has no dead air.</a:t>
+            </a:r>
           </a:p>
         </p:txBody>
       </p:sp>
@@ -949,10 +939,8 @@
           <a:lstStyle/>
           <a:p>
             <a:r>
-              <a:rPr lang="en-US" dirty="0"/>
-              <a:t/>
-            </a:r>
-            <a:endParaRPr lang="en-US" dirty="0"/>
+              <a:t>This slide is doing double duty as the moat argument, along with the closing slide — scam prevention, background checks and digital agreements are what a trust-first platform can sell that a lead-selling portal structurally can't retrofit. If a CEO asks "why can't NoBroker just copy this," point back here.</a:t>
+            </a:r>
           </a:p>
         </p:txBody>
       </p:sp>
@@ -1037,10 +1025,8 @@
           <a:lstStyle/>
           <a:p>
             <a:r>
-              <a:rPr lang="en-US" dirty="0"/>
-              <a:t/>
-            </a:r>
-            <a:endParaRPr lang="en-US" dirty="0"/>
+              <a:t>Two engines, two timeframes — be explicit that "today" funds the company and "tomorrow" is where the real upside is, using NoBroker's own ~50% non-listing mix as the proof point. Don't let this slide turn into a pricing negotiation; final pricing is explicitly TBD with the CEOs.</a:t>
+            </a:r>
           </a:p>
         </p:txBody>
       </p:sp>
@@ -1213,10 +1199,8 @@
           <a:lstStyle/>
           <a:p>
             <a:r>
-              <a:rPr lang="en-US" dirty="0"/>
-              <a:t/>
-            </a:r>
-            <a:endParaRPr lang="en-US" dirty="0"/>
+              <a:t>This is the mic-drop — deliver the two lines slowly, then stop talking. Let "Existing portals sell leads. PropWeb sells trust." sit before you open the floor. If the ask &amp; close slide raised a decision, circle back to it once more before Q&amp;A.</a:t>
+            </a:r>
           </a:p>
         </p:txBody>
       </p:sp>
@@ -1957,6 +1941,10 @@
             <a:prstDash val="solid"/>
           </a:ln>
         </p:spPr>
+        <p:txBody>
+          <a:bodyPr/>
+          <a:p/>
+        </p:txBody>
       </p:sp>
       <p:sp>
         <p:nvSpPr>
@@ -2062,6 +2050,10 @@
             <a:prstDash val="solid"/>
           </a:ln>
         </p:spPr>
+        <p:txBody>
+          <a:bodyPr/>
+          <a:p/>
+        </p:txBody>
       </p:sp>
       <p:sp>
         <p:nvSpPr>
@@ -2167,6 +2159,10 @@
             <a:prstDash val="solid"/>
           </a:ln>
         </p:spPr>
+        <p:txBody>
+          <a:bodyPr/>
+          <a:p/>
+        </p:txBody>
       </p:sp>
       <p:sp>
         <p:nvSpPr>
@@ -2272,6 +2268,10 @@
             <a:prstDash val="solid"/>
           </a:ln>
         </p:spPr>
+        <p:txBody>
+          <a:bodyPr/>
+          <a:p/>
+        </p:txBody>
       </p:sp>
       <p:sp>
         <p:nvSpPr>
@@ -2377,6 +2377,10 @@
             <a:prstDash val="solid"/>
           </a:ln>
         </p:spPr>
+        <p:txBody>
+          <a:bodyPr/>
+          <a:p/>
+        </p:txBody>
       </p:sp>
       <p:sp>
         <p:nvSpPr>
@@ -2482,6 +2486,10 @@
             <a:prstDash val="solid"/>
           </a:ln>
         </p:spPr>
+        <p:txBody>
+          <a:bodyPr/>
+          <a:p/>
+        </p:txBody>
       </p:sp>
       <p:sp>
         <p:nvSpPr>
@@ -2697,6 +2705,10 @@
             <a:prstDash val="solid"/>
           </a:ln>
         </p:spPr>
+        <p:txBody>
+          <a:bodyPr/>
+          <a:p/>
+        </p:txBody>
       </p:sp>
       <p:sp>
         <p:nvSpPr>
@@ -2802,6 +2814,10 @@
             <a:prstDash val="solid"/>
           </a:ln>
         </p:spPr>
+        <p:txBody>
+          <a:bodyPr/>
+          <a:p/>
+        </p:txBody>
       </p:sp>
       <p:sp>
         <p:nvSpPr>
@@ -2907,6 +2923,10 @@
             <a:prstDash val="solid"/>
           </a:ln>
         </p:spPr>
+        <p:txBody>
+          <a:bodyPr/>
+          <a:p/>
+        </p:txBody>
       </p:sp>
       <p:sp>
         <p:nvSpPr>
@@ -3012,6 +3032,10 @@
             <a:prstDash val="solid"/>
           </a:ln>
         </p:spPr>
+        <p:txBody>
+          <a:bodyPr/>
+          <a:p/>
+        </p:txBody>
       </p:sp>
       <p:sp>
         <p:nvSpPr>
@@ -3322,6 +3346,10 @@
             <a:prstDash val="solid"/>
           </a:ln>
         </p:spPr>
+        <p:txBody>
+          <a:bodyPr/>
+          <a:p/>
+        </p:txBody>
       </p:sp>
       <p:sp>
         <p:nvSpPr>
@@ -3342,6 +3370,10 @@
           </a:solidFill>
           <a:ln/>
         </p:spPr>
+        <p:txBody>
+          <a:bodyPr/>
+          <a:p/>
+        </p:txBody>
       </p:sp>
       <p:sp>
         <p:nvSpPr>
@@ -3447,6 +3479,10 @@
             <a:prstDash val="solid"/>
           </a:ln>
         </p:spPr>
+        <p:txBody>
+          <a:bodyPr/>
+          <a:p/>
+        </p:txBody>
       </p:sp>
       <p:sp>
         <p:nvSpPr>
@@ -3467,6 +3503,10 @@
           </a:solidFill>
           <a:ln/>
         </p:spPr>
+        <p:txBody>
+          <a:bodyPr/>
+          <a:p/>
+        </p:txBody>
       </p:sp>
       <p:sp>
         <p:nvSpPr>
@@ -3572,6 +3612,10 @@
             <a:prstDash val="solid"/>
           </a:ln>
         </p:spPr>
+        <p:txBody>
+          <a:bodyPr/>
+          <a:p/>
+        </p:txBody>
       </p:sp>
       <p:sp>
         <p:nvSpPr>
@@ -3592,6 +3636,10 @@
           </a:solidFill>
           <a:ln/>
         </p:spPr>
+        <p:txBody>
+          <a:bodyPr/>
+          <a:p/>
+        </p:txBody>
       </p:sp>
       <p:sp>
         <p:nvSpPr>
@@ -3697,6 +3745,10 @@
             <a:prstDash val="solid"/>
           </a:ln>
         </p:spPr>
+        <p:txBody>
+          <a:bodyPr/>
+          <a:p/>
+        </p:txBody>
       </p:sp>
       <p:sp>
         <p:nvSpPr>
@@ -3717,6 +3769,10 @@
           </a:solidFill>
           <a:ln/>
         </p:spPr>
+        <p:txBody>
+          <a:bodyPr/>
+          <a:p/>
+        </p:txBody>
       </p:sp>
       <p:sp>
         <p:nvSpPr>
@@ -3822,6 +3878,10 @@
             <a:prstDash val="solid"/>
           </a:ln>
         </p:spPr>
+        <p:txBody>
+          <a:bodyPr/>
+          <a:p/>
+        </p:txBody>
       </p:sp>
       <p:sp>
         <p:nvSpPr>
@@ -3842,6 +3902,10 @@
           </a:solidFill>
           <a:ln/>
         </p:spPr>
+        <p:txBody>
+          <a:bodyPr/>
+          <a:p/>
+        </p:txBody>
       </p:sp>
       <p:sp>
         <p:nvSpPr>
@@ -3947,6 +4011,10 @@
             <a:prstDash val="solid"/>
           </a:ln>
         </p:spPr>
+        <p:txBody>
+          <a:bodyPr/>
+          <a:p/>
+        </p:txBody>
       </p:sp>
       <p:sp>
         <p:nvSpPr>
@@ -3967,6 +4035,10 @@
           </a:solidFill>
           <a:ln/>
         </p:spPr>
+        <p:txBody>
+          <a:bodyPr/>
+          <a:p/>
+        </p:txBody>
       </p:sp>
       <p:sp>
         <p:nvSpPr>
@@ -4182,6 +4254,10 @@
             <a:prstDash val="solid"/>
           </a:ln>
         </p:spPr>
+        <p:txBody>
+          <a:bodyPr/>
+          <a:p/>
+        </p:txBody>
       </p:sp>
       <p:sp>
         <p:nvSpPr>
@@ -4326,6 +4402,10 @@
             <a:prstDash val="solid"/>
           </a:ln>
         </p:spPr>
+        <p:txBody>
+          <a:bodyPr/>
+          <a:p/>
+        </p:txBody>
       </p:sp>
       <p:sp>
         <p:nvSpPr>
@@ -4470,6 +4550,10 @@
             <a:prstDash val="solid"/>
           </a:ln>
         </p:spPr>
+        <p:txBody>
+          <a:bodyPr/>
+          <a:p/>
+        </p:txBody>
       </p:sp>
       <p:sp>
         <p:nvSpPr>
@@ -4614,6 +4698,10 @@
             <a:prstDash val="solid"/>
           </a:ln>
         </p:spPr>
+        <p:txBody>
+          <a:bodyPr/>
+          <a:p/>
+        </p:txBody>
       </p:sp>
       <p:sp>
         <p:nvSpPr>
@@ -4868,6 +4956,10 @@
             <a:prstDash val="solid"/>
           </a:ln>
         </p:spPr>
+        <p:txBody>
+          <a:bodyPr/>
+          <a:p/>
+        </p:txBody>
       </p:sp>
       <p:sp>
         <p:nvSpPr>
@@ -4973,6 +5065,10 @@
             <a:prstDash val="solid"/>
           </a:ln>
         </p:spPr>
+        <p:txBody>
+          <a:bodyPr/>
+          <a:p/>
+        </p:txBody>
       </p:sp>
       <p:sp>
         <p:nvSpPr>
@@ -5078,6 +5174,10 @@
             <a:prstDash val="solid"/>
           </a:ln>
         </p:spPr>
+        <p:txBody>
+          <a:bodyPr/>
+          <a:p/>
+        </p:txBody>
       </p:sp>
       <p:sp>
         <p:nvSpPr>
@@ -5293,6 +5393,10 @@
             <a:prstDash val="solid"/>
           </a:ln>
         </p:spPr>
+        <p:txBody>
+          <a:bodyPr/>
+          <a:p/>
+        </p:txBody>
       </p:sp>
       <p:sp>
         <p:nvSpPr>
@@ -5519,6 +5623,10 @@
             <a:prstDash val="solid"/>
           </a:ln>
         </p:spPr>
+        <p:txBody>
+          <a:bodyPr/>
+          <a:p/>
+        </p:txBody>
       </p:sp>
       <p:sp>
         <p:nvSpPr>

</xml_diff>

<commit_message>
feat: add Market opportunity slide
</commit_message>
<xml_diff>
--- a/docs/PropWeb_Pitch_v2.pptx
+++ b/docs/PropWeb_Pitch_v2.pptx
@@ -14,6 +14,7 @@
     <p:sldId id="262" r:id="rId8"/>
     <p:sldId id="263" r:id="rId9"/>
     <p:sldId id="264" r:id="rId10"/>
+    <p:sldId id="265" r:id="rId16"/>
   </p:sldIdLst>
   <p:notesMasterIdLst>
     <p:notesMasterId r:id="rId11"/>
@@ -543,6 +544,76 @@
         <p14:creationId xmlns:p14="http://schemas.microsoft.com/office/powerpoint/2010/main" val="1024086991"/>
       </p:ext>
     </p:extLst>
+  </p:cSld>
+  <p:clrMapOvr>
+    <a:masterClrMapping/>
+  </p:clrMapOvr>
+</p:notes>
+</file>
+
+<file path=ppt/notesSlides/notesSlide10.xml><?xml version="1.0" encoding="utf-8"?>
+<p:notes xmlns:a="http://schemas.openxmlformats.org/drawingml/2006/main" xmlns:p="http://schemas.openxmlformats.org/presentationml/2006/main" xmlns:r="http://schemas.openxmlformats.org/officeDocument/2006/relationships">
+  <p:cSld>
+    <p:spTree>
+      <p:nvGrpSpPr>
+        <p:cNvPr id="1" name=""/>
+        <p:cNvGrpSpPr/>
+        <p:nvPr/>
+      </p:nvGrpSpPr>
+      <p:grpSpPr>
+        <a:xfrm>
+          <a:off x="0" y="0"/>
+          <a:ext cx="0" cy="0"/>
+          <a:chOff x="0" y="0"/>
+          <a:chExt cx="0" cy="0"/>
+        </a:xfrm>
+      </p:grpSpPr>
+      <p:sp>
+        <p:nvSpPr>
+          <p:cNvPr id="2" name="Slide Image Placeholder 1"/>
+          <p:cNvSpPr>
+            <a:spLocks noGrp="1"/>
+          </p:cNvSpPr>
+          <p:nvPr>
+            <p:ph type="sldImg" idx="2"/>
+          </p:nvPr>
+        </p:nvSpPr>
+        <p:spPr/>
+      </p:sp>
+      <p:sp>
+        <p:nvSpPr>
+          <p:cNvPr id="3" name="Notes Placeholder 2"/>
+          <p:cNvSpPr>
+            <a:spLocks noGrp="1"/>
+          </p:cNvSpPr>
+          <p:nvPr>
+            <p:ph type="body" idx="3" sz="quarter"/>
+          </p:nvPr>
+        </p:nvSpPr>
+        <p:spPr/>
+        <p:txBody>
+          <a:bodyPr/>
+          <a:lstStyle/>
+          <a:p>
+            <a:r>
+              <a:t>This slide exists to pre-empt the "is this market even big enough" question before it's asked — lead with the CAGR, not the dollar figure; growth rate is the more persuasive number in the room. Bengaluru isn't arbitrary: name the three reasons (rental velocity, brokerage pain, digital readiness) so it reads as a decision, not a default.</a:t>
+            </a:r>
+          </a:p>
+        </p:txBody>
+      </p:sp>
+      <p:sp>
+        <p:nvSpPr>
+          <p:cNvPr id="4" name="Slide Number Placeholder 3"/>
+          <p:cNvSpPr>
+            <a:spLocks noGrp="1"/>
+          </p:cNvSpPr>
+          <p:nvPr>
+            <p:ph type="sldNum" idx="5" sz="quarter"/>
+          </p:nvPr>
+        </p:nvSpPr>
+        <p:spPr/>
+      </p:sp>
+    </p:spTree>
   </p:cSld>
   <p:clrMapOvr>
     <a:masterClrMapping/>
@@ -1735,6 +1806,627 @@
 </p:sld>
 </file>
 
+<file path=ppt/slides/slide10.xml><?xml version="1.0" encoding="utf-8"?>
+<p:sld xmlns:a="http://schemas.openxmlformats.org/drawingml/2006/main" xmlns:p="http://schemas.openxmlformats.org/presentationml/2006/main" xmlns:r="http://schemas.openxmlformats.org/officeDocument/2006/relationships">
+  <p:cSld>
+    <p:bg>
+      <p:bgPr>
+        <a:solidFill>
+          <a:srgbClr val="FFFFFF"/>
+        </a:solidFill>
+        <a:effectLst/>
+      </p:bgPr>
+    </p:bg>
+    <p:spTree>
+      <p:nvGrpSpPr>
+        <p:cNvPr id="1" name=""/>
+        <p:cNvGrpSpPr/>
+        <p:nvPr/>
+      </p:nvGrpSpPr>
+      <p:grpSpPr/>
+      <p:sp>
+        <p:nvSpPr>
+          <p:cNvPr id="2" name="TextBox 1"/>
+          <p:cNvSpPr txBox="1"/>
+          <p:nvPr/>
+        </p:nvSpPr>
+        <p:spPr>
+          <a:xfrm>
+            <a:off x="640080" y="502920"/>
+            <a:ext cx="7315200" cy="320040"/>
+          </a:xfrm>
+          <a:prstGeom prst="rect">
+            <a:avLst/>
+          </a:prstGeom>
+          <a:noFill/>
+        </p:spPr>
+        <p:txBody>
+          <a:bodyPr wrap="square" anchor="ctr">
+            <a:spAutoFit/>
+          </a:bodyPr>
+          <a:lstStyle/>
+          <a:p>
+            <a:pPr algn="l"/>
+            <a:r>
+              <a:rPr sz="1200" b="1" spc="300">
+                <a:solidFill>
+                  <a:srgbClr val="0E6E5C"/>
+                </a:solidFill>
+                <a:latin typeface="Calibri"/>
+              </a:rPr>
+              <a:t>THE OPPORTUNITY</a:t>
+            </a:r>
+          </a:p>
+        </p:txBody>
+      </p:sp>
+      <p:sp>
+        <p:nvSpPr>
+          <p:cNvPr id="3" name="TextBox 2"/>
+          <p:cNvSpPr txBox="1"/>
+          <p:nvPr/>
+        </p:nvSpPr>
+        <p:spPr>
+          <a:xfrm>
+            <a:off x="640080" y="868680"/>
+            <a:ext cx="10881360" cy="777240"/>
+          </a:xfrm>
+          <a:prstGeom prst="rect">
+            <a:avLst/>
+          </a:prstGeom>
+          <a:noFill/>
+        </p:spPr>
+        <p:txBody>
+          <a:bodyPr wrap="square" anchor="ctr">
+            <a:spAutoFit/>
+          </a:bodyPr>
+          <a:lstStyle/>
+          <a:p>
+            <a:pPr algn="l"/>
+            <a:r>
+              <a:rPr sz="3000" b="1">
+                <a:solidFill>
+                  <a:srgbClr val="141821"/>
+                </a:solidFill>
+                <a:latin typeface="Calibri"/>
+              </a:rPr>
+              <a:t>A large market with an unsolved trust gap.</a:t>
+            </a:r>
+          </a:p>
+        </p:txBody>
+      </p:sp>
+      <p:sp>
+        <p:nvSpPr>
+          <p:cNvPr id="4" name="Rounded Rectangle 3"/>
+          <p:cNvSpPr/>
+          <p:nvPr/>
+        </p:nvSpPr>
+        <p:spPr>
+          <a:xfrm>
+            <a:off x="640080" y="2103120"/>
+            <a:ext cx="2570586" cy="2377440"/>
+          </a:xfrm>
+          <a:prstGeom prst="roundRect">
+            <a:avLst>
+              <a:gd name="adj" fmla="val 3077"/>
+            </a:avLst>
+          </a:prstGeom>
+          <a:solidFill>
+            <a:srgbClr val="F2F7F5"/>
+          </a:solidFill>
+          <a:ln w="9525">
+            <a:solidFill>
+              <a:srgbClr val="D8DEE4"/>
+            </a:solidFill>
+          </a:ln>
+          <a:effectLst/>
+        </p:spPr>
+        <p:style>
+          <a:lnRef idx="1">
+            <a:schemeClr val="accent1"/>
+          </a:lnRef>
+          <a:fillRef idx="3">
+            <a:schemeClr val="accent1"/>
+          </a:fillRef>
+          <a:effectRef idx="2">
+            <a:schemeClr val="accent1"/>
+          </a:effectRef>
+          <a:fontRef idx="minor">
+            <a:schemeClr val="lt1"/>
+          </a:fontRef>
+        </p:style>
+        <p:txBody>
+          <a:bodyPr rtlCol="0" anchor="ctr"/>
+          <a:lstStyle/>
+          <a:p>
+            <a:pPr algn="ctr"/>
+          </a:p>
+        </p:txBody>
+      </p:sp>
+      <p:sp>
+        <p:nvSpPr>
+          <p:cNvPr id="5" name="TextBox 4"/>
+          <p:cNvSpPr txBox="1"/>
+          <p:nvPr/>
+        </p:nvSpPr>
+        <p:spPr>
+          <a:xfrm>
+            <a:off x="640080" y="2377440"/>
+            <a:ext cx="2570586" cy="868680"/>
+          </a:xfrm>
+          <a:prstGeom prst="rect">
+            <a:avLst/>
+          </a:prstGeom>
+          <a:noFill/>
+        </p:spPr>
+        <p:txBody>
+          <a:bodyPr wrap="square" anchor="ctr">
+            <a:spAutoFit/>
+          </a:bodyPr>
+          <a:lstStyle/>
+          <a:p>
+            <a:pPr algn="ctr"/>
+            <a:r>
+              <a:rPr sz="3600" b="1">
+                <a:solidFill>
+                  <a:srgbClr val="0E6E5C"/>
+                </a:solidFill>
+                <a:latin typeface="Calibri"/>
+              </a:rPr>
+              <a:t>$1.3–1.7B</a:t>
+            </a:r>
+          </a:p>
+        </p:txBody>
+      </p:sp>
+      <p:sp>
+        <p:nvSpPr>
+          <p:cNvPr id="6" name="TextBox 5"/>
+          <p:cNvSpPr txBox="1"/>
+          <p:nvPr/>
+        </p:nvSpPr>
+        <p:spPr>
+          <a:xfrm>
+            <a:off x="822960" y="3291840"/>
+            <a:ext cx="2204826" cy="1051560"/>
+          </a:xfrm>
+          <a:prstGeom prst="rect">
+            <a:avLst/>
+          </a:prstGeom>
+          <a:noFill/>
+        </p:spPr>
+        <p:txBody>
+          <a:bodyPr wrap="square" anchor="t">
+            <a:spAutoFit/>
+          </a:bodyPr>
+          <a:lstStyle/>
+          <a:p>
+            <a:pPr algn="ctr"/>
+            <a:r>
+              <a:rPr sz="1250" b="0">
+                <a:solidFill>
+                  <a:srgbClr val="5A6270"/>
+                </a:solidFill>
+                <a:latin typeface="Calibri"/>
+              </a:rPr>
+              <a:t>India proptech market size (2025)</a:t>
+            </a:r>
+          </a:p>
+        </p:txBody>
+      </p:sp>
+      <p:sp>
+        <p:nvSpPr>
+          <p:cNvPr id="7" name="Rounded Rectangle 6"/>
+          <p:cNvSpPr/>
+          <p:nvPr/>
+        </p:nvSpPr>
+        <p:spPr>
+          <a:xfrm>
+            <a:off x="3420498" y="2103120"/>
+            <a:ext cx="2570586" cy="2377440"/>
+          </a:xfrm>
+          <a:prstGeom prst="roundRect">
+            <a:avLst>
+              <a:gd name="adj" fmla="val 3077"/>
+            </a:avLst>
+          </a:prstGeom>
+          <a:solidFill>
+            <a:srgbClr val="F2F7F5"/>
+          </a:solidFill>
+          <a:ln w="9525">
+            <a:solidFill>
+              <a:srgbClr val="D8DEE4"/>
+            </a:solidFill>
+          </a:ln>
+          <a:effectLst/>
+        </p:spPr>
+        <p:style>
+          <a:lnRef idx="1">
+            <a:schemeClr val="accent1"/>
+          </a:lnRef>
+          <a:fillRef idx="3">
+            <a:schemeClr val="accent1"/>
+          </a:fillRef>
+          <a:effectRef idx="2">
+            <a:schemeClr val="accent1"/>
+          </a:effectRef>
+          <a:fontRef idx="minor">
+            <a:schemeClr val="lt1"/>
+          </a:fontRef>
+        </p:style>
+        <p:txBody>
+          <a:bodyPr rtlCol="0" anchor="ctr"/>
+          <a:lstStyle/>
+          <a:p>
+            <a:pPr algn="ctr"/>
+          </a:p>
+        </p:txBody>
+      </p:sp>
+      <p:sp>
+        <p:nvSpPr>
+          <p:cNvPr id="8" name="TextBox 7"/>
+          <p:cNvSpPr txBox="1"/>
+          <p:nvPr/>
+        </p:nvSpPr>
+        <p:spPr>
+          <a:xfrm>
+            <a:off x="3420498" y="2377440"/>
+            <a:ext cx="2570586" cy="868680"/>
+          </a:xfrm>
+          <a:prstGeom prst="rect">
+            <a:avLst/>
+          </a:prstGeom>
+          <a:noFill/>
+        </p:spPr>
+        <p:txBody>
+          <a:bodyPr wrap="square" anchor="ctr">
+            <a:spAutoFit/>
+          </a:bodyPr>
+          <a:lstStyle/>
+          <a:p>
+            <a:pPr algn="ctr"/>
+            <a:r>
+              <a:rPr sz="3600" b="1">
+                <a:solidFill>
+                  <a:srgbClr val="0E6E5C"/>
+                </a:solidFill>
+                <a:latin typeface="Calibri"/>
+              </a:rPr>
+              <a:t>12–19%</a:t>
+            </a:r>
+          </a:p>
+        </p:txBody>
+      </p:sp>
+      <p:sp>
+        <p:nvSpPr>
+          <p:cNvPr id="9" name="TextBox 8"/>
+          <p:cNvSpPr txBox="1"/>
+          <p:nvPr/>
+        </p:nvSpPr>
+        <p:spPr>
+          <a:xfrm>
+            <a:off x="3603378" y="3291840"/>
+            <a:ext cx="2204826" cy="1051560"/>
+          </a:xfrm>
+          <a:prstGeom prst="rect">
+            <a:avLst/>
+          </a:prstGeom>
+          <a:noFill/>
+        </p:spPr>
+        <p:txBody>
+          <a:bodyPr wrap="square" anchor="t">
+            <a:spAutoFit/>
+          </a:bodyPr>
+          <a:lstStyle/>
+          <a:p>
+            <a:pPr algn="ctr"/>
+            <a:r>
+              <a:rPr sz="1250" b="0">
+                <a:solidFill>
+                  <a:srgbClr val="5A6270"/>
+                </a:solidFill>
+                <a:latin typeface="Calibri"/>
+              </a:rPr>
+              <a:t>CAGR — proptech growth rate</a:t>
+            </a:r>
+          </a:p>
+        </p:txBody>
+      </p:sp>
+      <p:sp>
+        <p:nvSpPr>
+          <p:cNvPr id="10" name="Rounded Rectangle 9"/>
+          <p:cNvSpPr/>
+          <p:nvPr/>
+        </p:nvSpPr>
+        <p:spPr>
+          <a:xfrm>
+            <a:off x="6200916" y="2103120"/>
+            <a:ext cx="2570586" cy="2377440"/>
+          </a:xfrm>
+          <a:prstGeom prst="roundRect">
+            <a:avLst>
+              <a:gd name="adj" fmla="val 3077"/>
+            </a:avLst>
+          </a:prstGeom>
+          <a:solidFill>
+            <a:srgbClr val="F2F7F5"/>
+          </a:solidFill>
+          <a:ln w="9525">
+            <a:solidFill>
+              <a:srgbClr val="D8DEE4"/>
+            </a:solidFill>
+          </a:ln>
+          <a:effectLst/>
+        </p:spPr>
+        <p:style>
+          <a:lnRef idx="1">
+            <a:schemeClr val="accent1"/>
+          </a:lnRef>
+          <a:fillRef idx="3">
+            <a:schemeClr val="accent1"/>
+          </a:fillRef>
+          <a:effectRef idx="2">
+            <a:schemeClr val="accent1"/>
+          </a:effectRef>
+          <a:fontRef idx="minor">
+            <a:schemeClr val="lt1"/>
+          </a:fontRef>
+        </p:style>
+        <p:txBody>
+          <a:bodyPr rtlCol="0" anchor="ctr"/>
+          <a:lstStyle/>
+          <a:p>
+            <a:pPr algn="ctr"/>
+          </a:p>
+        </p:txBody>
+      </p:sp>
+      <p:sp>
+        <p:nvSpPr>
+          <p:cNvPr id="11" name="TextBox 10"/>
+          <p:cNvSpPr txBox="1"/>
+          <p:nvPr/>
+        </p:nvSpPr>
+        <p:spPr>
+          <a:xfrm>
+            <a:off x="6200916" y="2377440"/>
+            <a:ext cx="2570586" cy="868680"/>
+          </a:xfrm>
+          <a:prstGeom prst="rect">
+            <a:avLst/>
+          </a:prstGeom>
+          <a:noFill/>
+        </p:spPr>
+        <p:txBody>
+          <a:bodyPr wrap="square" anchor="ctr">
+            <a:spAutoFit/>
+          </a:bodyPr>
+          <a:lstStyle/>
+          <a:p>
+            <a:pPr algn="ctr"/>
+            <a:r>
+              <a:rPr sz="3600" b="1">
+                <a:solidFill>
+                  <a:srgbClr val="0E6E5C"/>
+                </a:solidFill>
+                <a:latin typeface="Calibri"/>
+              </a:rPr>
+              <a:t>$20B</a:t>
+            </a:r>
+          </a:p>
+        </p:txBody>
+      </p:sp>
+      <p:sp>
+        <p:nvSpPr>
+          <p:cNvPr id="12" name="TextBox 11"/>
+          <p:cNvSpPr txBox="1"/>
+          <p:nvPr/>
+        </p:nvSpPr>
+        <p:spPr>
+          <a:xfrm>
+            <a:off x="6383796" y="3291840"/>
+            <a:ext cx="2204826" cy="1051560"/>
+          </a:xfrm>
+          <a:prstGeom prst="rect">
+            <a:avLst/>
+          </a:prstGeom>
+          <a:noFill/>
+        </p:spPr>
+        <p:txBody>
+          <a:bodyPr wrap="square" anchor="t">
+            <a:spAutoFit/>
+          </a:bodyPr>
+          <a:lstStyle/>
+          <a:p>
+            <a:pPr algn="ctr"/>
+            <a:r>
+              <a:rPr sz="1250" b="0">
+                <a:solidFill>
+                  <a:srgbClr val="5A6270"/>
+                </a:solidFill>
+                <a:latin typeface="Calibri"/>
+              </a:rPr>
+              <a:t>Indian rental market size</a:t>
+            </a:r>
+          </a:p>
+        </p:txBody>
+      </p:sp>
+      <p:sp>
+        <p:nvSpPr>
+          <p:cNvPr id="13" name="Rounded Rectangle 12"/>
+          <p:cNvSpPr/>
+          <p:nvPr/>
+        </p:nvSpPr>
+        <p:spPr>
+          <a:xfrm>
+            <a:off x="8981334" y="2103120"/>
+            <a:ext cx="2570586" cy="2377440"/>
+          </a:xfrm>
+          <a:prstGeom prst="roundRect">
+            <a:avLst>
+              <a:gd name="adj" fmla="val 3077"/>
+            </a:avLst>
+          </a:prstGeom>
+          <a:solidFill>
+            <a:srgbClr val="F2F7F5"/>
+          </a:solidFill>
+          <a:ln w="9525">
+            <a:solidFill>
+              <a:srgbClr val="D8DEE4"/>
+            </a:solidFill>
+          </a:ln>
+          <a:effectLst/>
+        </p:spPr>
+        <p:style>
+          <a:lnRef idx="1">
+            <a:schemeClr val="accent1"/>
+          </a:lnRef>
+          <a:fillRef idx="3">
+            <a:schemeClr val="accent1"/>
+          </a:fillRef>
+          <a:effectRef idx="2">
+            <a:schemeClr val="accent1"/>
+          </a:effectRef>
+          <a:fontRef idx="minor">
+            <a:schemeClr val="lt1"/>
+          </a:fontRef>
+        </p:style>
+        <p:txBody>
+          <a:bodyPr rtlCol="0" anchor="ctr"/>
+          <a:lstStyle/>
+          <a:p>
+            <a:pPr algn="ctr"/>
+          </a:p>
+        </p:txBody>
+      </p:sp>
+      <p:sp>
+        <p:nvSpPr>
+          <p:cNvPr id="14" name="TextBox 13"/>
+          <p:cNvSpPr txBox="1"/>
+          <p:nvPr/>
+        </p:nvSpPr>
+        <p:spPr>
+          <a:xfrm>
+            <a:off x="8981334" y="2377440"/>
+            <a:ext cx="2570586" cy="868680"/>
+          </a:xfrm>
+          <a:prstGeom prst="rect">
+            <a:avLst/>
+          </a:prstGeom>
+          <a:noFill/>
+        </p:spPr>
+        <p:txBody>
+          <a:bodyPr wrap="square" anchor="ctr">
+            <a:spAutoFit/>
+          </a:bodyPr>
+          <a:lstStyle/>
+          <a:p>
+            <a:pPr algn="ctr"/>
+            <a:r>
+              <a:rPr sz="3600" b="1">
+                <a:solidFill>
+                  <a:srgbClr val="0E6E5C"/>
+                </a:solidFill>
+                <a:latin typeface="Calibri"/>
+              </a:rPr>
+              <a:t>Bengaluru</a:t>
+            </a:r>
+          </a:p>
+        </p:txBody>
+      </p:sp>
+      <p:sp>
+        <p:nvSpPr>
+          <p:cNvPr id="15" name="TextBox 14"/>
+          <p:cNvSpPr txBox="1"/>
+          <p:nvPr/>
+        </p:nvSpPr>
+        <p:spPr>
+          <a:xfrm>
+            <a:off x="9164214" y="3291840"/>
+            <a:ext cx="2204826" cy="1051560"/>
+          </a:xfrm>
+          <a:prstGeom prst="rect">
+            <a:avLst/>
+          </a:prstGeom>
+          <a:noFill/>
+        </p:spPr>
+        <p:txBody>
+          <a:bodyPr wrap="square" anchor="t">
+            <a:spAutoFit/>
+          </a:bodyPr>
+          <a:lstStyle/>
+          <a:p>
+            <a:pPr algn="ctr"/>
+            <a:r>
+              <a:rPr sz="1250" b="0">
+                <a:solidFill>
+                  <a:srgbClr val="5A6270"/>
+                </a:solidFill>
+                <a:latin typeface="Calibri"/>
+              </a:rPr>
+              <a:t>launch wedge: highest rental velocity, highest brokerage pain, most digitally-ready renters</a:t>
+            </a:r>
+          </a:p>
+        </p:txBody>
+      </p:sp>
+      <p:sp>
+        <p:nvSpPr>
+          <p:cNvPr id="16" name="TextBox 15"/>
+          <p:cNvSpPr txBox="1"/>
+          <p:nvPr/>
+        </p:nvSpPr>
+        <p:spPr>
+          <a:xfrm>
+            <a:off x="640080" y="4892040"/>
+            <a:ext cx="10972800" cy="914400"/>
+          </a:xfrm>
+          <a:prstGeom prst="rect">
+            <a:avLst/>
+          </a:prstGeom>
+          <a:noFill/>
+        </p:spPr>
+        <p:txBody>
+          <a:bodyPr wrap="square" anchor="ctr">
+            <a:spAutoFit/>
+          </a:bodyPr>
+          <a:lstStyle/>
+          <a:p>
+            <a:pPr algn="l"/>
+            <a:r>
+              <a:rPr sz="1400" b="0">
+                <a:solidFill>
+                  <a:srgbClr val="5A6270"/>
+                </a:solidFill>
+                <a:latin typeface="Calibri"/>
+              </a:rPr>
+              <a:t>NoBroker already proved renters will pay to skip brokers — </a:t>
+            </a:r>
+            <a:r>
+              <a:rPr sz="1400" b="1">
+                <a:solidFill>
+                  <a:srgbClr val="141821"/>
+                </a:solidFill>
+                <a:latin typeface="Calibri"/>
+              </a:rPr>
+              <a:t>₹803 Cr revenue, 30M+ users</a:t>
+            </a:r>
+            <a:r>
+              <a:rPr sz="1400" b="0">
+                <a:solidFill>
+                  <a:srgbClr val="5A6270"/>
+                </a:solidFill>
+                <a:latin typeface="Calibri"/>
+              </a:rPr>
+              <a:t> — inside a market growing double-digit. Demand is proven; the trust gap PropWeb targets is still wide open.</a:t>
+            </a:r>
+          </a:p>
+        </p:txBody>
+      </p:sp>
+    </p:spTree>
+  </p:cSld>
+  <p:clrMapOvr>
+    <a:masterClrMapping/>
+  </p:clrMapOvr>
+</p:sld>
+</file>
+
 <file path=ppt/slides/slide2.xml><?xml version="1.0" encoding="utf-8"?>
 <p:sld xmlns:a="http://schemas.openxmlformats.org/drawingml/2006/main" xmlns:r="http://schemas.openxmlformats.org/officeDocument/2006/relationships" xmlns:p="http://schemas.openxmlformats.org/presentationml/2006/main">
   <p:cSld name="Slide 2">

</xml_diff>

<commit_message>
feat: add Architecture slide
Add add_architecture_slide() function with modular monolith layout showing four
service modules (Listings & Search, Trust & KYC, Matching Engine, Connect & Payments).
Includes presenter notes explaining the one-application approach for a five-person team.

Co-Authored-By: Claude Sonnet 5 <noreply@anthropic.com>
</commit_message>
<xml_diff>
--- a/docs/PropWeb_Pitch_v2.pptx
+++ b/docs/PropWeb_Pitch_v2.pptx
@@ -15,6 +15,7 @@
     <p:sldId id="263" r:id="rId9"/>
     <p:sldId id="264" r:id="rId10"/>
     <p:sldId id="265" r:id="rId16"/>
+    <p:sldId id="266" r:id="rId17"/>
   </p:sldIdLst>
   <p:notesMasterIdLst>
     <p:notesMasterId r:id="rId11"/>
@@ -597,6 +598,76 @@
           <a:p>
             <a:r>
               <a:t>This slide exists to pre-empt the "is this market even big enough" question before it's asked — lead with the CAGR, not the dollar figure; growth rate is the more persuasive number in the room. Bengaluru isn't arbitrary: name the three reasons (rental velocity, brokerage pain, digital readiness) so it reads as a decision, not a default.</a:t>
+            </a:r>
+          </a:p>
+        </p:txBody>
+      </p:sp>
+      <p:sp>
+        <p:nvSpPr>
+          <p:cNvPr id="4" name="Slide Number Placeholder 3"/>
+          <p:cNvSpPr>
+            <a:spLocks noGrp="1"/>
+          </p:cNvSpPr>
+          <p:nvPr>
+            <p:ph type="sldNum" idx="5" sz="quarter"/>
+          </p:nvPr>
+        </p:nvSpPr>
+        <p:spPr/>
+      </p:sp>
+    </p:spTree>
+  </p:cSld>
+  <p:clrMapOvr>
+    <a:masterClrMapping/>
+  </p:clrMapOvr>
+</p:notes>
+</file>
+
+<file path=ppt/notesSlides/notesSlide11.xml><?xml version="1.0" encoding="utf-8"?>
+<p:notes xmlns:a="http://schemas.openxmlformats.org/drawingml/2006/main" xmlns:p="http://schemas.openxmlformats.org/presentationml/2006/main" xmlns:r="http://schemas.openxmlformats.org/officeDocument/2006/relationships">
+  <p:cSld>
+    <p:spTree>
+      <p:nvGrpSpPr>
+        <p:cNvPr id="1" name=""/>
+        <p:cNvGrpSpPr/>
+        <p:nvPr/>
+      </p:nvGrpSpPr>
+      <p:grpSpPr>
+        <a:xfrm>
+          <a:off x="0" y="0"/>
+          <a:ext cx="0" cy="0"/>
+          <a:chOff x="0" y="0"/>
+          <a:chExt cx="0" cy="0"/>
+        </a:xfrm>
+      </p:grpSpPr>
+      <p:sp>
+        <p:nvSpPr>
+          <p:cNvPr id="2" name="Slide Image Placeholder 1"/>
+          <p:cNvSpPr>
+            <a:spLocks noGrp="1"/>
+          </p:cNvSpPr>
+          <p:nvPr>
+            <p:ph type="sldImg" idx="2"/>
+          </p:nvPr>
+        </p:nvSpPr>
+        <p:spPr/>
+      </p:sp>
+      <p:sp>
+        <p:nvSpPr>
+          <p:cNvPr id="3" name="Notes Placeholder 2"/>
+          <p:cNvSpPr>
+            <a:spLocks noGrp="1"/>
+          </p:cNvSpPr>
+          <p:nvPr>
+            <p:ph type="body" idx="3" sz="quarter"/>
+          </p:nvPr>
+        </p:nvSpPr>
+        <p:spPr/>
+        <p:txBody>
+          <a:bodyPr/>
+          <a:lstStyle/>
+          <a:p>
+            <a:r>
+              <a:t>Keep this slide short on stage — the point is reassurance, not a systems-design lecture. One sentence: "one well-built application, not eleven fragile services, because we're a five-person team for the first year." If a CEO with a technical background pushes on scaling, the honest answer is that a modular monolith splits into services later without a rewrite — say that only if asked.</a:t>
             </a:r>
           </a:p>
         </p:txBody>
@@ -2427,6 +2498,552 @@
 </p:sld>
 </file>
 
+<file path=ppt/slides/slide11.xml><?xml version="1.0" encoding="utf-8"?>
+<p:sld xmlns:a="http://schemas.openxmlformats.org/drawingml/2006/main" xmlns:p="http://schemas.openxmlformats.org/presentationml/2006/main" xmlns:r="http://schemas.openxmlformats.org/officeDocument/2006/relationships">
+  <p:cSld>
+    <p:bg>
+      <p:bgPr>
+        <a:solidFill>
+          <a:srgbClr val="FFFFFF"/>
+        </a:solidFill>
+        <a:effectLst/>
+      </p:bgPr>
+    </p:bg>
+    <p:spTree>
+      <p:nvGrpSpPr>
+        <p:cNvPr id="1" name=""/>
+        <p:cNvGrpSpPr/>
+        <p:nvPr/>
+      </p:nvGrpSpPr>
+      <p:grpSpPr/>
+      <p:sp>
+        <p:nvSpPr>
+          <p:cNvPr id="2" name="TextBox 1"/>
+          <p:cNvSpPr txBox="1"/>
+          <p:nvPr/>
+        </p:nvSpPr>
+        <p:spPr>
+          <a:xfrm>
+            <a:off x="640080" y="502920"/>
+            <a:ext cx="7315200" cy="320040"/>
+          </a:xfrm>
+          <a:prstGeom prst="rect">
+            <a:avLst/>
+          </a:prstGeom>
+          <a:noFill/>
+        </p:spPr>
+        <p:txBody>
+          <a:bodyPr wrap="square" anchor="ctr">
+            <a:spAutoFit/>
+          </a:bodyPr>
+          <a:lstStyle/>
+          <a:p>
+            <a:pPr algn="l"/>
+            <a:r>
+              <a:rPr sz="1200" b="1" spc="300">
+                <a:solidFill>
+                  <a:srgbClr val="0E6E5C"/>
+                </a:solidFill>
+                <a:latin typeface="Calibri"/>
+              </a:rPr>
+              <a:t>ARCHITECTURE</a:t>
+            </a:r>
+          </a:p>
+        </p:txBody>
+      </p:sp>
+      <p:sp>
+        <p:nvSpPr>
+          <p:cNvPr id="3" name="TextBox 2"/>
+          <p:cNvSpPr txBox="1"/>
+          <p:nvPr/>
+        </p:nvSpPr>
+        <p:spPr>
+          <a:xfrm>
+            <a:off x="640080" y="868680"/>
+            <a:ext cx="10881360" cy="777240"/>
+          </a:xfrm>
+          <a:prstGeom prst="rect">
+            <a:avLst/>
+          </a:prstGeom>
+          <a:noFill/>
+        </p:spPr>
+        <p:txBody>
+          <a:bodyPr wrap="square" anchor="ctr">
+            <a:spAutoFit/>
+          </a:bodyPr>
+          <a:lstStyle/>
+          <a:p>
+            <a:pPr algn="l"/>
+            <a:r>
+              <a:rPr sz="3000" b="1">
+                <a:solidFill>
+                  <a:srgbClr val="141821"/>
+                </a:solidFill>
+                <a:latin typeface="Calibri"/>
+              </a:rPr>
+              <a:t>One well-organised building, not eleven services.</a:t>
+            </a:r>
+          </a:p>
+        </p:txBody>
+      </p:sp>
+      <p:sp>
+        <p:nvSpPr>
+          <p:cNvPr id="4" name="Rounded Rectangle 3"/>
+          <p:cNvSpPr/>
+          <p:nvPr/>
+        </p:nvSpPr>
+        <p:spPr>
+          <a:xfrm>
+            <a:off x="640080" y="2103120"/>
+            <a:ext cx="10911840" cy="3474720"/>
+          </a:xfrm>
+          <a:prstGeom prst="roundRect">
+            <a:avLst>
+              <a:gd name="adj" fmla="val 3000"/>
+            </a:avLst>
+          </a:prstGeom>
+          <a:solidFill>
+            <a:srgbClr val="F2F7F5"/>
+          </a:solidFill>
+          <a:ln w="9525">
+            <a:solidFill>
+              <a:srgbClr val="D8DEE4"/>
+            </a:solidFill>
+          </a:ln>
+          <a:effectLst/>
+        </p:spPr>
+        <p:style>
+          <a:lnRef idx="1">
+            <a:schemeClr val="accent1"/>
+          </a:lnRef>
+          <a:fillRef idx="3">
+            <a:schemeClr val="accent1"/>
+          </a:fillRef>
+          <a:effectRef idx="2">
+            <a:schemeClr val="accent1"/>
+          </a:effectRef>
+          <a:fontRef idx="minor">
+            <a:schemeClr val="lt1"/>
+          </a:fontRef>
+        </p:style>
+        <p:txBody>
+          <a:bodyPr rtlCol="0" anchor="ctr"/>
+          <a:lstStyle/>
+          <a:p>
+            <a:pPr algn="ctr"/>
+          </a:p>
+        </p:txBody>
+      </p:sp>
+      <p:sp>
+        <p:nvSpPr>
+          <p:cNvPr id="5" name="TextBox 4"/>
+          <p:cNvSpPr txBox="1"/>
+          <p:nvPr/>
+        </p:nvSpPr>
+        <p:spPr>
+          <a:xfrm>
+            <a:off x="868680" y="2377440"/>
+            <a:ext cx="10454640" cy="365760"/>
+          </a:xfrm>
+          <a:prstGeom prst="rect">
+            <a:avLst/>
+          </a:prstGeom>
+          <a:noFill/>
+        </p:spPr>
+        <p:txBody>
+          <a:bodyPr wrap="square" anchor="ctr">
+            <a:spAutoFit/>
+          </a:bodyPr>
+          <a:lstStyle/>
+          <a:p>
+            <a:pPr algn="l"/>
+            <a:r>
+              <a:rPr sz="1500" b="1">
+                <a:solidFill>
+                  <a:srgbClr val="141821"/>
+                </a:solidFill>
+                <a:latin typeface="Calibri"/>
+              </a:rPr>
+              <a:t>PropWeb — modular monolith</a:t>
+            </a:r>
+          </a:p>
+        </p:txBody>
+      </p:sp>
+      <p:sp>
+        <p:nvSpPr>
+          <p:cNvPr id="6" name="Rounded Rectangle 5"/>
+          <p:cNvSpPr/>
+          <p:nvPr/>
+        </p:nvSpPr>
+        <p:spPr>
+          <a:xfrm>
+            <a:off x="868680" y="2960000"/>
+            <a:ext cx="2476500" cy="1000000"/>
+          </a:xfrm>
+          <a:prstGeom prst="roundRect">
+            <a:avLst>
+              <a:gd name="adj" fmla="val 6061"/>
+            </a:avLst>
+          </a:prstGeom>
+          <a:solidFill>
+            <a:srgbClr val="FFFFFF"/>
+          </a:solidFill>
+          <a:ln w="9525">
+            <a:solidFill>
+              <a:srgbClr val="D8DEE4"/>
+            </a:solidFill>
+          </a:ln>
+          <a:effectLst/>
+        </p:spPr>
+        <p:style>
+          <a:lnRef idx="1">
+            <a:schemeClr val="accent1"/>
+          </a:lnRef>
+          <a:fillRef idx="3">
+            <a:schemeClr val="accent1"/>
+          </a:fillRef>
+          <a:effectRef idx="2">
+            <a:schemeClr val="accent1"/>
+          </a:effectRef>
+          <a:fontRef idx="minor">
+            <a:schemeClr val="lt1"/>
+          </a:fontRef>
+        </p:style>
+        <p:txBody>
+          <a:bodyPr rtlCol="0" anchor="ctr"/>
+          <a:lstStyle/>
+          <a:p>
+            <a:pPr algn="ctr"/>
+          </a:p>
+        </p:txBody>
+      </p:sp>
+      <p:sp>
+        <p:nvSpPr>
+          <p:cNvPr id="7" name="TextBox 6"/>
+          <p:cNvSpPr txBox="1"/>
+          <p:nvPr/>
+        </p:nvSpPr>
+        <p:spPr>
+          <a:xfrm>
+            <a:off x="868680" y="2960000"/>
+            <a:ext cx="2476500" cy="1000000"/>
+          </a:xfrm>
+          <a:prstGeom prst="rect">
+            <a:avLst/>
+          </a:prstGeom>
+          <a:noFill/>
+        </p:spPr>
+        <p:txBody>
+          <a:bodyPr wrap="square" anchor="ctr">
+            <a:spAutoFit/>
+          </a:bodyPr>
+          <a:lstStyle/>
+          <a:p>
+            <a:pPr algn="ctr"/>
+            <a:r>
+              <a:rPr sz="1300" b="1">
+                <a:solidFill>
+                  <a:srgbClr val="0E6E5C"/>
+                </a:solidFill>
+                <a:latin typeface="Calibri"/>
+              </a:rPr>
+              <a:t>Listings &amp; Search</a:t>
+            </a:r>
+          </a:p>
+        </p:txBody>
+      </p:sp>
+      <p:sp>
+        <p:nvSpPr>
+          <p:cNvPr id="8" name="Rounded Rectangle 7"/>
+          <p:cNvSpPr/>
+          <p:nvPr/>
+        </p:nvSpPr>
+        <p:spPr>
+          <a:xfrm>
+            <a:off x="3528060" y="2960000"/>
+            <a:ext cx="2476500" cy="1000000"/>
+          </a:xfrm>
+          <a:prstGeom prst="roundRect">
+            <a:avLst>
+              <a:gd name="adj" fmla="val 6061"/>
+            </a:avLst>
+          </a:prstGeom>
+          <a:solidFill>
+            <a:srgbClr val="FFFFFF"/>
+          </a:solidFill>
+          <a:ln w="9525">
+            <a:solidFill>
+              <a:srgbClr val="D8DEE4"/>
+            </a:solidFill>
+          </a:ln>
+          <a:effectLst/>
+        </p:spPr>
+        <p:style>
+          <a:lnRef idx="1">
+            <a:schemeClr val="accent1"/>
+          </a:lnRef>
+          <a:fillRef idx="3">
+            <a:schemeClr val="accent1"/>
+          </a:fillRef>
+          <a:effectRef idx="2">
+            <a:schemeClr val="accent1"/>
+          </a:effectRef>
+          <a:fontRef idx="minor">
+            <a:schemeClr val="lt1"/>
+          </a:fontRef>
+        </p:style>
+        <p:txBody>
+          <a:bodyPr rtlCol="0" anchor="ctr"/>
+          <a:lstStyle/>
+          <a:p>
+            <a:pPr algn="ctr"/>
+          </a:p>
+        </p:txBody>
+      </p:sp>
+      <p:sp>
+        <p:nvSpPr>
+          <p:cNvPr id="9" name="TextBox 8"/>
+          <p:cNvSpPr txBox="1"/>
+          <p:nvPr/>
+        </p:nvSpPr>
+        <p:spPr>
+          <a:xfrm>
+            <a:off x="3528060" y="2960000"/>
+            <a:ext cx="2476500" cy="1000000"/>
+          </a:xfrm>
+          <a:prstGeom prst="rect">
+            <a:avLst/>
+          </a:prstGeom>
+          <a:noFill/>
+        </p:spPr>
+        <p:txBody>
+          <a:bodyPr wrap="square" anchor="ctr">
+            <a:spAutoFit/>
+          </a:bodyPr>
+          <a:lstStyle/>
+          <a:p>
+            <a:pPr algn="ctr"/>
+            <a:r>
+              <a:rPr sz="1300" b="1">
+                <a:solidFill>
+                  <a:srgbClr val="0E6E5C"/>
+                </a:solidFill>
+                <a:latin typeface="Calibri"/>
+              </a:rPr>
+              <a:t>Trust &amp; KYC</a:t>
+            </a:r>
+          </a:p>
+        </p:txBody>
+      </p:sp>
+      <p:sp>
+        <p:nvSpPr>
+          <p:cNvPr id="10" name="Rounded Rectangle 9"/>
+          <p:cNvSpPr/>
+          <p:nvPr/>
+        </p:nvSpPr>
+        <p:spPr>
+          <a:xfrm>
+            <a:off x="6187440" y="2960000"/>
+            <a:ext cx="2476500" cy="1000000"/>
+          </a:xfrm>
+          <a:prstGeom prst="roundRect">
+            <a:avLst>
+              <a:gd name="adj" fmla="val 6061"/>
+            </a:avLst>
+          </a:prstGeom>
+          <a:solidFill>
+            <a:srgbClr val="FFFFFF"/>
+          </a:solidFill>
+          <a:ln w="9525">
+            <a:solidFill>
+              <a:srgbClr val="D8DEE4"/>
+            </a:solidFill>
+          </a:ln>
+          <a:effectLst/>
+        </p:spPr>
+        <p:style>
+          <a:lnRef idx="1">
+            <a:schemeClr val="accent1"/>
+          </a:lnRef>
+          <a:fillRef idx="3">
+            <a:schemeClr val="accent1"/>
+          </a:fillRef>
+          <a:effectRef idx="2">
+            <a:schemeClr val="accent1"/>
+          </a:effectRef>
+          <a:fontRef idx="minor">
+            <a:schemeClr val="lt1"/>
+          </a:fontRef>
+        </p:style>
+        <p:txBody>
+          <a:bodyPr rtlCol="0" anchor="ctr"/>
+          <a:lstStyle/>
+          <a:p>
+            <a:pPr algn="ctr"/>
+          </a:p>
+        </p:txBody>
+      </p:sp>
+      <p:sp>
+        <p:nvSpPr>
+          <p:cNvPr id="11" name="TextBox 10"/>
+          <p:cNvSpPr txBox="1"/>
+          <p:nvPr/>
+        </p:nvSpPr>
+        <p:spPr>
+          <a:xfrm>
+            <a:off x="6187440" y="2960000"/>
+            <a:ext cx="2476500" cy="1000000"/>
+          </a:xfrm>
+          <a:prstGeom prst="rect">
+            <a:avLst/>
+          </a:prstGeom>
+          <a:noFill/>
+        </p:spPr>
+        <p:txBody>
+          <a:bodyPr wrap="square" anchor="ctr">
+            <a:spAutoFit/>
+          </a:bodyPr>
+          <a:lstStyle/>
+          <a:p>
+            <a:pPr algn="ctr"/>
+            <a:r>
+              <a:rPr sz="1300" b="1">
+                <a:solidFill>
+                  <a:srgbClr val="0E6E5C"/>
+                </a:solidFill>
+                <a:latin typeface="Calibri"/>
+              </a:rPr>
+              <a:t>Matching Engine</a:t>
+            </a:r>
+          </a:p>
+        </p:txBody>
+      </p:sp>
+      <p:sp>
+        <p:nvSpPr>
+          <p:cNvPr id="12" name="Rounded Rectangle 11"/>
+          <p:cNvSpPr/>
+          <p:nvPr/>
+        </p:nvSpPr>
+        <p:spPr>
+          <a:xfrm>
+            <a:off x="8846820" y="2960000"/>
+            <a:ext cx="2476500" cy="1000000"/>
+          </a:xfrm>
+          <a:prstGeom prst="roundRect">
+            <a:avLst>
+              <a:gd name="adj" fmla="val 6061"/>
+            </a:avLst>
+          </a:prstGeom>
+          <a:solidFill>
+            <a:srgbClr val="FFFFFF"/>
+          </a:solidFill>
+          <a:ln w="9525">
+            <a:solidFill>
+              <a:srgbClr val="D8DEE4"/>
+            </a:solidFill>
+          </a:ln>
+          <a:effectLst/>
+        </p:spPr>
+        <p:style>
+          <a:lnRef idx="1">
+            <a:schemeClr val="accent1"/>
+          </a:lnRef>
+          <a:fillRef idx="3">
+            <a:schemeClr val="accent1"/>
+          </a:fillRef>
+          <a:effectRef idx="2">
+            <a:schemeClr val="accent1"/>
+          </a:effectRef>
+          <a:fontRef idx="minor">
+            <a:schemeClr val="lt1"/>
+          </a:fontRef>
+        </p:style>
+        <p:txBody>
+          <a:bodyPr rtlCol="0" anchor="ctr"/>
+          <a:lstStyle/>
+          <a:p>
+            <a:pPr algn="ctr"/>
+          </a:p>
+        </p:txBody>
+      </p:sp>
+      <p:sp>
+        <p:nvSpPr>
+          <p:cNvPr id="13" name="TextBox 12"/>
+          <p:cNvSpPr txBox="1"/>
+          <p:nvPr/>
+        </p:nvSpPr>
+        <p:spPr>
+          <a:xfrm>
+            <a:off x="8846820" y="2960000"/>
+            <a:ext cx="2476500" cy="1000000"/>
+          </a:xfrm>
+          <a:prstGeom prst="rect">
+            <a:avLst/>
+          </a:prstGeom>
+          <a:noFill/>
+        </p:spPr>
+        <p:txBody>
+          <a:bodyPr wrap="square" anchor="ctr">
+            <a:spAutoFit/>
+          </a:bodyPr>
+          <a:lstStyle/>
+          <a:p>
+            <a:pPr algn="ctr"/>
+            <a:r>
+              <a:rPr sz="1300" b="1">
+                <a:solidFill>
+                  <a:srgbClr val="0E6E5C"/>
+                </a:solidFill>
+                <a:latin typeface="Calibri"/>
+              </a:rPr>
+              <a:t>Connect &amp; Payments</a:t>
+            </a:r>
+          </a:p>
+        </p:txBody>
+      </p:sp>
+      <p:sp>
+        <p:nvSpPr>
+          <p:cNvPr id="14" name="TextBox 13"/>
+          <p:cNvSpPr txBox="1"/>
+          <p:nvPr/>
+        </p:nvSpPr>
+        <p:spPr>
+          <a:xfrm>
+            <a:off x="640080" y="5738160"/>
+            <a:ext cx="10911840" cy="365760"/>
+          </a:xfrm>
+          <a:prstGeom prst="rect">
+            <a:avLst/>
+          </a:prstGeom>
+          <a:noFill/>
+        </p:spPr>
+        <p:txBody>
+          <a:bodyPr wrap="square" anchor="ctr">
+            <a:spAutoFit/>
+          </a:bodyPr>
+          <a:lstStyle/>
+          <a:p>
+            <a:pPr algn="l"/>
+            <a:r>
+              <a:rPr sz="1400" b="0">
+                <a:solidFill>
+                  <a:srgbClr val="5A6270"/>
+                </a:solidFill>
+                <a:latin typeface="Calibri"/>
+              </a:rPr>
+              <a:t>Small team, one codebase, one language (TypeScript) — ship fast without distributed-systems overhead.</a:t>
+            </a:r>
+          </a:p>
+        </p:txBody>
+      </p:sp>
+    </p:spTree>
+  </p:cSld>
+  <p:clrMapOvr>
+    <a:masterClrMapping/>
+  </p:clrMapOvr>
+</p:sld>
+</file>
+
 <file path=ppt/slides/slide2.xml><?xml version="1.0" encoding="utf-8"?>
 <p:sld xmlns:a="http://schemas.openxmlformats.org/drawingml/2006/main" xmlns:r="http://schemas.openxmlformats.org/officeDocument/2006/relationships" xmlns:p="http://schemas.openxmlformats.org/presentationml/2006/main">
   <p:cSld name="Slide 2">

</xml_diff>

<commit_message>
fix: restore rupee (₹) and approx (≈) symbols in Stack slide table rows
</commit_message>
<xml_diff>
--- a/docs/PropWeb_Pitch_v2.pptx
+++ b/docs/PropWeb_Pitch_v2.pptx
@@ -12,10 +12,10 @@
     <p:sldId id="260" r:id="rId6"/>
     <p:sldId id="261" r:id="rId7"/>
     <p:sldId id="262" r:id="rId8"/>
-    <p:sldId id="263" r:id="rId9"/>
     <p:sldId id="264" r:id="rId10"/>
     <p:sldId id="265" r:id="rId16"/>
     <p:sldId id="266" r:id="rId17"/>
+    <p:sldId id="267" r:id="rId18"/>
   </p:sldIdLst>
   <p:notesMasterIdLst>
     <p:notesMasterId r:id="rId11"/>
@@ -692,6 +692,76 @@
 </p:notes>
 </file>
 
+<file path=ppt/notesSlides/notesSlide12.xml><?xml version="1.0" encoding="utf-8"?>
+<p:notes xmlns:a="http://schemas.openxmlformats.org/drawingml/2006/main" xmlns:p="http://schemas.openxmlformats.org/presentationml/2006/main" xmlns:r="http://schemas.openxmlformats.org/officeDocument/2006/relationships">
+  <p:cSld>
+    <p:spTree>
+      <p:nvGrpSpPr>
+        <p:cNvPr id="1" name=""/>
+        <p:cNvGrpSpPr/>
+        <p:nvPr/>
+      </p:nvGrpSpPr>
+      <p:grpSpPr>
+        <a:xfrm>
+          <a:off x="0" y="0"/>
+          <a:ext cx="0" cy="0"/>
+          <a:chOff x="0" y="0"/>
+          <a:chExt cx="0" cy="0"/>
+        </a:xfrm>
+      </p:grpSpPr>
+      <p:sp>
+        <p:nvSpPr>
+          <p:cNvPr id="2" name="Slide Image Placeholder 1"/>
+          <p:cNvSpPr>
+            <a:spLocks noGrp="1"/>
+          </p:cNvSpPr>
+          <p:nvPr>
+            <p:ph type="sldImg" idx="2"/>
+          </p:nvPr>
+        </p:nvSpPr>
+        <p:spPr/>
+      </p:sp>
+      <p:sp>
+        <p:nvSpPr>
+          <p:cNvPr id="3" name="Notes Placeholder 2"/>
+          <p:cNvSpPr>
+            <a:spLocks noGrp="1"/>
+          </p:cNvSpPr>
+          <p:nvPr>
+            <p:ph type="body" idx="3" sz="quarter"/>
+          </p:nvPr>
+        </p:nvSpPr>
+        <p:spPr/>
+        <p:txBody>
+          <a:bodyPr/>
+          <a:lstStyle/>
+          <a:p>
+            <a:r>
+              <a:t>Don't read the table row by row — the room doesn't need to know what Typesense is. The only two numbers worth saying out loud are the Algolia cost comparison and the AWS Mumbai/DPDP compliance line, because those are the ones a CEO will actually remember and repeat to an investor.</a:t>
+            </a:r>
+          </a:p>
+        </p:txBody>
+      </p:sp>
+      <p:sp>
+        <p:nvSpPr>
+          <p:cNvPr id="4" name="Slide Number Placeholder 3"/>
+          <p:cNvSpPr>
+            <a:spLocks noGrp="1"/>
+          </p:cNvSpPr>
+          <p:nvPr>
+            <p:ph type="sldNum" idx="5" sz="quarter"/>
+          </p:nvPr>
+        </p:nvSpPr>
+        <p:spPr/>
+      </p:sp>
+    </p:spTree>
+  </p:cSld>
+  <p:clrMapOvr>
+    <a:masterClrMapping/>
+  </p:clrMapOvr>
+</p:notes>
+</file>
+
 <file path=ppt/notesSlides/notesSlide2.xml><?xml version="1.0" encoding="utf-8"?>
 <p:notes xmlns:a="http://schemas.openxmlformats.org/drawingml/2006/main" xmlns:r="http://schemas.openxmlformats.org/officeDocument/2006/relationships" xmlns:p="http://schemas.openxmlformats.org/presentationml/2006/main">
   <p:cSld>
@@ -1190,94 +1260,6 @@
             <a:fld id="{F7021451-1387-4CA6-816F-3879F97B5CBC}" type="slidenum">
               <a:rPr lang="en-US"/>
               <a:t>7</a:t>
-            </a:fld>
-            <a:endParaRPr lang="en-US"/>
-          </a:p>
-        </p:txBody>
-      </p:sp>
-    </p:spTree>
-    <p:extLst>
-      <p:ext uri="{BB962C8B-B14F-4D97-AF65-F5344CB8AC3E}">
-        <p14:creationId xmlns:p14="http://schemas.microsoft.com/office/powerpoint/2010/main" val="1024086991"/>
-      </p:ext>
-    </p:extLst>
-  </p:cSld>
-  <p:clrMapOvr>
-    <a:masterClrMapping/>
-  </p:clrMapOvr>
-</p:notes>
-</file>
-
-<file path=ppt/notesSlides/notesSlide8.xml><?xml version="1.0" encoding="utf-8"?>
-<p:notes xmlns:a="http://schemas.openxmlformats.org/drawingml/2006/main" xmlns:r="http://schemas.openxmlformats.org/officeDocument/2006/relationships" xmlns:p="http://schemas.openxmlformats.org/presentationml/2006/main">
-  <p:cSld>
-    <p:spTree>
-      <p:nvGrpSpPr>
-        <p:cNvPr id="1" name=""/>
-        <p:cNvGrpSpPr/>
-        <p:nvPr/>
-      </p:nvGrpSpPr>
-      <p:grpSpPr>
-        <a:xfrm>
-          <a:off x="0" y="0"/>
-          <a:ext cx="0" cy="0"/>
-          <a:chOff x="0" y="0"/>
-          <a:chExt cx="0" cy="0"/>
-        </a:xfrm>
-      </p:grpSpPr>
-      <p:sp>
-        <p:nvSpPr>
-          <p:cNvPr id="2" name="Slide Image Placeholder 1"/>
-          <p:cNvSpPr>
-            <a:spLocks noGrp="1" noRot="1" noChangeAspect="1"/>
-          </p:cNvSpPr>
-          <p:nvPr>
-            <p:ph type="sldImg"/>
-          </p:nvPr>
-        </p:nvSpPr>
-        <p:spPr/>
-      </p:sp>
-      <p:sp>
-        <p:nvSpPr>
-          <p:cNvPr id="3" name="Notes Placeholder 2"/>
-          <p:cNvSpPr>
-            <a:spLocks noGrp="1"/>
-          </p:cNvSpPr>
-          <p:nvPr>
-            <p:ph type="body" idx="1"/>
-          </p:nvPr>
-        </p:nvSpPr>
-        <p:spPr/>
-        <p:txBody>
-          <a:bodyPr/>
-          <a:lstStyle/>
-          <a:p>
-            <a:r>
-              <a:rPr lang="en-US" dirty="0"/>
-              <a:t/>
-            </a:r>
-            <a:endParaRPr lang="en-US" dirty="0"/>
-          </a:p>
-        </p:txBody>
-      </p:sp>
-      <p:sp>
-        <p:nvSpPr>
-          <p:cNvPr id="4" name="Slide Number Placeholder 3"/>
-          <p:cNvSpPr>
-            <a:spLocks noGrp="1"/>
-          </p:cNvSpPr>
-          <p:nvPr>
-            <p:ph type="sldNum" sz="quarter" idx="10"/>
-          </p:nvPr>
-        </p:nvSpPr>
-        <p:spPr/>
-        <p:txBody>
-          <a:bodyPr/>
-          <a:lstStyle/>
-          <a:p>
-            <a:fld id="{F7021451-1387-4CA6-816F-3879F97B5CBC}" type="slidenum">
-              <a:rPr lang="en-US"/>
-              <a:t>8</a:t>
             </a:fld>
             <a:endParaRPr lang="en-US"/>
           </a:p>
@@ -3044,6 +3026,912 @@
 </p:sld>
 </file>
 
+<file path=ppt/slides/slide12.xml><?xml version="1.0" encoding="utf-8"?>
+<p:sld xmlns:a="http://schemas.openxmlformats.org/drawingml/2006/main" xmlns:p="http://schemas.openxmlformats.org/presentationml/2006/main" xmlns:r="http://schemas.openxmlformats.org/officeDocument/2006/relationships">
+  <p:cSld>
+    <p:bg>
+      <p:bgPr>
+        <a:solidFill>
+          <a:srgbClr val="FFFFFF"/>
+        </a:solidFill>
+        <a:effectLst/>
+      </p:bgPr>
+    </p:bg>
+    <p:spTree>
+      <p:nvGrpSpPr>
+        <p:cNvPr id="1" name=""/>
+        <p:cNvGrpSpPr/>
+        <p:nvPr/>
+      </p:nvGrpSpPr>
+      <p:grpSpPr/>
+      <p:sp>
+        <p:nvSpPr>
+          <p:cNvPr id="2" name="TextBox 1"/>
+          <p:cNvSpPr txBox="1"/>
+          <p:nvPr/>
+        </p:nvSpPr>
+        <p:spPr>
+          <a:xfrm>
+            <a:off x="640080" y="502920"/>
+            <a:ext cx="7315200" cy="320040"/>
+          </a:xfrm>
+          <a:prstGeom prst="rect">
+            <a:avLst/>
+          </a:prstGeom>
+          <a:noFill/>
+        </p:spPr>
+        <p:txBody>
+          <a:bodyPr wrap="square" anchor="ctr">
+            <a:spAutoFit/>
+          </a:bodyPr>
+          <a:lstStyle/>
+          <a:p>
+            <a:pPr algn="l"/>
+            <a:r>
+              <a:rPr sz="1200" b="1" spc="300">
+                <a:solidFill>
+                  <a:srgbClr val="0E6E5C"/>
+                </a:solidFill>
+                <a:latin typeface="Calibri"/>
+              </a:rPr>
+              <a:t>THE STACK</a:t>
+            </a:r>
+          </a:p>
+        </p:txBody>
+      </p:sp>
+      <p:sp>
+        <p:nvSpPr>
+          <p:cNvPr id="3" name="TextBox 2"/>
+          <p:cNvSpPr txBox="1"/>
+          <p:nvPr/>
+        </p:nvSpPr>
+        <p:spPr>
+          <a:xfrm>
+            <a:off x="640080" y="868680"/>
+            <a:ext cx="10881360" cy="777240"/>
+          </a:xfrm>
+          <a:prstGeom prst="rect">
+            <a:avLst/>
+          </a:prstGeom>
+          <a:noFill/>
+        </p:spPr>
+        <p:txBody>
+          <a:bodyPr wrap="square" anchor="ctr">
+            <a:spAutoFit/>
+          </a:bodyPr>
+          <a:lstStyle/>
+          <a:p>
+            <a:pPr algn="l"/>
+            <a:r>
+              <a:rPr sz="3000" b="1">
+                <a:solidFill>
+                  <a:srgbClr val="141821"/>
+                </a:solidFill>
+                <a:latin typeface="Calibri"/>
+              </a:rPr>
+              <a:t>A modern stack, corrected for India economics.</a:t>
+            </a:r>
+          </a:p>
+        </p:txBody>
+      </p:sp>
+      <p:graphicFrame>
+        <p:nvGraphicFramePr>
+          <p:cNvPr id="4" name="Table 3"/>
+          <p:cNvGraphicFramePr>
+            <a:graphicFrameLocks noGrp="1"/>
+          </p:cNvGraphicFramePr>
+          <p:nvPr/>
+        </p:nvGraphicFramePr>
+        <p:xfrm>
+          <a:off x="640080" y="2103120"/>
+          <a:ext cx="10911840" cy="3800000"/>
+        </p:xfrm>
+        <a:graphic>
+          <a:graphicData uri="http://schemas.openxmlformats.org/drawingml/2006/table">
+            <a:tbl>
+              <a:tblPr firstRow="1" bandRow="1">
+                <a:tableStyleId>{5C22544A-7EE6-4342-B048-85BDC9FD1C3A}</a:tableStyleId>
+              </a:tblPr>
+              <a:tblGrid>
+                <a:gridCol w="2743680"/>
+                <a:gridCol w="3200000"/>
+                <a:gridCol w="4968160"/>
+              </a:tblGrid>
+              <a:tr h="345454">
+                <a:tc>
+                  <a:txBody>
+                    <a:bodyPr/>
+                    <a:lstStyle/>
+                    <a:p>
+                      <a:r>
+                        <a:rPr sz="1250" b="1">
+                          <a:solidFill>
+                            <a:srgbClr val="141821"/>
+                          </a:solidFill>
+                          <a:latin typeface="Calibri"/>
+                        </a:rPr>
+                        <a:t>Layer</a:t>
+                      </a:r>
+                    </a:p>
+                  </a:txBody>
+                  <a:tcPr>
+                    <a:solidFill>
+                      <a:srgbClr val="F2F7F5"/>
+                    </a:solidFill>
+                  </a:tcPr>
+                </a:tc>
+                <a:tc>
+                  <a:txBody>
+                    <a:bodyPr/>
+                    <a:lstStyle/>
+                    <a:p>
+                      <a:r>
+                        <a:rPr sz="1250" b="1">
+                          <a:solidFill>
+                            <a:srgbClr val="141821"/>
+                          </a:solidFill>
+                          <a:latin typeface="Calibri"/>
+                        </a:rPr>
+                        <a:t>Choice</a:t>
+                      </a:r>
+                    </a:p>
+                  </a:txBody>
+                  <a:tcPr>
+                    <a:solidFill>
+                      <a:srgbClr val="F2F7F5"/>
+                    </a:solidFill>
+                  </a:tcPr>
+                </a:tc>
+                <a:tc>
+                  <a:txBody>
+                    <a:bodyPr/>
+                    <a:lstStyle/>
+                    <a:p>
+                      <a:r>
+                        <a:rPr sz="1250" b="1">
+                          <a:solidFill>
+                            <a:srgbClr val="141821"/>
+                          </a:solidFill>
+                          <a:latin typeface="Calibri"/>
+                        </a:rPr>
+                        <a:t>Why it wins</a:t>
+                      </a:r>
+                    </a:p>
+                  </a:txBody>
+                  <a:tcPr>
+                    <a:solidFill>
+                      <a:srgbClr val="F2F7F5"/>
+                    </a:solidFill>
+                  </a:tcPr>
+                </a:tc>
+              </a:tr>
+              <a:tr h="345454">
+                <a:tc>
+                  <a:txBody>
+                    <a:bodyPr/>
+                    <a:lstStyle/>
+                    <a:p>
+                      <a:r>
+                        <a:rPr sz="1200" b="0">
+                          <a:solidFill>
+                            <a:srgbClr val="5A6270"/>
+                          </a:solidFill>
+                          <a:latin typeface="Calibri"/>
+                        </a:rPr>
+                        <a:t>Frontend</a:t>
+                      </a:r>
+                    </a:p>
+                  </a:txBody>
+                  <a:tcPr>
+                    <a:solidFill>
+                      <a:srgbClr val="FFFFFF"/>
+                    </a:solidFill>
+                  </a:tcPr>
+                </a:tc>
+                <a:tc>
+                  <a:txBody>
+                    <a:bodyPr/>
+                    <a:lstStyle/>
+                    <a:p>
+                      <a:r>
+                        <a:rPr sz="1200" b="0">
+                          <a:solidFill>
+                            <a:srgbClr val="5A6270"/>
+                          </a:solidFill>
+                          <a:latin typeface="Calibri"/>
+                        </a:rPr>
+                        <a:t>Next.js (React)</a:t>
+                      </a:r>
+                    </a:p>
+                  </a:txBody>
+                  <a:tcPr>
+                    <a:solidFill>
+                      <a:srgbClr val="FFFFFF"/>
+                    </a:solidFill>
+                  </a:tcPr>
+                </a:tc>
+                <a:tc>
+                  <a:txBody>
+                    <a:bodyPr/>
+                    <a:lstStyle/>
+                    <a:p>
+                      <a:r>
+                        <a:rPr sz="1200" b="0">
+                          <a:solidFill>
+                            <a:srgbClr val="5A6270"/>
+                          </a:solidFill>
+                          <a:latin typeface="Calibri"/>
+                        </a:rPr>
+                        <a:t>SEO locality pages = free Google traffic</a:t>
+                      </a:r>
+                    </a:p>
+                  </a:txBody>
+                  <a:tcPr>
+                    <a:solidFill>
+                      <a:srgbClr val="FFFFFF"/>
+                    </a:solidFill>
+                  </a:tcPr>
+                </a:tc>
+              </a:tr>
+              <a:tr h="345454">
+                <a:tc>
+                  <a:txBody>
+                    <a:bodyPr/>
+                    <a:lstStyle/>
+                    <a:p>
+                      <a:r>
+                        <a:rPr sz="1200" b="0">
+                          <a:solidFill>
+                            <a:srgbClr val="5A6270"/>
+                          </a:solidFill>
+                          <a:latin typeface="Calibri"/>
+                        </a:rPr>
+                        <a:t>Backend</a:t>
+                      </a:r>
+                    </a:p>
+                  </a:txBody>
+                  <a:tcPr>
+                    <a:solidFill>
+                      <a:srgbClr val="F2F7F5"/>
+                    </a:solidFill>
+                  </a:tcPr>
+                </a:tc>
+                <a:tc>
+                  <a:txBody>
+                    <a:bodyPr/>
+                    <a:lstStyle/>
+                    <a:p>
+                      <a:r>
+                        <a:rPr sz="1200" b="0">
+                          <a:solidFill>
+                            <a:srgbClr val="5A6270"/>
+                          </a:solidFill>
+                          <a:latin typeface="Calibri"/>
+                        </a:rPr>
+                        <a:t>Node.js + TypeScript</a:t>
+                      </a:r>
+                    </a:p>
+                  </a:txBody>
+                  <a:tcPr>
+                    <a:solidFill>
+                      <a:srgbClr val="F2F7F5"/>
+                    </a:solidFill>
+                  </a:tcPr>
+                </a:tc>
+                <a:tc>
+                  <a:txBody>
+                    <a:bodyPr/>
+                    <a:lstStyle/>
+                    <a:p>
+                      <a:r>
+                        <a:rPr sz="1200" b="0">
+                          <a:solidFill>
+                            <a:srgbClr val="5A6270"/>
+                          </a:solidFill>
+                          <a:latin typeface="Calibri"/>
+                        </a:rPr>
+                        <a:t>One language, small team moves fast</a:t>
+                      </a:r>
+                    </a:p>
+                  </a:txBody>
+                  <a:tcPr>
+                    <a:solidFill>
+                      <a:srgbClr val="F2F7F5"/>
+                    </a:solidFill>
+                  </a:tcPr>
+                </a:tc>
+              </a:tr>
+              <a:tr h="345454">
+                <a:tc>
+                  <a:txBody>
+                    <a:bodyPr/>
+                    <a:lstStyle/>
+                    <a:p>
+                      <a:r>
+                        <a:rPr sz="1200" b="0">
+                          <a:solidFill>
+                            <a:srgbClr val="5A6270"/>
+                          </a:solidFill>
+                          <a:latin typeface="Calibri"/>
+                        </a:rPr>
+                        <a:t>Database</a:t>
+                      </a:r>
+                    </a:p>
+                  </a:txBody>
+                  <a:tcPr>
+                    <a:solidFill>
+                      <a:srgbClr val="FFFFFF"/>
+                    </a:solidFill>
+                  </a:tcPr>
+                </a:tc>
+                <a:tc>
+                  <a:txBody>
+                    <a:bodyPr/>
+                    <a:lstStyle/>
+                    <a:p>
+                      <a:r>
+                        <a:rPr sz="1200" b="0">
+                          <a:solidFill>
+                            <a:srgbClr val="5A6270"/>
+                          </a:solidFill>
+                          <a:latin typeface="Calibri"/>
+                        </a:rPr>
+                        <a:t>PostgreSQL + PostGIS</a:t>
+                      </a:r>
+                    </a:p>
+                  </a:txBody>
+                  <a:tcPr>
+                    <a:solidFill>
+                      <a:srgbClr val="FFFFFF"/>
+                    </a:solidFill>
+                  </a:tcPr>
+                </a:tc>
+                <a:tc>
+                  <a:txBody>
+                    <a:bodyPr/>
+                    <a:lstStyle/>
+                    <a:p>
+                      <a:r>
+                        <a:rPr sz="1200" b="0">
+                          <a:solidFill>
+                            <a:srgbClr val="5A6270"/>
+                          </a:solidFill>
+                          <a:latin typeface="Calibri"/>
+                        </a:rPr>
+                        <a:t>'Flats within 3 km' queries, reliably</a:t>
+                      </a:r>
+                    </a:p>
+                  </a:txBody>
+                  <a:tcPr>
+                    <a:solidFill>
+                      <a:srgbClr val="FFFFFF"/>
+                    </a:solidFill>
+                  </a:tcPr>
+                </a:tc>
+              </a:tr>
+              <a:tr h="345454">
+                <a:tc>
+                  <a:txBody>
+                    <a:bodyPr/>
+                    <a:lstStyle/>
+                    <a:p>
+                      <a:r>
+                        <a:rPr sz="1200" b="0">
+                          <a:solidFill>
+                            <a:srgbClr val="5A6270"/>
+                          </a:solidFill>
+                          <a:latin typeface="Calibri"/>
+                        </a:rPr>
+                        <a:t>Search</a:t>
+                      </a:r>
+                    </a:p>
+                  </a:txBody>
+                  <a:tcPr>
+                    <a:solidFill>
+                      <a:srgbClr val="F2F7F5"/>
+                    </a:solidFill>
+                  </a:tcPr>
+                </a:tc>
+                <a:tc>
+                  <a:txBody>
+                    <a:bodyPr/>
+                    <a:lstStyle/>
+                    <a:p>
+                      <a:r>
+                        <a:rPr sz="1200" b="0">
+                          <a:solidFill>
+                            <a:srgbClr val="5A6270"/>
+                          </a:solidFill>
+                          <a:latin typeface="Calibri"/>
+                        </a:rPr>
+                        <a:t>Typesense (self-hosted)</a:t>
+                      </a:r>
+                    </a:p>
+                  </a:txBody>
+                  <a:tcPr>
+                    <a:solidFill>
+                      <a:srgbClr val="F2F7F5"/>
+                    </a:solidFill>
+                  </a:tcPr>
+                </a:tc>
+                <a:tc>
+                  <a:txBody>
+                    <a:bodyPr/>
+                    <a:lstStyle/>
+                    <a:p>
+                      <a:r>
+                        <a:rPr sz="1200" b="0">
+                          <a:solidFill>
+                            <a:srgbClr val="5A6270"/>
+                          </a:solidFill>
+                          <a:latin typeface="Calibri"/>
+                        </a:rPr>
+                        <a:t>~$69/mo vs Algolia ~$525/mo</a:t>
+                      </a:r>
+                    </a:p>
+                  </a:txBody>
+                  <a:tcPr>
+                    <a:solidFill>
+                      <a:srgbClr val="F2F7F5"/>
+                    </a:solidFill>
+                  </a:tcPr>
+                </a:tc>
+              </a:tr>
+              <a:tr h="345454">
+                <a:tc>
+                  <a:txBody>
+                    <a:bodyPr/>
+                    <a:lstStyle/>
+                    <a:p>
+                      <a:r>
+                        <a:rPr sz="1200" b="0">
+                          <a:solidFill>
+                            <a:srgbClr val="5A6270"/>
+                          </a:solidFill>
+                          <a:latin typeface="Calibri"/>
+                        </a:rPr>
+                        <a:t>Maps</a:t>
+                      </a:r>
+                    </a:p>
+                  </a:txBody>
+                  <a:tcPr>
+                    <a:solidFill>
+                      <a:srgbClr val="FFFFFF"/>
+                    </a:solidFill>
+                  </a:tcPr>
+                </a:tc>
+                <a:tc>
+                  <a:txBody>
+                    <a:bodyPr/>
+                    <a:lstStyle/>
+                    <a:p>
+                      <a:r>
+                        <a:rPr sz="1200" b="0">
+                          <a:solidFill>
+                            <a:srgbClr val="5A6270"/>
+                          </a:solidFill>
+                          <a:latin typeface="Calibri"/>
+                        </a:rPr>
+                        <a:t>Ola Maps / MapmyIndia</a:t>
+                      </a:r>
+                    </a:p>
+                  </a:txBody>
+                  <a:tcPr>
+                    <a:solidFill>
+                      <a:srgbClr val="FFFFFF"/>
+                    </a:solidFill>
+                  </a:tcPr>
+                </a:tc>
+                <a:tc>
+                  <a:txBody>
+                    <a:bodyPr/>
+                    <a:lstStyle/>
+                    <a:p>
+                      <a:r>
+                        <a:rPr sz="1200" b="0">
+                          <a:solidFill>
+                            <a:srgbClr val="5A6270"/>
+                          </a:solidFill>
+                          <a:latin typeface="Calibri"/>
+                        </a:rPr>
+                        <a:t>Free tier + best Indian locality data</a:t>
+                      </a:r>
+                    </a:p>
+                  </a:txBody>
+                  <a:tcPr>
+                    <a:solidFill>
+                      <a:srgbClr val="FFFFFF"/>
+                    </a:solidFill>
+                  </a:tcPr>
+                </a:tc>
+              </a:tr>
+              <a:tr h="345454">
+                <a:tc>
+                  <a:txBody>
+                    <a:bodyPr/>
+                    <a:lstStyle/>
+                    <a:p>
+                      <a:r>
+                        <a:rPr sz="1200" b="0">
+                          <a:solidFill>
+                            <a:srgbClr val="5A6270"/>
+                          </a:solidFill>
+                          <a:latin typeface="Calibri"/>
+                        </a:rPr>
+                        <a:t>Cloud</a:t>
+                      </a:r>
+                    </a:p>
+                  </a:txBody>
+                  <a:tcPr>
+                    <a:solidFill>
+                      <a:srgbClr val="F2F7F5"/>
+                    </a:solidFill>
+                  </a:tcPr>
+                </a:tc>
+                <a:tc>
+                  <a:txBody>
+                    <a:bodyPr/>
+                    <a:lstStyle/>
+                    <a:p>
+                      <a:r>
+                        <a:rPr sz="1200" b="0">
+                          <a:solidFill>
+                            <a:srgbClr val="5A6270"/>
+                          </a:solidFill>
+                          <a:latin typeface="Calibri"/>
+                        </a:rPr>
+                        <a:t>AWS Mumbai</a:t>
+                      </a:r>
+                    </a:p>
+                  </a:txBody>
+                  <a:tcPr>
+                    <a:solidFill>
+                      <a:srgbClr val="F2F7F5"/>
+                    </a:solidFill>
+                  </a:tcPr>
+                </a:tc>
+                <a:tc>
+                  <a:txBody>
+                    <a:bodyPr/>
+                    <a:lstStyle/>
+                    <a:p>
+                      <a:r>
+                        <a:rPr sz="1200" b="0">
+                          <a:solidFill>
+                            <a:srgbClr val="5A6270"/>
+                          </a:solidFill>
+                          <a:latin typeface="Calibri"/>
+                        </a:rPr>
+                        <a:t>KYC data stays in India (DPDP compliance)</a:t>
+                      </a:r>
+                    </a:p>
+                  </a:txBody>
+                  <a:tcPr>
+                    <a:solidFill>
+                      <a:srgbClr val="F2F7F5"/>
+                    </a:solidFill>
+                  </a:tcPr>
+                </a:tc>
+              </a:tr>
+              <a:tr h="345454">
+                <a:tc>
+                  <a:txBody>
+                    <a:bodyPr/>
+                    <a:lstStyle/>
+                    <a:p>
+                      <a:r>
+                        <a:rPr sz="1200" b="0">
+                          <a:solidFill>
+                            <a:srgbClr val="5A6270"/>
+                          </a:solidFill>
+                          <a:latin typeface="Calibri"/>
+                        </a:rPr>
+                        <a:t>Payments</a:t>
+                      </a:r>
+                    </a:p>
+                  </a:txBody>
+                  <a:tcPr>
+                    <a:solidFill>
+                      <a:srgbClr val="FFFFFF"/>
+                    </a:solidFill>
+                  </a:tcPr>
+                </a:tc>
+                <a:tc>
+                  <a:txBody>
+                    <a:bodyPr/>
+                    <a:lstStyle/>
+                    <a:p>
+                      <a:r>
+                        <a:rPr sz="1200" b="0">
+                          <a:solidFill>
+                            <a:srgbClr val="5A6270"/>
+                          </a:solidFill>
+                          <a:latin typeface="Calibri"/>
+                        </a:rPr>
+                        <a:t>Razorpay (UPI-first)</a:t>
+                      </a:r>
+                    </a:p>
+                  </a:txBody>
+                  <a:tcPr>
+                    <a:solidFill>
+                      <a:srgbClr val="FFFFFF"/>
+                    </a:solidFill>
+                  </a:tcPr>
+                </a:tc>
+                <a:tc>
+                  <a:txBody>
+                    <a:bodyPr/>
+                    <a:lstStyle/>
+                    <a:p>
+                      <a:r>
+                        <a:rPr sz="1200" b="0">
+                          <a:solidFill>
+                            <a:srgbClr val="5A6270"/>
+                          </a:solidFill>
+                          <a:latin typeface="Calibri"/>
+                        </a:rPr>
+                        <a:t>UPI at 0% MDR by RBI mandate</a:t>
+                      </a:r>
+                    </a:p>
+                  </a:txBody>
+                  <a:tcPr>
+                    <a:solidFill>
+                      <a:srgbClr val="FFFFFF"/>
+                    </a:solidFill>
+                  </a:tcPr>
+                </a:tc>
+              </a:tr>
+              <a:tr h="345454">
+                <a:tc>
+                  <a:txBody>
+                    <a:bodyPr/>
+                    <a:lstStyle/>
+                    <a:p>
+                      <a:r>
+                        <a:rPr sz="1200" b="0">
+                          <a:solidFill>
+                            <a:srgbClr val="5A6270"/>
+                          </a:solidFill>
+                          <a:latin typeface="Calibri"/>
+                        </a:rPr>
+                        <a:t>Call masking</a:t>
+                      </a:r>
+                    </a:p>
+                  </a:txBody>
+                  <a:tcPr>
+                    <a:solidFill>
+                      <a:srgbClr val="F2F7F5"/>
+                    </a:solidFill>
+                  </a:tcPr>
+                </a:tc>
+                <a:tc>
+                  <a:txBody>
+                    <a:bodyPr/>
+                    <a:lstStyle/>
+                    <a:p>
+                      <a:r>
+                        <a:rPr sz="1200" b="0">
+                          <a:solidFill>
+                            <a:srgbClr val="5A6270"/>
+                          </a:solidFill>
+                          <a:latin typeface="Calibri"/>
+                        </a:rPr>
+                        <a:t>Exotel</a:t>
+                      </a:r>
+                    </a:p>
+                  </a:txBody>
+                  <a:tcPr>
+                    <a:solidFill>
+                      <a:srgbClr val="F2F7F5"/>
+                    </a:solidFill>
+                  </a:tcPr>
+                </a:tc>
+                <a:tc>
+                  <a:txBody>
+                    <a:bodyPr/>
+                    <a:lstStyle/>
+                    <a:p>
+                      <a:r>
+                        <a:rPr sz="1200" b="0">
+                          <a:solidFill>
+                            <a:srgbClr val="5A6270"/>
+                          </a:solidFill>
+                          <a:latin typeface="Calibri"/>
+                        </a:rPr>
+                        <a:t>Virtual numbers keep owner phones private</a:t>
+                      </a:r>
+                    </a:p>
+                  </a:txBody>
+                  <a:tcPr>
+                    <a:solidFill>
+                      <a:srgbClr val="F2F7F5"/>
+                    </a:solidFill>
+                  </a:tcPr>
+                </a:tc>
+              </a:tr>
+              <a:tr h="345454">
+                <a:tc>
+                  <a:txBody>
+                    <a:bodyPr/>
+                    <a:lstStyle/>
+                    <a:p>
+                      <a:r>
+                        <a:rPr sz="1200" b="0">
+                          <a:solidFill>
+                            <a:srgbClr val="5A6270"/>
+                          </a:solidFill>
+                          <a:latin typeface="Calibri"/>
+                        </a:rPr>
+                        <a:t>KYC APIs</a:t>
+                      </a:r>
+                    </a:p>
+                  </a:txBody>
+                  <a:tcPr>
+                    <a:solidFill>
+                      <a:srgbClr val="FFFFFF"/>
+                    </a:solidFill>
+                  </a:tcPr>
+                </a:tc>
+                <a:tc>
+                  <a:txBody>
+                    <a:bodyPr/>
+                    <a:lstStyle/>
+                    <a:p>
+                      <a:r>
+                        <a:rPr sz="1200" b="0">
+                          <a:solidFill>
+                            <a:srgbClr val="5A6270"/>
+                          </a:solidFill>
+                          <a:latin typeface="Calibri"/>
+                        </a:rPr>
+                        <a:t>Surepass/IDfy class vendors</a:t>
+                      </a:r>
+                    </a:p>
+                  </a:txBody>
+                  <a:tcPr>
+                    <a:solidFill>
+                      <a:srgbClr val="FFFFFF"/>
+                    </a:solidFill>
+                  </a:tcPr>
+                </a:tc>
+                <a:tc>
+                  <a:txBody>
+                    <a:bodyPr/>
+                    <a:lstStyle/>
+                    <a:p>
+                      <a:r>
+                        <a:rPr sz="1200" b="0">
+                          <a:solidFill>
+                            <a:srgbClr val="5A6270"/>
+                          </a:solidFill>
+                          <a:latin typeface="Calibri"/>
+                        </a:rPr>
+                        <a:t>PAN ≈₹1–3/check; Aadhaar via offline XML/DigiLocker</a:t>
+                      </a:r>
+                    </a:p>
+                  </a:txBody>
+                  <a:tcPr>
+                    <a:solidFill>
+                      <a:srgbClr val="FFFFFF"/>
+                    </a:solidFill>
+                  </a:tcPr>
+                </a:tc>
+              </a:tr>
+              <a:tr h="345460">
+                <a:tc>
+                  <a:txBody>
+                    <a:bodyPr/>
+                    <a:lstStyle/>
+                    <a:p>
+                      <a:r>
+                        <a:rPr sz="1200" b="0">
+                          <a:solidFill>
+                            <a:srgbClr val="5A6270"/>
+                          </a:solidFill>
+                          <a:latin typeface="Calibri"/>
+                        </a:rPr>
+                        <a:t>Agreements</a:t>
+                      </a:r>
+                    </a:p>
+                  </a:txBody>
+                  <a:tcPr>
+                    <a:solidFill>
+                      <a:srgbClr val="F2F7F5"/>
+                    </a:solidFill>
+                  </a:tcPr>
+                </a:tc>
+                <a:tc>
+                  <a:txBody>
+                    <a:bodyPr/>
+                    <a:lstStyle/>
+                    <a:p>
+                      <a:r>
+                        <a:rPr sz="1200" b="0">
+                          <a:solidFill>
+                            <a:srgbClr val="5A6270"/>
+                          </a:solidFill>
+                          <a:latin typeface="Calibri"/>
+                        </a:rPr>
+                        <a:t>Leegality/Digio</a:t>
+                      </a:r>
+                    </a:p>
+                  </a:txBody>
+                  <a:tcPr>
+                    <a:solidFill>
+                      <a:srgbClr val="F2F7F5"/>
+                    </a:solidFill>
+                  </a:tcPr>
+                </a:tc>
+                <a:tc>
+                  <a:txBody>
+                    <a:bodyPr/>
+                    <a:lstStyle/>
+                    <a:p>
+                      <a:r>
+                        <a:rPr sz="1200" b="0">
+                          <a:solidFill>
+                            <a:srgbClr val="5A6270"/>
+                          </a:solidFill>
+                          <a:latin typeface="Calibri"/>
+                        </a:rPr>
+                        <a:t>Aadhaar eSign ₹10–40/signature + state-wise e-stamping</a:t>
+                      </a:r>
+                    </a:p>
+                  </a:txBody>
+                  <a:tcPr>
+                    <a:solidFill>
+                      <a:srgbClr val="F2F7F5"/>
+                    </a:solidFill>
+                  </a:tcPr>
+                </a:tc>
+              </a:tr>
+            </a:tbl>
+          </a:graphicData>
+        </a:graphic>
+      </p:graphicFrame>
+      <p:sp>
+        <p:nvSpPr>
+          <p:cNvPr id="5" name="TextBox 4"/>
+          <p:cNvSpPr txBox="1"/>
+          <p:nvPr/>
+        </p:nvSpPr>
+        <p:spPr>
+          <a:xfrm>
+            <a:off x="640080" y="6100000"/>
+            <a:ext cx="10911840" cy="600000"/>
+          </a:xfrm>
+          <a:prstGeom prst="rect">
+            <a:avLst/>
+          </a:prstGeom>
+          <a:noFill/>
+        </p:spPr>
+        <p:txBody>
+          <a:bodyPr wrap="square" anchor="t">
+            <a:spAutoFit/>
+          </a:bodyPr>
+          <a:lstStyle/>
+          <a:p>
+            <a:pPr algn="l"/>
+            <a:r>
+              <a:rPr sz="1200" b="0">
+                <a:solidFill>
+                  <a:srgbClr val="5A6270"/>
+                </a:solidFill>
+                <a:latin typeface="Calibri"/>
+              </a:rPr>
+              <a:t>Cost traps avoided: Typesense keeps ~80% of Algolia's power at ~20% of the cost; Google Maps stays a free-tier fallback, not the primary, ahead of its post-2027 pricing changes.</a:t>
+            </a:r>
+          </a:p>
+        </p:txBody>
+      </p:sp>
+    </p:spTree>
+  </p:cSld>
+  <p:clrMapOvr>
+    <a:masterClrMapping/>
+  </p:clrMapOvr>
+</p:sld>
+</file>
+
 <file path=ppt/slides/slide2.xml><?xml version="1.0" encoding="utf-8"?>
 <p:sld xmlns:a="http://schemas.openxmlformats.org/drawingml/2006/main" xmlns:r="http://schemas.openxmlformats.org/officeDocument/2006/relationships" xmlns:p="http://schemas.openxmlformats.org/presentationml/2006/main">
   <p:cSld name="Slide 2">
@@ -7133,2040 +8021,6 @@
               <a:t>We earn when a genuine connection happens — not by reselling the same lead</a:t>
             </a:r>
             <a:endParaRPr lang="en-US" sz="1250" dirty="0"/>
-          </a:p>
-        </p:txBody>
-      </p:sp>
-    </p:spTree>
-  </p:cSld>
-  <p:clrMapOvr>
-    <a:masterClrMapping/>
-  </p:clrMapOvr>
-</p:sld>
-</file>
-
-<file path=ppt/slides/slide8.xml><?xml version="1.0" encoding="utf-8"?>
-<p:sld xmlns:a="http://schemas.openxmlformats.org/drawingml/2006/main" xmlns:r="http://schemas.openxmlformats.org/officeDocument/2006/relationships" xmlns:p="http://schemas.openxmlformats.org/presentationml/2006/main">
-  <p:cSld name="Slide 8">
-    <p:bg>
-      <p:bgPr>
-        <a:solidFill>
-          <a:srgbClr val="FFFFFF"/>
-        </a:solidFill>
-      </p:bgPr>
-    </p:bg>
-    <p:spTree>
-      <p:nvGrpSpPr>
-        <p:cNvPr id="1" name=""/>
-        <p:cNvGrpSpPr/>
-        <p:nvPr/>
-      </p:nvGrpSpPr>
-      <p:grpSpPr>
-        <a:xfrm>
-          <a:off x="0" y="0"/>
-          <a:ext cx="0" cy="0"/>
-          <a:chOff x="0" y="0"/>
-          <a:chExt cx="0" cy="0"/>
-        </a:xfrm>
-      </p:grpSpPr>
-      <p:sp>
-        <p:nvSpPr>
-          <p:cNvPr id="2" name="Text 0"/>
-          <p:cNvSpPr/>
-          <p:nvPr/>
-        </p:nvSpPr>
-        <p:spPr>
-          <a:xfrm>
-            <a:off x="640080" y="502920"/>
-            <a:ext cx="7315200" cy="320040"/>
-          </a:xfrm>
-          <a:prstGeom prst="rect">
-            <a:avLst/>
-          </a:prstGeom>
-          <a:noFill/>
-          <a:ln/>
-        </p:spPr>
-        <p:txBody>
-          <a:bodyPr wrap="square" rtlCol="0" anchor="ctr"/>
-          <a:lstStyle/>
-          <a:p>
-            <a:pPr indent="0" marL="0">
-              <a:buNone/>
-            </a:pPr>
-            <a:r>
-              <a:rPr lang="en-US" sz="1200" b="1" spc="300" kern="0" dirty="0">
-                <a:solidFill>
-                  <a:srgbClr val="0E6E5C"/>
-                </a:solidFill>
-                <a:latin typeface="Calibri" pitchFamily="34" charset="0"/>
-                <a:ea typeface="Calibri" pitchFamily="34" charset="-122"/>
-                <a:cs typeface="Calibri" pitchFamily="34" charset="-120"/>
-              </a:rPr>
-              <a:t>BUILT TO SCALE — COST-SAFE BY DESIGN</a:t>
-            </a:r>
-            <a:endParaRPr lang="en-US" sz="1200" dirty="0"/>
-          </a:p>
-        </p:txBody>
-      </p:sp>
-      <p:sp>
-        <p:nvSpPr>
-          <p:cNvPr id="3" name="Text 1"/>
-          <p:cNvSpPr/>
-          <p:nvPr/>
-        </p:nvSpPr>
-        <p:spPr>
-          <a:xfrm>
-            <a:off x="640080" y="868680"/>
-            <a:ext cx="10881360" cy="777240"/>
-          </a:xfrm>
-          <a:prstGeom prst="rect">
-            <a:avLst/>
-          </a:prstGeom>
-          <a:noFill/>
-          <a:ln/>
-        </p:spPr>
-        <p:txBody>
-          <a:bodyPr wrap="square" rtlCol="0" anchor="ctr"/>
-          <a:lstStyle/>
-          <a:p>
-            <a:pPr indent="0" marL="0">
-              <a:buNone/>
-            </a:pPr>
-            <a:r>
-              <a:rPr lang="en-US" sz="2800" b="1" dirty="0">
-                <a:solidFill>
-                  <a:srgbClr val="141821"/>
-                </a:solidFill>
-                <a:latin typeface="Calibri" pitchFamily="34" charset="0"/>
-                <a:ea typeface="Calibri" pitchFamily="34" charset="-122"/>
-                <a:cs typeface="Calibri" pitchFamily="34" charset="-120"/>
-              </a:rPr>
-              <a:t>A modern stack, corrected for India economics</a:t>
-            </a:r>
-            <a:endParaRPr lang="en-US" sz="2800" dirty="0"/>
-          </a:p>
-        </p:txBody>
-      </p:sp>
-      <p:graphicFrame>
-        <p:nvGraphicFramePr>
-          <p:cNvPr id="9" name="Table 0"/>
-          <p:cNvGraphicFramePr>
-            <a:graphicFrameLocks noGrp="1"/>
-          </p:cNvGraphicFramePr>
-          <p:nvPr>
-            <p:extLst>
-              <p:ext uri="{D42A27DB-BD31-4B8C-83A1-F6EECF244321}">
-                <p14:modId xmlns:p14="http://schemas.microsoft.com/office/powerpoint/2010/main" val="1579011935"/>
-              </p:ext>
-            </p:extLst>
-          </p:nvPr>
-        </p:nvGraphicFramePr>
-        <p:xfrm>
-          <a:off x="640080" y="1874520"/>
-          <a:ext cx="10972800" cy="914400"/>
-        </p:xfrm>
-        <a:graphic>
-          <a:graphicData uri="http://schemas.openxmlformats.org/drawingml/2006/table">
-            <a:tbl>
-              <a:tblPr/>
-              <a:tblGrid>
-                <a:gridCol w="1737360"/>
-                <a:gridCol w="4206240"/>
-                <a:gridCol w="5029200"/>
-              </a:tblGrid>
-              <a:tr h="384048">
-                <a:tc>
-                  <a:txBody>
-                    <a:bodyPr/>
-                    <a:lstStyle/>
-                    <a:p>
-                      <a:pPr indent="0" marL="0">
-                        <a:buNone/>
-                      </a:pPr>
-                      <a:r>
-                        <a:rPr lang="en-US" sz="1200" b="1" dirty="0">
-                          <a:solidFill>
-                            <a:srgbClr val="FFFFFF"/>
-                          </a:solidFill>
-                          <a:latin typeface="Calibri" pitchFamily="34" charset="0"/>
-                          <a:ea typeface="Calibri" pitchFamily="34" charset="-122"/>
-                          <a:cs typeface="Calibri" pitchFamily="34" charset="-120"/>
-                        </a:rPr>
-                        <a:t>Layer</a:t>
-                      </a:r>
-                      <a:endParaRPr lang="en-US" sz="1200" dirty="0">
-                        <a:latin typeface="Calibri" charset="0"/>
-                        <a:ea typeface="Calibri" charset="0"/>
-                        <a:cs typeface="Calibri" charset="0"/>
-                      </a:endParaRPr>
-                    </a:p>
-                  </a:txBody>
-                  <a:tcPr marL="91440" marR="91440" marT="45720" marB="45720" anchor="ctr">
-                    <a:lnL w="6350" cap="flat" cmpd="sng" algn="ctr">
-                      <a:solidFill>
-                        <a:srgbClr val="D8DEE4"/>
-                      </a:solidFill>
-                      <a:prstDash val="solid"/>
-                      <a:round/>
-                      <a:headEnd type="none" w="med" len="med"/>
-                      <a:tailEnd type="none" w="med" len="med"/>
-                    </a:lnL>
-                    <a:lnR w="6350" cap="flat" cmpd="sng" algn="ctr">
-                      <a:solidFill>
-                        <a:srgbClr val="D8DEE4"/>
-                      </a:solidFill>
-                      <a:prstDash val="solid"/>
-                      <a:round/>
-                      <a:headEnd type="none" w="med" len="med"/>
-                      <a:tailEnd type="none" w="med" len="med"/>
-                    </a:lnR>
-                    <a:lnT w="6350" cap="flat" cmpd="sng" algn="ctr">
-                      <a:solidFill>
-                        <a:srgbClr val="D8DEE4"/>
-                      </a:solidFill>
-                      <a:prstDash val="solid"/>
-                      <a:round/>
-                      <a:headEnd type="none" w="med" len="med"/>
-                      <a:tailEnd type="none" w="med" len="med"/>
-                    </a:lnT>
-                    <a:lnB w="6350" cap="flat" cmpd="sng" algn="ctr">
-                      <a:solidFill>
-                        <a:srgbClr val="D8DEE4"/>
-                      </a:solidFill>
-                      <a:prstDash val="solid"/>
-                      <a:round/>
-                      <a:headEnd type="none" w="med" len="med"/>
-                      <a:tailEnd type="none" w="med" len="med"/>
-                    </a:lnB>
-                    <a:solidFill>
-                      <a:srgbClr val="0E6E5C"/>
-                    </a:solidFill>
-                  </a:tcPr>
-                </a:tc>
-                <a:tc>
-                  <a:txBody>
-                    <a:bodyPr/>
-                    <a:lstStyle/>
-                    <a:p>
-                      <a:pPr indent="0" marL="0">
-                        <a:buNone/>
-                      </a:pPr>
-                      <a:r>
-                        <a:rPr lang="en-US" sz="1200" b="1" dirty="0">
-                          <a:solidFill>
-                            <a:srgbClr val="FFFFFF"/>
-                          </a:solidFill>
-                          <a:latin typeface="Calibri" pitchFamily="34" charset="0"/>
-                          <a:ea typeface="Calibri" pitchFamily="34" charset="-122"/>
-                          <a:cs typeface="Calibri" pitchFamily="34" charset="-120"/>
-                        </a:rPr>
-                        <a:t>Choice</a:t>
-                      </a:r>
-                      <a:endParaRPr lang="en-US" sz="1200" dirty="0">
-                        <a:latin typeface="Calibri" charset="0"/>
-                        <a:ea typeface="Calibri" charset="0"/>
-                        <a:cs typeface="Calibri" charset="0"/>
-                      </a:endParaRPr>
-                    </a:p>
-                  </a:txBody>
-                  <a:tcPr marL="91440" marR="91440" marT="45720" marB="45720" anchor="ctr">
-                    <a:lnL w="6350" cap="flat" cmpd="sng" algn="ctr">
-                      <a:solidFill>
-                        <a:srgbClr val="D8DEE4"/>
-                      </a:solidFill>
-                      <a:prstDash val="solid"/>
-                      <a:round/>
-                      <a:headEnd type="none" w="med" len="med"/>
-                      <a:tailEnd type="none" w="med" len="med"/>
-                    </a:lnL>
-                    <a:lnR w="6350" cap="flat" cmpd="sng" algn="ctr">
-                      <a:solidFill>
-                        <a:srgbClr val="D8DEE4"/>
-                      </a:solidFill>
-                      <a:prstDash val="solid"/>
-                      <a:round/>
-                      <a:headEnd type="none" w="med" len="med"/>
-                      <a:tailEnd type="none" w="med" len="med"/>
-                    </a:lnR>
-                    <a:lnT w="6350" cap="flat" cmpd="sng" algn="ctr">
-                      <a:solidFill>
-                        <a:srgbClr val="D8DEE4"/>
-                      </a:solidFill>
-                      <a:prstDash val="solid"/>
-                      <a:round/>
-                      <a:headEnd type="none" w="med" len="med"/>
-                      <a:tailEnd type="none" w="med" len="med"/>
-                    </a:lnT>
-                    <a:lnB w="6350" cap="flat" cmpd="sng" algn="ctr">
-                      <a:solidFill>
-                        <a:srgbClr val="D8DEE4"/>
-                      </a:solidFill>
-                      <a:prstDash val="solid"/>
-                      <a:round/>
-                      <a:headEnd type="none" w="med" len="med"/>
-                      <a:tailEnd type="none" w="med" len="med"/>
-                    </a:lnB>
-                    <a:solidFill>
-                      <a:srgbClr val="0E6E5C"/>
-                    </a:solidFill>
-                  </a:tcPr>
-                </a:tc>
-                <a:tc>
-                  <a:txBody>
-                    <a:bodyPr/>
-                    <a:lstStyle/>
-                    <a:p>
-                      <a:pPr indent="0" marL="0">
-                        <a:buNone/>
-                      </a:pPr>
-                      <a:r>
-                        <a:rPr lang="en-US" sz="1200" b="1" dirty="0">
-                          <a:solidFill>
-                            <a:srgbClr val="FFFFFF"/>
-                          </a:solidFill>
-                          <a:latin typeface="Calibri" pitchFamily="34" charset="0"/>
-                          <a:ea typeface="Calibri" pitchFamily="34" charset="-122"/>
-                          <a:cs typeface="Calibri" pitchFamily="34" charset="-120"/>
-                        </a:rPr>
-                        <a:t>Why it wins</a:t>
-                      </a:r>
-                      <a:endParaRPr lang="en-US" sz="1200" dirty="0">
-                        <a:latin typeface="Calibri" charset="0"/>
-                        <a:ea typeface="Calibri" charset="0"/>
-                        <a:cs typeface="Calibri" charset="0"/>
-                      </a:endParaRPr>
-                    </a:p>
-                  </a:txBody>
-                  <a:tcPr marL="91440" marR="91440" marT="45720" marB="45720" anchor="ctr">
-                    <a:lnL w="6350" cap="flat" cmpd="sng" algn="ctr">
-                      <a:solidFill>
-                        <a:srgbClr val="D8DEE4"/>
-                      </a:solidFill>
-                      <a:prstDash val="solid"/>
-                      <a:round/>
-                      <a:headEnd type="none" w="med" len="med"/>
-                      <a:tailEnd type="none" w="med" len="med"/>
-                    </a:lnL>
-                    <a:lnR w="6350" cap="flat" cmpd="sng" algn="ctr">
-                      <a:solidFill>
-                        <a:srgbClr val="D8DEE4"/>
-                      </a:solidFill>
-                      <a:prstDash val="solid"/>
-                      <a:round/>
-                      <a:headEnd type="none" w="med" len="med"/>
-                      <a:tailEnd type="none" w="med" len="med"/>
-                    </a:lnR>
-                    <a:lnT w="6350" cap="flat" cmpd="sng" algn="ctr">
-                      <a:solidFill>
-                        <a:srgbClr val="D8DEE4"/>
-                      </a:solidFill>
-                      <a:prstDash val="solid"/>
-                      <a:round/>
-                      <a:headEnd type="none" w="med" len="med"/>
-                      <a:tailEnd type="none" w="med" len="med"/>
-                    </a:lnT>
-                    <a:lnB w="6350" cap="flat" cmpd="sng" algn="ctr">
-                      <a:solidFill>
-                        <a:srgbClr val="D8DEE4"/>
-                      </a:solidFill>
-                      <a:prstDash val="solid"/>
-                      <a:round/>
-                      <a:headEnd type="none" w="med" len="med"/>
-                      <a:tailEnd type="none" w="med" len="med"/>
-                    </a:lnB>
-                    <a:solidFill>
-                      <a:srgbClr val="0E6E5C"/>
-                    </a:solidFill>
-                  </a:tcPr>
-                </a:tc>
-              </a:tr>
-              <a:tr h="384048">
-                <a:tc>
-                  <a:txBody>
-                    <a:bodyPr/>
-                    <a:lstStyle/>
-                    <a:p>
-                      <a:pPr indent="0" marL="0">
-                        <a:buNone/>
-                      </a:pPr>
-                      <a:r>
-                        <a:rPr lang="en-US" sz="1150" dirty="0">
-                          <a:solidFill>
-                            <a:srgbClr val="141821"/>
-                          </a:solidFill>
-                          <a:latin typeface="Calibri" pitchFamily="34" charset="0"/>
-                          <a:ea typeface="Calibri" pitchFamily="34" charset="-122"/>
-                          <a:cs typeface="Calibri" pitchFamily="34" charset="-120"/>
-                        </a:rPr>
-                        <a:t>Frontend</a:t>
-                      </a:r>
-                      <a:endParaRPr lang="en-US" sz="1150" dirty="0">
-                        <a:latin typeface="Calibri" charset="0"/>
-                        <a:ea typeface="Calibri" charset="0"/>
-                        <a:cs typeface="Calibri" charset="0"/>
-                      </a:endParaRPr>
-                    </a:p>
-                  </a:txBody>
-                  <a:tcPr marL="91440" marR="91440" marT="45720" marB="45720" anchor="ctr">
-                    <a:lnL w="6350" cap="flat" cmpd="sng" algn="ctr">
-                      <a:solidFill>
-                        <a:srgbClr val="D8DEE4"/>
-                      </a:solidFill>
-                      <a:prstDash val="solid"/>
-                      <a:round/>
-                      <a:headEnd type="none" w="med" len="med"/>
-                      <a:tailEnd type="none" w="med" len="med"/>
-                    </a:lnL>
-                    <a:lnR w="6350" cap="flat" cmpd="sng" algn="ctr">
-                      <a:solidFill>
-                        <a:srgbClr val="D8DEE4"/>
-                      </a:solidFill>
-                      <a:prstDash val="solid"/>
-                      <a:round/>
-                      <a:headEnd type="none" w="med" len="med"/>
-                      <a:tailEnd type="none" w="med" len="med"/>
-                    </a:lnR>
-                    <a:lnT w="6350" cap="flat" cmpd="sng" algn="ctr">
-                      <a:solidFill>
-                        <a:srgbClr val="D8DEE4"/>
-                      </a:solidFill>
-                      <a:prstDash val="solid"/>
-                      <a:round/>
-                      <a:headEnd type="none" w="med" len="med"/>
-                      <a:tailEnd type="none" w="med" len="med"/>
-                    </a:lnT>
-                    <a:lnB w="6350" cap="flat" cmpd="sng" algn="ctr">
-                      <a:solidFill>
-                        <a:srgbClr val="D8DEE4"/>
-                      </a:solidFill>
-                      <a:prstDash val="solid"/>
-                      <a:round/>
-                      <a:headEnd type="none" w="med" len="med"/>
-                      <a:tailEnd type="none" w="med" len="med"/>
-                    </a:lnB>
-                    <a:solidFill>
-                      <a:srgbClr val="FFFFFF"/>
-                    </a:solidFill>
-                  </a:tcPr>
-                </a:tc>
-                <a:tc>
-                  <a:txBody>
-                    <a:bodyPr/>
-                    <a:lstStyle/>
-                    <a:p>
-                      <a:pPr indent="0" marL="0">
-                        <a:buNone/>
-                      </a:pPr>
-                      <a:r>
-                        <a:rPr lang="en-US" sz="1150" dirty="0">
-                          <a:solidFill>
-                            <a:srgbClr val="141821"/>
-                          </a:solidFill>
-                          <a:latin typeface="Calibri" pitchFamily="34" charset="0"/>
-                          <a:ea typeface="Calibri" pitchFamily="34" charset="-122"/>
-                          <a:cs typeface="Calibri" pitchFamily="34" charset="-120"/>
-                        </a:rPr>
-                        <a:t>Next.js (React)</a:t>
-                      </a:r>
-                      <a:endParaRPr lang="en-US" sz="1150" dirty="0">
-                        <a:latin typeface="Calibri" charset="0"/>
-                        <a:ea typeface="Calibri" charset="0"/>
-                        <a:cs typeface="Calibri" charset="0"/>
-                      </a:endParaRPr>
-                    </a:p>
-                  </a:txBody>
-                  <a:tcPr marL="91440" marR="91440" marT="45720" marB="45720" anchor="ctr">
-                    <a:lnL w="6350" cap="flat" cmpd="sng" algn="ctr">
-                      <a:solidFill>
-                        <a:srgbClr val="D8DEE4"/>
-                      </a:solidFill>
-                      <a:prstDash val="solid"/>
-                      <a:round/>
-                      <a:headEnd type="none" w="med" len="med"/>
-                      <a:tailEnd type="none" w="med" len="med"/>
-                    </a:lnL>
-                    <a:lnR w="6350" cap="flat" cmpd="sng" algn="ctr">
-                      <a:solidFill>
-                        <a:srgbClr val="D8DEE4"/>
-                      </a:solidFill>
-                      <a:prstDash val="solid"/>
-                      <a:round/>
-                      <a:headEnd type="none" w="med" len="med"/>
-                      <a:tailEnd type="none" w="med" len="med"/>
-                    </a:lnR>
-                    <a:lnT w="6350" cap="flat" cmpd="sng" algn="ctr">
-                      <a:solidFill>
-                        <a:srgbClr val="D8DEE4"/>
-                      </a:solidFill>
-                      <a:prstDash val="solid"/>
-                      <a:round/>
-                      <a:headEnd type="none" w="med" len="med"/>
-                      <a:tailEnd type="none" w="med" len="med"/>
-                    </a:lnT>
-                    <a:lnB w="6350" cap="flat" cmpd="sng" algn="ctr">
-                      <a:solidFill>
-                        <a:srgbClr val="D8DEE4"/>
-                      </a:solidFill>
-                      <a:prstDash val="solid"/>
-                      <a:round/>
-                      <a:headEnd type="none" w="med" len="med"/>
-                      <a:tailEnd type="none" w="med" len="med"/>
-                    </a:lnB>
-                    <a:solidFill>
-                      <a:srgbClr val="FFFFFF"/>
-                    </a:solidFill>
-                  </a:tcPr>
-                </a:tc>
-                <a:tc>
-                  <a:txBody>
-                    <a:bodyPr/>
-                    <a:lstStyle/>
-                    <a:p>
-                      <a:pPr indent="0" marL="0">
-                        <a:buNone/>
-                      </a:pPr>
-                      <a:r>
-                        <a:rPr lang="en-US" sz="1150" dirty="0">
-                          <a:solidFill>
-                            <a:srgbClr val="141821"/>
-                          </a:solidFill>
-                          <a:latin typeface="Calibri" pitchFamily="34" charset="0"/>
-                          <a:ea typeface="Calibri" pitchFamily="34" charset="-122"/>
-                          <a:cs typeface="Calibri" pitchFamily="34" charset="-120"/>
-                        </a:rPr>
-                        <a:t>SEO locality pages = free Google traffic</a:t>
-                      </a:r>
-                      <a:endParaRPr lang="en-US" sz="1150" dirty="0">
-                        <a:latin typeface="Calibri" charset="0"/>
-                        <a:ea typeface="Calibri" charset="0"/>
-                        <a:cs typeface="Calibri" charset="0"/>
-                      </a:endParaRPr>
-                    </a:p>
-                  </a:txBody>
-                  <a:tcPr marL="91440" marR="91440" marT="45720" marB="45720" anchor="ctr">
-                    <a:lnL w="6350" cap="flat" cmpd="sng" algn="ctr">
-                      <a:solidFill>
-                        <a:srgbClr val="D8DEE4"/>
-                      </a:solidFill>
-                      <a:prstDash val="solid"/>
-                      <a:round/>
-                      <a:headEnd type="none" w="med" len="med"/>
-                      <a:tailEnd type="none" w="med" len="med"/>
-                    </a:lnL>
-                    <a:lnR w="6350" cap="flat" cmpd="sng" algn="ctr">
-                      <a:solidFill>
-                        <a:srgbClr val="D8DEE4"/>
-                      </a:solidFill>
-                      <a:prstDash val="solid"/>
-                      <a:round/>
-                      <a:headEnd type="none" w="med" len="med"/>
-                      <a:tailEnd type="none" w="med" len="med"/>
-                    </a:lnR>
-                    <a:lnT w="6350" cap="flat" cmpd="sng" algn="ctr">
-                      <a:solidFill>
-                        <a:srgbClr val="D8DEE4"/>
-                      </a:solidFill>
-                      <a:prstDash val="solid"/>
-                      <a:round/>
-                      <a:headEnd type="none" w="med" len="med"/>
-                      <a:tailEnd type="none" w="med" len="med"/>
-                    </a:lnT>
-                    <a:lnB w="6350" cap="flat" cmpd="sng" algn="ctr">
-                      <a:solidFill>
-                        <a:srgbClr val="D8DEE4"/>
-                      </a:solidFill>
-                      <a:prstDash val="solid"/>
-                      <a:round/>
-                      <a:headEnd type="none" w="med" len="med"/>
-                      <a:tailEnd type="none" w="med" len="med"/>
-                    </a:lnB>
-                    <a:solidFill>
-                      <a:srgbClr val="FFFFFF"/>
-                    </a:solidFill>
-                  </a:tcPr>
-                </a:tc>
-              </a:tr>
-              <a:tr h="384048">
-                <a:tc>
-                  <a:txBody>
-                    <a:bodyPr/>
-                    <a:lstStyle/>
-                    <a:p>
-                      <a:pPr indent="0" marL="0">
-                        <a:buNone/>
-                      </a:pPr>
-                      <a:r>
-                        <a:rPr lang="en-US" sz="1150" dirty="0">
-                          <a:solidFill>
-                            <a:srgbClr val="141821"/>
-                          </a:solidFill>
-                          <a:latin typeface="Calibri" pitchFamily="34" charset="0"/>
-                          <a:ea typeface="Calibri" pitchFamily="34" charset="-122"/>
-                          <a:cs typeface="Calibri" pitchFamily="34" charset="-120"/>
-                        </a:rPr>
-                        <a:t>Backend</a:t>
-                      </a:r>
-                      <a:endParaRPr lang="en-US" sz="1150" dirty="0">
-                        <a:latin typeface="Calibri" charset="0"/>
-                        <a:ea typeface="Calibri" charset="0"/>
-                        <a:cs typeface="Calibri" charset="0"/>
-                      </a:endParaRPr>
-                    </a:p>
-                  </a:txBody>
-                  <a:tcPr marL="91440" marR="91440" marT="45720" marB="45720" anchor="ctr">
-                    <a:lnL w="6350" cap="flat" cmpd="sng" algn="ctr">
-                      <a:solidFill>
-                        <a:srgbClr val="D8DEE4"/>
-                      </a:solidFill>
-                      <a:prstDash val="solid"/>
-                      <a:round/>
-                      <a:headEnd type="none" w="med" len="med"/>
-                      <a:tailEnd type="none" w="med" len="med"/>
-                    </a:lnL>
-                    <a:lnR w="6350" cap="flat" cmpd="sng" algn="ctr">
-                      <a:solidFill>
-                        <a:srgbClr val="D8DEE4"/>
-                      </a:solidFill>
-                      <a:prstDash val="solid"/>
-                      <a:round/>
-                      <a:headEnd type="none" w="med" len="med"/>
-                      <a:tailEnd type="none" w="med" len="med"/>
-                    </a:lnR>
-                    <a:lnT w="6350" cap="flat" cmpd="sng" algn="ctr">
-                      <a:solidFill>
-                        <a:srgbClr val="D8DEE4"/>
-                      </a:solidFill>
-                      <a:prstDash val="solid"/>
-                      <a:round/>
-                      <a:headEnd type="none" w="med" len="med"/>
-                      <a:tailEnd type="none" w="med" len="med"/>
-                    </a:lnT>
-                    <a:lnB w="6350" cap="flat" cmpd="sng" algn="ctr">
-                      <a:solidFill>
-                        <a:srgbClr val="D8DEE4"/>
-                      </a:solidFill>
-                      <a:prstDash val="solid"/>
-                      <a:round/>
-                      <a:headEnd type="none" w="med" len="med"/>
-                      <a:tailEnd type="none" w="med" len="med"/>
-                    </a:lnB>
-                    <a:solidFill>
-                      <a:srgbClr val="F2F7F5"/>
-                    </a:solidFill>
-                  </a:tcPr>
-                </a:tc>
-                <a:tc>
-                  <a:txBody>
-                    <a:bodyPr/>
-                    <a:lstStyle/>
-                    <a:p>
-                      <a:pPr indent="0" marL="0">
-                        <a:buNone/>
-                      </a:pPr>
-                      <a:r>
-                        <a:rPr lang="en-US" sz="1150" dirty="0">
-                          <a:solidFill>
-                            <a:srgbClr val="141821"/>
-                          </a:solidFill>
-                          <a:latin typeface="Calibri" pitchFamily="34" charset="0"/>
-                          <a:ea typeface="Calibri" pitchFamily="34" charset="-122"/>
-                          <a:cs typeface="Calibri" pitchFamily="34" charset="-120"/>
-                        </a:rPr>
-                        <a:t>Node.js + TypeScript</a:t>
-                      </a:r>
-                      <a:endParaRPr lang="en-US" sz="1150" dirty="0">
-                        <a:latin typeface="Calibri" charset="0"/>
-                        <a:ea typeface="Calibri" charset="0"/>
-                        <a:cs typeface="Calibri" charset="0"/>
-                      </a:endParaRPr>
-                    </a:p>
-                  </a:txBody>
-                  <a:tcPr marL="91440" marR="91440" marT="45720" marB="45720" anchor="ctr">
-                    <a:lnL w="6350" cap="flat" cmpd="sng" algn="ctr">
-                      <a:solidFill>
-                        <a:srgbClr val="D8DEE4"/>
-                      </a:solidFill>
-                      <a:prstDash val="solid"/>
-                      <a:round/>
-                      <a:headEnd type="none" w="med" len="med"/>
-                      <a:tailEnd type="none" w="med" len="med"/>
-                    </a:lnL>
-                    <a:lnR w="6350" cap="flat" cmpd="sng" algn="ctr">
-                      <a:solidFill>
-                        <a:srgbClr val="D8DEE4"/>
-                      </a:solidFill>
-                      <a:prstDash val="solid"/>
-                      <a:round/>
-                      <a:headEnd type="none" w="med" len="med"/>
-                      <a:tailEnd type="none" w="med" len="med"/>
-                    </a:lnR>
-                    <a:lnT w="6350" cap="flat" cmpd="sng" algn="ctr">
-                      <a:solidFill>
-                        <a:srgbClr val="D8DEE4"/>
-                      </a:solidFill>
-                      <a:prstDash val="solid"/>
-                      <a:round/>
-                      <a:headEnd type="none" w="med" len="med"/>
-                      <a:tailEnd type="none" w="med" len="med"/>
-                    </a:lnT>
-                    <a:lnB w="6350" cap="flat" cmpd="sng" algn="ctr">
-                      <a:solidFill>
-                        <a:srgbClr val="D8DEE4"/>
-                      </a:solidFill>
-                      <a:prstDash val="solid"/>
-                      <a:round/>
-                      <a:headEnd type="none" w="med" len="med"/>
-                      <a:tailEnd type="none" w="med" len="med"/>
-                    </a:lnB>
-                    <a:solidFill>
-                      <a:srgbClr val="F2F7F5"/>
-                    </a:solidFill>
-                  </a:tcPr>
-                </a:tc>
-                <a:tc>
-                  <a:txBody>
-                    <a:bodyPr/>
-                    <a:lstStyle/>
-                    <a:p>
-                      <a:pPr indent="0" marL="0">
-                        <a:buNone/>
-                      </a:pPr>
-                      <a:r>
-                        <a:rPr lang="en-US" sz="1150" dirty="0">
-                          <a:solidFill>
-                            <a:srgbClr val="141821"/>
-                          </a:solidFill>
-                          <a:latin typeface="Calibri" pitchFamily="34" charset="0"/>
-                          <a:ea typeface="Calibri" pitchFamily="34" charset="-122"/>
-                          <a:cs typeface="Calibri" pitchFamily="34" charset="-120"/>
-                        </a:rPr>
-                        <a:t>One language, small team moves fast</a:t>
-                      </a:r>
-                      <a:endParaRPr lang="en-US" sz="1150" dirty="0">
-                        <a:latin typeface="Calibri" charset="0"/>
-                        <a:ea typeface="Calibri" charset="0"/>
-                        <a:cs typeface="Calibri" charset="0"/>
-                      </a:endParaRPr>
-                    </a:p>
-                  </a:txBody>
-                  <a:tcPr marL="91440" marR="91440" marT="45720" marB="45720" anchor="ctr">
-                    <a:lnL w="6350" cap="flat" cmpd="sng" algn="ctr">
-                      <a:solidFill>
-                        <a:srgbClr val="D8DEE4"/>
-                      </a:solidFill>
-                      <a:prstDash val="solid"/>
-                      <a:round/>
-                      <a:headEnd type="none" w="med" len="med"/>
-                      <a:tailEnd type="none" w="med" len="med"/>
-                    </a:lnL>
-                    <a:lnR w="6350" cap="flat" cmpd="sng" algn="ctr">
-                      <a:solidFill>
-                        <a:srgbClr val="D8DEE4"/>
-                      </a:solidFill>
-                      <a:prstDash val="solid"/>
-                      <a:round/>
-                      <a:headEnd type="none" w="med" len="med"/>
-                      <a:tailEnd type="none" w="med" len="med"/>
-                    </a:lnR>
-                    <a:lnT w="6350" cap="flat" cmpd="sng" algn="ctr">
-                      <a:solidFill>
-                        <a:srgbClr val="D8DEE4"/>
-                      </a:solidFill>
-                      <a:prstDash val="solid"/>
-                      <a:round/>
-                      <a:headEnd type="none" w="med" len="med"/>
-                      <a:tailEnd type="none" w="med" len="med"/>
-                    </a:lnT>
-                    <a:lnB w="6350" cap="flat" cmpd="sng" algn="ctr">
-                      <a:solidFill>
-                        <a:srgbClr val="D8DEE4"/>
-                      </a:solidFill>
-                      <a:prstDash val="solid"/>
-                      <a:round/>
-                      <a:headEnd type="none" w="med" len="med"/>
-                      <a:tailEnd type="none" w="med" len="med"/>
-                    </a:lnB>
-                    <a:solidFill>
-                      <a:srgbClr val="F2F7F5"/>
-                    </a:solidFill>
-                  </a:tcPr>
-                </a:tc>
-              </a:tr>
-              <a:tr h="384048">
-                <a:tc>
-                  <a:txBody>
-                    <a:bodyPr/>
-                    <a:lstStyle/>
-                    <a:p>
-                      <a:pPr indent="0" marL="0">
-                        <a:buNone/>
-                      </a:pPr>
-                      <a:r>
-                        <a:rPr lang="en-US" sz="1150" dirty="0">
-                          <a:solidFill>
-                            <a:srgbClr val="141821"/>
-                          </a:solidFill>
-                          <a:latin typeface="Calibri" pitchFamily="34" charset="0"/>
-                          <a:ea typeface="Calibri" pitchFamily="34" charset="-122"/>
-                          <a:cs typeface="Calibri" pitchFamily="34" charset="-120"/>
-                        </a:rPr>
-                        <a:t>Database</a:t>
-                      </a:r>
-                      <a:endParaRPr lang="en-US" sz="1150" dirty="0">
-                        <a:latin typeface="Calibri" charset="0"/>
-                        <a:ea typeface="Calibri" charset="0"/>
-                        <a:cs typeface="Calibri" charset="0"/>
-                      </a:endParaRPr>
-                    </a:p>
-                  </a:txBody>
-                  <a:tcPr marL="91440" marR="91440" marT="45720" marB="45720" anchor="ctr">
-                    <a:lnL w="6350" cap="flat" cmpd="sng" algn="ctr">
-                      <a:solidFill>
-                        <a:srgbClr val="D8DEE4"/>
-                      </a:solidFill>
-                      <a:prstDash val="solid"/>
-                      <a:round/>
-                      <a:headEnd type="none" w="med" len="med"/>
-                      <a:tailEnd type="none" w="med" len="med"/>
-                    </a:lnL>
-                    <a:lnR w="6350" cap="flat" cmpd="sng" algn="ctr">
-                      <a:solidFill>
-                        <a:srgbClr val="D8DEE4"/>
-                      </a:solidFill>
-                      <a:prstDash val="solid"/>
-                      <a:round/>
-                      <a:headEnd type="none" w="med" len="med"/>
-                      <a:tailEnd type="none" w="med" len="med"/>
-                    </a:lnR>
-                    <a:lnT w="6350" cap="flat" cmpd="sng" algn="ctr">
-                      <a:solidFill>
-                        <a:srgbClr val="D8DEE4"/>
-                      </a:solidFill>
-                      <a:prstDash val="solid"/>
-                      <a:round/>
-                      <a:headEnd type="none" w="med" len="med"/>
-                      <a:tailEnd type="none" w="med" len="med"/>
-                    </a:lnT>
-                    <a:lnB w="6350" cap="flat" cmpd="sng" algn="ctr">
-                      <a:solidFill>
-                        <a:srgbClr val="D8DEE4"/>
-                      </a:solidFill>
-                      <a:prstDash val="solid"/>
-                      <a:round/>
-                      <a:headEnd type="none" w="med" len="med"/>
-                      <a:tailEnd type="none" w="med" len="med"/>
-                    </a:lnB>
-                    <a:solidFill>
-                      <a:srgbClr val="FFFFFF"/>
-                    </a:solidFill>
-                  </a:tcPr>
-                </a:tc>
-                <a:tc>
-                  <a:txBody>
-                    <a:bodyPr/>
-                    <a:lstStyle/>
-                    <a:p>
-                      <a:pPr indent="0" marL="0">
-                        <a:buNone/>
-                      </a:pPr>
-                      <a:r>
-                        <a:rPr lang="en-US" sz="1150" dirty="0">
-                          <a:solidFill>
-                            <a:srgbClr val="141821"/>
-                          </a:solidFill>
-                          <a:latin typeface="Calibri" pitchFamily="34" charset="0"/>
-                          <a:ea typeface="Calibri" pitchFamily="34" charset="-122"/>
-                          <a:cs typeface="Calibri" pitchFamily="34" charset="-120"/>
-                        </a:rPr>
-                        <a:t>PostgreSQL + PostGIS</a:t>
-                      </a:r>
-                      <a:endParaRPr lang="en-US" sz="1150" dirty="0">
-                        <a:latin typeface="Calibri" charset="0"/>
-                        <a:ea typeface="Calibri" charset="0"/>
-                        <a:cs typeface="Calibri" charset="0"/>
-                      </a:endParaRPr>
-                    </a:p>
-                  </a:txBody>
-                  <a:tcPr marL="91440" marR="91440" marT="45720" marB="45720" anchor="ctr">
-                    <a:lnL w="6350" cap="flat" cmpd="sng" algn="ctr">
-                      <a:solidFill>
-                        <a:srgbClr val="D8DEE4"/>
-                      </a:solidFill>
-                      <a:prstDash val="solid"/>
-                      <a:round/>
-                      <a:headEnd type="none" w="med" len="med"/>
-                      <a:tailEnd type="none" w="med" len="med"/>
-                    </a:lnL>
-                    <a:lnR w="6350" cap="flat" cmpd="sng" algn="ctr">
-                      <a:solidFill>
-                        <a:srgbClr val="D8DEE4"/>
-                      </a:solidFill>
-                      <a:prstDash val="solid"/>
-                      <a:round/>
-                      <a:headEnd type="none" w="med" len="med"/>
-                      <a:tailEnd type="none" w="med" len="med"/>
-                    </a:lnR>
-                    <a:lnT w="6350" cap="flat" cmpd="sng" algn="ctr">
-                      <a:solidFill>
-                        <a:srgbClr val="D8DEE4"/>
-                      </a:solidFill>
-                      <a:prstDash val="solid"/>
-                      <a:round/>
-                      <a:headEnd type="none" w="med" len="med"/>
-                      <a:tailEnd type="none" w="med" len="med"/>
-                    </a:lnT>
-                    <a:lnB w="6350" cap="flat" cmpd="sng" algn="ctr">
-                      <a:solidFill>
-                        <a:srgbClr val="D8DEE4"/>
-                      </a:solidFill>
-                      <a:prstDash val="solid"/>
-                      <a:round/>
-                      <a:headEnd type="none" w="med" len="med"/>
-                      <a:tailEnd type="none" w="med" len="med"/>
-                    </a:lnB>
-                    <a:solidFill>
-                      <a:srgbClr val="FFFFFF"/>
-                    </a:solidFill>
-                  </a:tcPr>
-                </a:tc>
-                <a:tc>
-                  <a:txBody>
-                    <a:bodyPr/>
-                    <a:lstStyle/>
-                    <a:p>
-                      <a:pPr indent="0" marL="0">
-                        <a:buNone/>
-                      </a:pPr>
-                      <a:r>
-                        <a:rPr lang="en-US" sz="1150" dirty="0">
-                          <a:solidFill>
-                            <a:srgbClr val="141821"/>
-                          </a:solidFill>
-                          <a:latin typeface="Calibri" pitchFamily="34" charset="0"/>
-                          <a:ea typeface="Calibri" pitchFamily="34" charset="-122"/>
-                          <a:cs typeface="Calibri" pitchFamily="34" charset="-120"/>
-                        </a:rPr>
-                        <a:t>'Flats within 3 km' queries, reliably</a:t>
-                      </a:r>
-                      <a:endParaRPr lang="en-US" sz="1150" dirty="0">
-                        <a:latin typeface="Calibri" charset="0"/>
-                        <a:ea typeface="Calibri" charset="0"/>
-                        <a:cs typeface="Calibri" charset="0"/>
-                      </a:endParaRPr>
-                    </a:p>
-                  </a:txBody>
-                  <a:tcPr marL="91440" marR="91440" marT="45720" marB="45720" anchor="ctr">
-                    <a:lnL w="6350" cap="flat" cmpd="sng" algn="ctr">
-                      <a:solidFill>
-                        <a:srgbClr val="D8DEE4"/>
-                      </a:solidFill>
-                      <a:prstDash val="solid"/>
-                      <a:round/>
-                      <a:headEnd type="none" w="med" len="med"/>
-                      <a:tailEnd type="none" w="med" len="med"/>
-                    </a:lnL>
-                    <a:lnR w="6350" cap="flat" cmpd="sng" algn="ctr">
-                      <a:solidFill>
-                        <a:srgbClr val="D8DEE4"/>
-                      </a:solidFill>
-                      <a:prstDash val="solid"/>
-                      <a:round/>
-                      <a:headEnd type="none" w="med" len="med"/>
-                      <a:tailEnd type="none" w="med" len="med"/>
-                    </a:lnR>
-                    <a:lnT w="6350" cap="flat" cmpd="sng" algn="ctr">
-                      <a:solidFill>
-                        <a:srgbClr val="D8DEE4"/>
-                      </a:solidFill>
-                      <a:prstDash val="solid"/>
-                      <a:round/>
-                      <a:headEnd type="none" w="med" len="med"/>
-                      <a:tailEnd type="none" w="med" len="med"/>
-                    </a:lnT>
-                    <a:lnB w="6350" cap="flat" cmpd="sng" algn="ctr">
-                      <a:solidFill>
-                        <a:srgbClr val="D8DEE4"/>
-                      </a:solidFill>
-                      <a:prstDash val="solid"/>
-                      <a:round/>
-                      <a:headEnd type="none" w="med" len="med"/>
-                      <a:tailEnd type="none" w="med" len="med"/>
-                    </a:lnB>
-                    <a:solidFill>
-                      <a:srgbClr val="FFFFFF"/>
-                    </a:solidFill>
-                  </a:tcPr>
-                </a:tc>
-              </a:tr>
-              <a:tr h="384048">
-                <a:tc>
-                  <a:txBody>
-                    <a:bodyPr/>
-                    <a:lstStyle/>
-                    <a:p>
-                      <a:pPr indent="0" marL="0">
-                        <a:buNone/>
-                      </a:pPr>
-                      <a:r>
-                        <a:rPr lang="en-US" sz="1150" dirty="0">
-                          <a:solidFill>
-                            <a:srgbClr val="141821"/>
-                          </a:solidFill>
-                          <a:latin typeface="Calibri" pitchFamily="34" charset="0"/>
-                          <a:ea typeface="Calibri" pitchFamily="34" charset="-122"/>
-                          <a:cs typeface="Calibri" pitchFamily="34" charset="-120"/>
-                        </a:rPr>
-                        <a:t>Search</a:t>
-                      </a:r>
-                      <a:endParaRPr lang="en-US" sz="1150" dirty="0">
-                        <a:latin typeface="Calibri" charset="0"/>
-                        <a:ea typeface="Calibri" charset="0"/>
-                        <a:cs typeface="Calibri" charset="0"/>
-                      </a:endParaRPr>
-                    </a:p>
-                  </a:txBody>
-                  <a:tcPr marL="91440" marR="91440" marT="45720" marB="45720" anchor="ctr">
-                    <a:lnL w="6350" cap="flat" cmpd="sng" algn="ctr">
-                      <a:solidFill>
-                        <a:srgbClr val="D8DEE4"/>
-                      </a:solidFill>
-                      <a:prstDash val="solid"/>
-                      <a:round/>
-                      <a:headEnd type="none" w="med" len="med"/>
-                      <a:tailEnd type="none" w="med" len="med"/>
-                    </a:lnL>
-                    <a:lnR w="6350" cap="flat" cmpd="sng" algn="ctr">
-                      <a:solidFill>
-                        <a:srgbClr val="D8DEE4"/>
-                      </a:solidFill>
-                      <a:prstDash val="solid"/>
-                      <a:round/>
-                      <a:headEnd type="none" w="med" len="med"/>
-                      <a:tailEnd type="none" w="med" len="med"/>
-                    </a:lnR>
-                    <a:lnT w="6350" cap="flat" cmpd="sng" algn="ctr">
-                      <a:solidFill>
-                        <a:srgbClr val="D8DEE4"/>
-                      </a:solidFill>
-                      <a:prstDash val="solid"/>
-                      <a:round/>
-                      <a:headEnd type="none" w="med" len="med"/>
-                      <a:tailEnd type="none" w="med" len="med"/>
-                    </a:lnT>
-                    <a:lnB w="6350" cap="flat" cmpd="sng" algn="ctr">
-                      <a:solidFill>
-                        <a:srgbClr val="D8DEE4"/>
-                      </a:solidFill>
-                      <a:prstDash val="solid"/>
-                      <a:round/>
-                      <a:headEnd type="none" w="med" len="med"/>
-                      <a:tailEnd type="none" w="med" len="med"/>
-                    </a:lnB>
-                    <a:solidFill>
-                      <a:srgbClr val="F2F7F5"/>
-                    </a:solidFill>
-                  </a:tcPr>
-                </a:tc>
-                <a:tc>
-                  <a:txBody>
-                    <a:bodyPr/>
-                    <a:lstStyle/>
-                    <a:p>
-                      <a:pPr indent="0" marL="0">
-                        <a:buNone/>
-                      </a:pPr>
-                      <a:r>
-                        <a:rPr lang="en-US" sz="1150" dirty="0">
-                          <a:solidFill>
-                            <a:srgbClr val="141821"/>
-                          </a:solidFill>
-                          <a:latin typeface="Calibri" pitchFamily="34" charset="0"/>
-                          <a:ea typeface="Calibri" pitchFamily="34" charset="-122"/>
-                          <a:cs typeface="Calibri" pitchFamily="34" charset="-120"/>
-                        </a:rPr>
-                        <a:t>Typesense (self-hosted)</a:t>
-                      </a:r>
-                      <a:endParaRPr lang="en-US" sz="1150" dirty="0">
-                        <a:latin typeface="Calibri" charset="0"/>
-                        <a:ea typeface="Calibri" charset="0"/>
-                        <a:cs typeface="Calibri" charset="0"/>
-                      </a:endParaRPr>
-                    </a:p>
-                  </a:txBody>
-                  <a:tcPr marL="91440" marR="91440" marT="45720" marB="45720" anchor="ctr">
-                    <a:lnL w="6350" cap="flat" cmpd="sng" algn="ctr">
-                      <a:solidFill>
-                        <a:srgbClr val="D8DEE4"/>
-                      </a:solidFill>
-                      <a:prstDash val="solid"/>
-                      <a:round/>
-                      <a:headEnd type="none" w="med" len="med"/>
-                      <a:tailEnd type="none" w="med" len="med"/>
-                    </a:lnL>
-                    <a:lnR w="6350" cap="flat" cmpd="sng" algn="ctr">
-                      <a:solidFill>
-                        <a:srgbClr val="D8DEE4"/>
-                      </a:solidFill>
-                      <a:prstDash val="solid"/>
-                      <a:round/>
-                      <a:headEnd type="none" w="med" len="med"/>
-                      <a:tailEnd type="none" w="med" len="med"/>
-                    </a:lnR>
-                    <a:lnT w="6350" cap="flat" cmpd="sng" algn="ctr">
-                      <a:solidFill>
-                        <a:srgbClr val="D8DEE4"/>
-                      </a:solidFill>
-                      <a:prstDash val="solid"/>
-                      <a:round/>
-                      <a:headEnd type="none" w="med" len="med"/>
-                      <a:tailEnd type="none" w="med" len="med"/>
-                    </a:lnT>
-                    <a:lnB w="6350" cap="flat" cmpd="sng" algn="ctr">
-                      <a:solidFill>
-                        <a:srgbClr val="D8DEE4"/>
-                      </a:solidFill>
-                      <a:prstDash val="solid"/>
-                      <a:round/>
-                      <a:headEnd type="none" w="med" len="med"/>
-                      <a:tailEnd type="none" w="med" len="med"/>
-                    </a:lnB>
-                    <a:solidFill>
-                      <a:srgbClr val="F2F7F5"/>
-                    </a:solidFill>
-                  </a:tcPr>
-                </a:tc>
-                <a:tc>
-                  <a:txBody>
-                    <a:bodyPr/>
-                    <a:lstStyle/>
-                    <a:p>
-                      <a:pPr indent="0" marL="0">
-                        <a:buNone/>
-                      </a:pPr>
-                      <a:r>
-                        <a:rPr lang="en-US" sz="1150" dirty="0">
-                          <a:solidFill>
-                            <a:srgbClr val="141821"/>
-                          </a:solidFill>
-                          <a:latin typeface="Calibri" pitchFamily="34" charset="0"/>
-                          <a:ea typeface="Calibri" pitchFamily="34" charset="-122"/>
-                          <a:cs typeface="Calibri" pitchFamily="34" charset="-120"/>
-                        </a:rPr>
-                        <a:t>≈$69/mo vs Algolia's ≈$525/mo</a:t>
-                      </a:r>
-                      <a:endParaRPr lang="en-US" sz="1150" dirty="0">
-                        <a:latin typeface="Calibri" charset="0"/>
-                        <a:ea typeface="Calibri" charset="0"/>
-                        <a:cs typeface="Calibri" charset="0"/>
-                      </a:endParaRPr>
-                    </a:p>
-                  </a:txBody>
-                  <a:tcPr marL="91440" marR="91440" marT="45720" marB="45720" anchor="ctr">
-                    <a:lnL w="6350" cap="flat" cmpd="sng" algn="ctr">
-                      <a:solidFill>
-                        <a:srgbClr val="D8DEE4"/>
-                      </a:solidFill>
-                      <a:prstDash val="solid"/>
-                      <a:round/>
-                      <a:headEnd type="none" w="med" len="med"/>
-                      <a:tailEnd type="none" w="med" len="med"/>
-                    </a:lnL>
-                    <a:lnR w="6350" cap="flat" cmpd="sng" algn="ctr">
-                      <a:solidFill>
-                        <a:srgbClr val="D8DEE4"/>
-                      </a:solidFill>
-                      <a:prstDash val="solid"/>
-                      <a:round/>
-                      <a:headEnd type="none" w="med" len="med"/>
-                      <a:tailEnd type="none" w="med" len="med"/>
-                    </a:lnR>
-                    <a:lnT w="6350" cap="flat" cmpd="sng" algn="ctr">
-                      <a:solidFill>
-                        <a:srgbClr val="D8DEE4"/>
-                      </a:solidFill>
-                      <a:prstDash val="solid"/>
-                      <a:round/>
-                      <a:headEnd type="none" w="med" len="med"/>
-                      <a:tailEnd type="none" w="med" len="med"/>
-                    </a:lnT>
-                    <a:lnB w="6350" cap="flat" cmpd="sng" algn="ctr">
-                      <a:solidFill>
-                        <a:srgbClr val="D8DEE4"/>
-                      </a:solidFill>
-                      <a:prstDash val="solid"/>
-                      <a:round/>
-                      <a:headEnd type="none" w="med" len="med"/>
-                      <a:tailEnd type="none" w="med" len="med"/>
-                    </a:lnB>
-                    <a:solidFill>
-                      <a:srgbClr val="F2F7F5"/>
-                    </a:solidFill>
-                  </a:tcPr>
-                </a:tc>
-              </a:tr>
-              <a:tr h="384048">
-                <a:tc>
-                  <a:txBody>
-                    <a:bodyPr/>
-                    <a:lstStyle/>
-                    <a:p>
-                      <a:pPr indent="0" marL="0">
-                        <a:buNone/>
-                      </a:pPr>
-                      <a:r>
-                        <a:rPr lang="en-US" sz="1150" dirty="0">
-                          <a:solidFill>
-                            <a:srgbClr val="141821"/>
-                          </a:solidFill>
-                          <a:latin typeface="Calibri" pitchFamily="34" charset="0"/>
-                          <a:ea typeface="Calibri" pitchFamily="34" charset="-122"/>
-                          <a:cs typeface="Calibri" pitchFamily="34" charset="-120"/>
-                        </a:rPr>
-                        <a:t>Maps</a:t>
-                      </a:r>
-                      <a:endParaRPr lang="en-US" sz="1150" dirty="0">
-                        <a:latin typeface="Calibri" charset="0"/>
-                        <a:ea typeface="Calibri" charset="0"/>
-                        <a:cs typeface="Calibri" charset="0"/>
-                      </a:endParaRPr>
-                    </a:p>
-                  </a:txBody>
-                  <a:tcPr marL="91440" marR="91440" marT="45720" marB="45720" anchor="ctr">
-                    <a:lnL w="6350" cap="flat" cmpd="sng" algn="ctr">
-                      <a:solidFill>
-                        <a:srgbClr val="D8DEE4"/>
-                      </a:solidFill>
-                      <a:prstDash val="solid"/>
-                      <a:round/>
-                      <a:headEnd type="none" w="med" len="med"/>
-                      <a:tailEnd type="none" w="med" len="med"/>
-                    </a:lnL>
-                    <a:lnR w="6350" cap="flat" cmpd="sng" algn="ctr">
-                      <a:solidFill>
-                        <a:srgbClr val="D8DEE4"/>
-                      </a:solidFill>
-                      <a:prstDash val="solid"/>
-                      <a:round/>
-                      <a:headEnd type="none" w="med" len="med"/>
-                      <a:tailEnd type="none" w="med" len="med"/>
-                    </a:lnR>
-                    <a:lnT w="6350" cap="flat" cmpd="sng" algn="ctr">
-                      <a:solidFill>
-                        <a:srgbClr val="D8DEE4"/>
-                      </a:solidFill>
-                      <a:prstDash val="solid"/>
-                      <a:round/>
-                      <a:headEnd type="none" w="med" len="med"/>
-                      <a:tailEnd type="none" w="med" len="med"/>
-                    </a:lnT>
-                    <a:lnB w="6350" cap="flat" cmpd="sng" algn="ctr">
-                      <a:solidFill>
-                        <a:srgbClr val="D8DEE4"/>
-                      </a:solidFill>
-                      <a:prstDash val="solid"/>
-                      <a:round/>
-                      <a:headEnd type="none" w="med" len="med"/>
-                      <a:tailEnd type="none" w="med" len="med"/>
-                    </a:lnB>
-                    <a:solidFill>
-                      <a:srgbClr val="FFFFFF"/>
-                    </a:solidFill>
-                  </a:tcPr>
-                </a:tc>
-                <a:tc>
-                  <a:txBody>
-                    <a:bodyPr/>
-                    <a:lstStyle/>
-                    <a:p>
-                      <a:pPr indent="0" marL="0">
-                        <a:buNone/>
-                      </a:pPr>
-                      <a:r>
-                        <a:rPr lang="en-US" sz="1150" dirty="0">
-                          <a:solidFill>
-                            <a:srgbClr val="141821"/>
-                          </a:solidFill>
-                          <a:latin typeface="Calibri" pitchFamily="34" charset="0"/>
-                          <a:ea typeface="Calibri" pitchFamily="34" charset="-122"/>
-                          <a:cs typeface="Calibri" pitchFamily="34" charset="-120"/>
-                        </a:rPr>
-                        <a:t>Ola Maps / MapmyIndia</a:t>
-                      </a:r>
-                      <a:endParaRPr lang="en-US" sz="1150" dirty="0">
-                        <a:latin typeface="Calibri" charset="0"/>
-                        <a:ea typeface="Calibri" charset="0"/>
-                        <a:cs typeface="Calibri" charset="0"/>
-                      </a:endParaRPr>
-                    </a:p>
-                  </a:txBody>
-                  <a:tcPr marL="91440" marR="91440" marT="45720" marB="45720" anchor="ctr">
-                    <a:lnL w="6350" cap="flat" cmpd="sng" algn="ctr">
-                      <a:solidFill>
-                        <a:srgbClr val="D8DEE4"/>
-                      </a:solidFill>
-                      <a:prstDash val="solid"/>
-                      <a:round/>
-                      <a:headEnd type="none" w="med" len="med"/>
-                      <a:tailEnd type="none" w="med" len="med"/>
-                    </a:lnL>
-                    <a:lnR w="6350" cap="flat" cmpd="sng" algn="ctr">
-                      <a:solidFill>
-                        <a:srgbClr val="D8DEE4"/>
-                      </a:solidFill>
-                      <a:prstDash val="solid"/>
-                      <a:round/>
-                      <a:headEnd type="none" w="med" len="med"/>
-                      <a:tailEnd type="none" w="med" len="med"/>
-                    </a:lnR>
-                    <a:lnT w="6350" cap="flat" cmpd="sng" algn="ctr">
-                      <a:solidFill>
-                        <a:srgbClr val="D8DEE4"/>
-                      </a:solidFill>
-                      <a:prstDash val="solid"/>
-                      <a:round/>
-                      <a:headEnd type="none" w="med" len="med"/>
-                      <a:tailEnd type="none" w="med" len="med"/>
-                    </a:lnT>
-                    <a:lnB w="6350" cap="flat" cmpd="sng" algn="ctr">
-                      <a:solidFill>
-                        <a:srgbClr val="D8DEE4"/>
-                      </a:solidFill>
-                      <a:prstDash val="solid"/>
-                      <a:round/>
-                      <a:headEnd type="none" w="med" len="med"/>
-                      <a:tailEnd type="none" w="med" len="med"/>
-                    </a:lnB>
-                    <a:solidFill>
-                      <a:srgbClr val="FFFFFF"/>
-                    </a:solidFill>
-                  </a:tcPr>
-                </a:tc>
-                <a:tc>
-                  <a:txBody>
-                    <a:bodyPr/>
-                    <a:lstStyle/>
-                    <a:p>
-                      <a:pPr indent="0" marL="0">
-                        <a:buNone/>
-                      </a:pPr>
-                      <a:r>
-                        <a:rPr lang="en-US" sz="1150" dirty="0">
-                          <a:solidFill>
-                            <a:srgbClr val="141821"/>
-                          </a:solidFill>
-                          <a:latin typeface="Calibri" pitchFamily="34" charset="0"/>
-                          <a:ea typeface="Calibri" pitchFamily="34" charset="-122"/>
-                          <a:cs typeface="Calibri" pitchFamily="34" charset="-120"/>
-                        </a:rPr>
-                        <a:t>Free tier + best Indian locality data</a:t>
-                      </a:r>
-                      <a:endParaRPr lang="en-US" sz="1150" dirty="0">
-                        <a:latin typeface="Calibri" charset="0"/>
-                        <a:ea typeface="Calibri" charset="0"/>
-                        <a:cs typeface="Calibri" charset="0"/>
-                      </a:endParaRPr>
-                    </a:p>
-                  </a:txBody>
-                  <a:tcPr marL="91440" marR="91440" marT="45720" marB="45720" anchor="ctr">
-                    <a:lnL w="6350" cap="flat" cmpd="sng" algn="ctr">
-                      <a:solidFill>
-                        <a:srgbClr val="D8DEE4"/>
-                      </a:solidFill>
-                      <a:prstDash val="solid"/>
-                      <a:round/>
-                      <a:headEnd type="none" w="med" len="med"/>
-                      <a:tailEnd type="none" w="med" len="med"/>
-                    </a:lnL>
-                    <a:lnR w="6350" cap="flat" cmpd="sng" algn="ctr">
-                      <a:solidFill>
-                        <a:srgbClr val="D8DEE4"/>
-                      </a:solidFill>
-                      <a:prstDash val="solid"/>
-                      <a:round/>
-                      <a:headEnd type="none" w="med" len="med"/>
-                      <a:tailEnd type="none" w="med" len="med"/>
-                    </a:lnR>
-                    <a:lnT w="6350" cap="flat" cmpd="sng" algn="ctr">
-                      <a:solidFill>
-                        <a:srgbClr val="D8DEE4"/>
-                      </a:solidFill>
-                      <a:prstDash val="solid"/>
-                      <a:round/>
-                      <a:headEnd type="none" w="med" len="med"/>
-                      <a:tailEnd type="none" w="med" len="med"/>
-                    </a:lnT>
-                    <a:lnB w="6350" cap="flat" cmpd="sng" algn="ctr">
-                      <a:solidFill>
-                        <a:srgbClr val="D8DEE4"/>
-                      </a:solidFill>
-                      <a:prstDash val="solid"/>
-                      <a:round/>
-                      <a:headEnd type="none" w="med" len="med"/>
-                      <a:tailEnd type="none" w="med" len="med"/>
-                    </a:lnB>
-                    <a:solidFill>
-                      <a:srgbClr val="FFFFFF"/>
-                    </a:solidFill>
-                  </a:tcPr>
-                </a:tc>
-              </a:tr>
-              <a:tr h="384048">
-                <a:tc>
-                  <a:txBody>
-                    <a:bodyPr/>
-                    <a:lstStyle/>
-                    <a:p>
-                      <a:pPr indent="0" marL="0">
-                        <a:buNone/>
-                      </a:pPr>
-                      <a:r>
-                        <a:rPr lang="en-US" sz="1150" dirty="0">
-                          <a:solidFill>
-                            <a:srgbClr val="141821"/>
-                          </a:solidFill>
-                          <a:latin typeface="Calibri" pitchFamily="34" charset="0"/>
-                          <a:ea typeface="Calibri" pitchFamily="34" charset="-122"/>
-                          <a:cs typeface="Calibri" pitchFamily="34" charset="-120"/>
-                        </a:rPr>
-                        <a:t>Cloud</a:t>
-                      </a:r>
-                      <a:endParaRPr lang="en-US" sz="1150" dirty="0">
-                        <a:latin typeface="Calibri" charset="0"/>
-                        <a:ea typeface="Calibri" charset="0"/>
-                        <a:cs typeface="Calibri" charset="0"/>
-                      </a:endParaRPr>
-                    </a:p>
-                  </a:txBody>
-                  <a:tcPr marL="91440" marR="91440" marT="45720" marB="45720" anchor="ctr">
-                    <a:lnL w="6350" cap="flat" cmpd="sng" algn="ctr">
-                      <a:solidFill>
-                        <a:srgbClr val="D8DEE4"/>
-                      </a:solidFill>
-                      <a:prstDash val="solid"/>
-                      <a:round/>
-                      <a:headEnd type="none" w="med" len="med"/>
-                      <a:tailEnd type="none" w="med" len="med"/>
-                    </a:lnL>
-                    <a:lnR w="6350" cap="flat" cmpd="sng" algn="ctr">
-                      <a:solidFill>
-                        <a:srgbClr val="D8DEE4"/>
-                      </a:solidFill>
-                      <a:prstDash val="solid"/>
-                      <a:round/>
-                      <a:headEnd type="none" w="med" len="med"/>
-                      <a:tailEnd type="none" w="med" len="med"/>
-                    </a:lnR>
-                    <a:lnT w="6350" cap="flat" cmpd="sng" algn="ctr">
-                      <a:solidFill>
-                        <a:srgbClr val="D8DEE4"/>
-                      </a:solidFill>
-                      <a:prstDash val="solid"/>
-                      <a:round/>
-                      <a:headEnd type="none" w="med" len="med"/>
-                      <a:tailEnd type="none" w="med" len="med"/>
-                    </a:lnT>
-                    <a:lnB w="6350" cap="flat" cmpd="sng" algn="ctr">
-                      <a:solidFill>
-                        <a:srgbClr val="D8DEE4"/>
-                      </a:solidFill>
-                      <a:prstDash val="solid"/>
-                      <a:round/>
-                      <a:headEnd type="none" w="med" len="med"/>
-                      <a:tailEnd type="none" w="med" len="med"/>
-                    </a:lnB>
-                    <a:solidFill>
-                      <a:srgbClr val="F2F7F5"/>
-                    </a:solidFill>
-                  </a:tcPr>
-                </a:tc>
-                <a:tc>
-                  <a:txBody>
-                    <a:bodyPr/>
-                    <a:lstStyle/>
-                    <a:p>
-                      <a:pPr indent="0" marL="0">
-                        <a:buNone/>
-                      </a:pPr>
-                      <a:r>
-                        <a:rPr lang="en-US" sz="1150" dirty="0">
-                          <a:solidFill>
-                            <a:srgbClr val="141821"/>
-                          </a:solidFill>
-                          <a:latin typeface="Calibri" pitchFamily="34" charset="0"/>
-                          <a:ea typeface="Calibri" pitchFamily="34" charset="-122"/>
-                          <a:cs typeface="Calibri" pitchFamily="34" charset="-120"/>
-                        </a:rPr>
-                        <a:t>AWS Mumbai</a:t>
-                      </a:r>
-                      <a:endParaRPr lang="en-US" sz="1150" dirty="0">
-                        <a:latin typeface="Calibri" charset="0"/>
-                        <a:ea typeface="Calibri" charset="0"/>
-                        <a:cs typeface="Calibri" charset="0"/>
-                      </a:endParaRPr>
-                    </a:p>
-                  </a:txBody>
-                  <a:tcPr marL="91440" marR="91440" marT="45720" marB="45720" anchor="ctr">
-                    <a:lnL w="6350" cap="flat" cmpd="sng" algn="ctr">
-                      <a:solidFill>
-                        <a:srgbClr val="D8DEE4"/>
-                      </a:solidFill>
-                      <a:prstDash val="solid"/>
-                      <a:round/>
-                      <a:headEnd type="none" w="med" len="med"/>
-                      <a:tailEnd type="none" w="med" len="med"/>
-                    </a:lnL>
-                    <a:lnR w="6350" cap="flat" cmpd="sng" algn="ctr">
-                      <a:solidFill>
-                        <a:srgbClr val="D8DEE4"/>
-                      </a:solidFill>
-                      <a:prstDash val="solid"/>
-                      <a:round/>
-                      <a:headEnd type="none" w="med" len="med"/>
-                      <a:tailEnd type="none" w="med" len="med"/>
-                    </a:lnR>
-                    <a:lnT w="6350" cap="flat" cmpd="sng" algn="ctr">
-                      <a:solidFill>
-                        <a:srgbClr val="D8DEE4"/>
-                      </a:solidFill>
-                      <a:prstDash val="solid"/>
-                      <a:round/>
-                      <a:headEnd type="none" w="med" len="med"/>
-                      <a:tailEnd type="none" w="med" len="med"/>
-                    </a:lnT>
-                    <a:lnB w="6350" cap="flat" cmpd="sng" algn="ctr">
-                      <a:solidFill>
-                        <a:srgbClr val="D8DEE4"/>
-                      </a:solidFill>
-                      <a:prstDash val="solid"/>
-                      <a:round/>
-                      <a:headEnd type="none" w="med" len="med"/>
-                      <a:tailEnd type="none" w="med" len="med"/>
-                    </a:lnB>
-                    <a:solidFill>
-                      <a:srgbClr val="F2F7F5"/>
-                    </a:solidFill>
-                  </a:tcPr>
-                </a:tc>
-                <a:tc>
-                  <a:txBody>
-                    <a:bodyPr/>
-                    <a:lstStyle/>
-                    <a:p>
-                      <a:pPr indent="0" marL="0">
-                        <a:buNone/>
-                      </a:pPr>
-                      <a:r>
-                        <a:rPr lang="en-US" sz="1150" dirty="0">
-                          <a:solidFill>
-                            <a:srgbClr val="141821"/>
-                          </a:solidFill>
-                          <a:latin typeface="Calibri" pitchFamily="34" charset="0"/>
-                          <a:ea typeface="Calibri" pitchFamily="34" charset="-122"/>
-                          <a:cs typeface="Calibri" pitchFamily="34" charset="-120"/>
-                        </a:rPr>
-                        <a:t>KYC data stays in India (DPDP)</a:t>
-                      </a:r>
-                      <a:endParaRPr lang="en-US" sz="1150" dirty="0">
-                        <a:latin typeface="Calibri" charset="0"/>
-                        <a:ea typeface="Calibri" charset="0"/>
-                        <a:cs typeface="Calibri" charset="0"/>
-                      </a:endParaRPr>
-                    </a:p>
-                  </a:txBody>
-                  <a:tcPr marL="91440" marR="91440" marT="45720" marB="45720" anchor="ctr">
-                    <a:lnL w="6350" cap="flat" cmpd="sng" algn="ctr">
-                      <a:solidFill>
-                        <a:srgbClr val="D8DEE4"/>
-                      </a:solidFill>
-                      <a:prstDash val="solid"/>
-                      <a:round/>
-                      <a:headEnd type="none" w="med" len="med"/>
-                      <a:tailEnd type="none" w="med" len="med"/>
-                    </a:lnL>
-                    <a:lnR w="6350" cap="flat" cmpd="sng" algn="ctr">
-                      <a:solidFill>
-                        <a:srgbClr val="D8DEE4"/>
-                      </a:solidFill>
-                      <a:prstDash val="solid"/>
-                      <a:round/>
-                      <a:headEnd type="none" w="med" len="med"/>
-                      <a:tailEnd type="none" w="med" len="med"/>
-                    </a:lnR>
-                    <a:lnT w="6350" cap="flat" cmpd="sng" algn="ctr">
-                      <a:solidFill>
-                        <a:srgbClr val="D8DEE4"/>
-                      </a:solidFill>
-                      <a:prstDash val="solid"/>
-                      <a:round/>
-                      <a:headEnd type="none" w="med" len="med"/>
-                      <a:tailEnd type="none" w="med" len="med"/>
-                    </a:lnT>
-                    <a:lnB w="6350" cap="flat" cmpd="sng" algn="ctr">
-                      <a:solidFill>
-                        <a:srgbClr val="D8DEE4"/>
-                      </a:solidFill>
-                      <a:prstDash val="solid"/>
-                      <a:round/>
-                      <a:headEnd type="none" w="med" len="med"/>
-                      <a:tailEnd type="none" w="med" len="med"/>
-                    </a:lnB>
-                    <a:solidFill>
-                      <a:srgbClr val="F2F7F5"/>
-                    </a:solidFill>
-                  </a:tcPr>
-                </a:tc>
-              </a:tr>
-              <a:tr h="384048">
-                <a:tc>
-                  <a:txBody>
-                    <a:bodyPr/>
-                    <a:lstStyle/>
-                    <a:p>
-                      <a:pPr indent="0" marL="0">
-                        <a:buNone/>
-                      </a:pPr>
-                      <a:r>
-                        <a:rPr lang="en-US" sz="1150" dirty="0">
-                          <a:solidFill>
-                            <a:srgbClr val="141821"/>
-                          </a:solidFill>
-                          <a:latin typeface="Calibri" pitchFamily="34" charset="0"/>
-                          <a:ea typeface="Calibri" pitchFamily="34" charset="-122"/>
-                          <a:cs typeface="Calibri" pitchFamily="34" charset="-120"/>
-                        </a:rPr>
-                        <a:t>Payments</a:t>
-                      </a:r>
-                      <a:endParaRPr lang="en-US" sz="1150" dirty="0">
-                        <a:latin typeface="Calibri" charset="0"/>
-                        <a:ea typeface="Calibri" charset="0"/>
-                        <a:cs typeface="Calibri" charset="0"/>
-                      </a:endParaRPr>
-                    </a:p>
-                  </a:txBody>
-                  <a:tcPr marL="91440" marR="91440" marT="45720" marB="45720" anchor="ctr">
-                    <a:lnL w="6350" cap="flat" cmpd="sng" algn="ctr">
-                      <a:solidFill>
-                        <a:srgbClr val="D8DEE4"/>
-                      </a:solidFill>
-                      <a:prstDash val="solid"/>
-                      <a:round/>
-                      <a:headEnd type="none" w="med" len="med"/>
-                      <a:tailEnd type="none" w="med" len="med"/>
-                    </a:lnL>
-                    <a:lnR w="6350" cap="flat" cmpd="sng" algn="ctr">
-                      <a:solidFill>
-                        <a:srgbClr val="D8DEE4"/>
-                      </a:solidFill>
-                      <a:prstDash val="solid"/>
-                      <a:round/>
-                      <a:headEnd type="none" w="med" len="med"/>
-                      <a:tailEnd type="none" w="med" len="med"/>
-                    </a:lnR>
-                    <a:lnT w="6350" cap="flat" cmpd="sng" algn="ctr">
-                      <a:solidFill>
-                        <a:srgbClr val="D8DEE4"/>
-                      </a:solidFill>
-                      <a:prstDash val="solid"/>
-                      <a:round/>
-                      <a:headEnd type="none" w="med" len="med"/>
-                      <a:tailEnd type="none" w="med" len="med"/>
-                    </a:lnT>
-                    <a:lnB w="6350" cap="flat" cmpd="sng" algn="ctr">
-                      <a:solidFill>
-                        <a:srgbClr val="D8DEE4"/>
-                      </a:solidFill>
-                      <a:prstDash val="solid"/>
-                      <a:round/>
-                      <a:headEnd type="none" w="med" len="med"/>
-                      <a:tailEnd type="none" w="med" len="med"/>
-                    </a:lnB>
-                    <a:solidFill>
-                      <a:srgbClr val="FFFFFF"/>
-                    </a:solidFill>
-                  </a:tcPr>
-                </a:tc>
-                <a:tc>
-                  <a:txBody>
-                    <a:bodyPr/>
-                    <a:lstStyle/>
-                    <a:p>
-                      <a:pPr indent="0" marL="0">
-                        <a:buNone/>
-                      </a:pPr>
-                      <a:r>
-                        <a:rPr lang="en-US" sz="1150" dirty="0">
-                          <a:solidFill>
-                            <a:srgbClr val="141821"/>
-                          </a:solidFill>
-                          <a:latin typeface="Calibri" pitchFamily="34" charset="0"/>
-                          <a:ea typeface="Calibri" pitchFamily="34" charset="-122"/>
-                          <a:cs typeface="Calibri" pitchFamily="34" charset="-120"/>
-                        </a:rPr>
-                        <a:t>Razorpay (UPI-first)</a:t>
-                      </a:r>
-                      <a:endParaRPr lang="en-US" sz="1150" dirty="0">
-                        <a:latin typeface="Calibri" charset="0"/>
-                        <a:ea typeface="Calibri" charset="0"/>
-                        <a:cs typeface="Calibri" charset="0"/>
-                      </a:endParaRPr>
-                    </a:p>
-                  </a:txBody>
-                  <a:tcPr marL="91440" marR="91440" marT="45720" marB="45720" anchor="ctr">
-                    <a:lnL w="6350" cap="flat" cmpd="sng" algn="ctr">
-                      <a:solidFill>
-                        <a:srgbClr val="D8DEE4"/>
-                      </a:solidFill>
-                      <a:prstDash val="solid"/>
-                      <a:round/>
-                      <a:headEnd type="none" w="med" len="med"/>
-                      <a:tailEnd type="none" w="med" len="med"/>
-                    </a:lnL>
-                    <a:lnR w="6350" cap="flat" cmpd="sng" algn="ctr">
-                      <a:solidFill>
-                        <a:srgbClr val="D8DEE4"/>
-                      </a:solidFill>
-                      <a:prstDash val="solid"/>
-                      <a:round/>
-                      <a:headEnd type="none" w="med" len="med"/>
-                      <a:tailEnd type="none" w="med" len="med"/>
-                    </a:lnR>
-                    <a:lnT w="6350" cap="flat" cmpd="sng" algn="ctr">
-                      <a:solidFill>
-                        <a:srgbClr val="D8DEE4"/>
-                      </a:solidFill>
-                      <a:prstDash val="solid"/>
-                      <a:round/>
-                      <a:headEnd type="none" w="med" len="med"/>
-                      <a:tailEnd type="none" w="med" len="med"/>
-                    </a:lnT>
-                    <a:lnB w="6350" cap="flat" cmpd="sng" algn="ctr">
-                      <a:solidFill>
-                        <a:srgbClr val="D8DEE4"/>
-                      </a:solidFill>
-                      <a:prstDash val="solid"/>
-                      <a:round/>
-                      <a:headEnd type="none" w="med" len="med"/>
-                      <a:tailEnd type="none" w="med" len="med"/>
-                    </a:lnB>
-                    <a:solidFill>
-                      <a:srgbClr val="FFFFFF"/>
-                    </a:solidFill>
-                  </a:tcPr>
-                </a:tc>
-                <a:tc>
-                  <a:txBody>
-                    <a:bodyPr/>
-                    <a:lstStyle/>
-                    <a:p>
-                      <a:pPr indent="0" marL="0">
-                        <a:buNone/>
-                      </a:pPr>
-                      <a:r>
-                        <a:rPr lang="en-US" sz="1150" dirty="0">
-                          <a:solidFill>
-                            <a:srgbClr val="141821"/>
-                          </a:solidFill>
-                          <a:latin typeface="Calibri" pitchFamily="34" charset="0"/>
-                          <a:ea typeface="Calibri" pitchFamily="34" charset="-122"/>
-                          <a:cs typeface="Calibri" pitchFamily="34" charset="-120"/>
-                        </a:rPr>
-                        <a:t>UPI at 0% MDR by RBI mandate</a:t>
-                      </a:r>
-                      <a:endParaRPr lang="en-US" sz="1150" dirty="0">
-                        <a:latin typeface="Calibri" charset="0"/>
-                        <a:ea typeface="Calibri" charset="0"/>
-                        <a:cs typeface="Calibri" charset="0"/>
-                      </a:endParaRPr>
-                    </a:p>
-                  </a:txBody>
-                  <a:tcPr marL="91440" marR="91440" marT="45720" marB="45720" anchor="ctr">
-                    <a:lnL w="6350" cap="flat" cmpd="sng" algn="ctr">
-                      <a:solidFill>
-                        <a:srgbClr val="D8DEE4"/>
-                      </a:solidFill>
-                      <a:prstDash val="solid"/>
-                      <a:round/>
-                      <a:headEnd type="none" w="med" len="med"/>
-                      <a:tailEnd type="none" w="med" len="med"/>
-                    </a:lnL>
-                    <a:lnR w="6350" cap="flat" cmpd="sng" algn="ctr">
-                      <a:solidFill>
-                        <a:srgbClr val="D8DEE4"/>
-                      </a:solidFill>
-                      <a:prstDash val="solid"/>
-                      <a:round/>
-                      <a:headEnd type="none" w="med" len="med"/>
-                      <a:tailEnd type="none" w="med" len="med"/>
-                    </a:lnR>
-                    <a:lnT w="6350" cap="flat" cmpd="sng" algn="ctr">
-                      <a:solidFill>
-                        <a:srgbClr val="D8DEE4"/>
-                      </a:solidFill>
-                      <a:prstDash val="solid"/>
-                      <a:round/>
-                      <a:headEnd type="none" w="med" len="med"/>
-                      <a:tailEnd type="none" w="med" len="med"/>
-                    </a:lnT>
-                    <a:lnB w="6350" cap="flat" cmpd="sng" algn="ctr">
-                      <a:solidFill>
-                        <a:srgbClr val="D8DEE4"/>
-                      </a:solidFill>
-                      <a:prstDash val="solid"/>
-                      <a:round/>
-                      <a:headEnd type="none" w="med" len="med"/>
-                      <a:tailEnd type="none" w="med" len="med"/>
-                    </a:lnB>
-                    <a:solidFill>
-                      <a:srgbClr val="FFFFFF"/>
-                    </a:solidFill>
-                  </a:tcPr>
-                </a:tc>
-              </a:tr>
-              <a:tr h="384048">
-                <a:tc>
-                  <a:txBody>
-                    <a:bodyPr/>
-                    <a:lstStyle/>
-                    <a:p>
-                      <a:pPr indent="0" marL="0">
-                        <a:buNone/>
-                      </a:pPr>
-                      <a:r>
-                        <a:rPr lang="en-US" sz="1150" dirty="0">
-                          <a:solidFill>
-                            <a:srgbClr val="141821"/>
-                          </a:solidFill>
-                          <a:latin typeface="Calibri" pitchFamily="34" charset="0"/>
-                          <a:ea typeface="Calibri" pitchFamily="34" charset="-122"/>
-                          <a:cs typeface="Calibri" pitchFamily="34" charset="-120"/>
-                        </a:rPr>
-                        <a:t>Trust APIs</a:t>
-                      </a:r>
-                      <a:endParaRPr lang="en-US" sz="1150" dirty="0">
-                        <a:latin typeface="Calibri" charset="0"/>
-                        <a:ea typeface="Calibri" charset="0"/>
-                        <a:cs typeface="Calibri" charset="0"/>
-                      </a:endParaRPr>
-                    </a:p>
-                  </a:txBody>
-                  <a:tcPr marL="91440" marR="91440" marT="45720" marB="45720" anchor="ctr">
-                    <a:lnL w="6350" cap="flat" cmpd="sng" algn="ctr">
-                      <a:solidFill>
-                        <a:srgbClr val="D8DEE4"/>
-                      </a:solidFill>
-                      <a:prstDash val="solid"/>
-                      <a:round/>
-                      <a:headEnd type="none" w="med" len="med"/>
-                      <a:tailEnd type="none" w="med" len="med"/>
-                    </a:lnL>
-                    <a:lnR w="6350" cap="flat" cmpd="sng" algn="ctr">
-                      <a:solidFill>
-                        <a:srgbClr val="D8DEE4"/>
-                      </a:solidFill>
-                      <a:prstDash val="solid"/>
-                      <a:round/>
-                      <a:headEnd type="none" w="med" len="med"/>
-                      <a:tailEnd type="none" w="med" len="med"/>
-                    </a:lnR>
-                    <a:lnT w="6350" cap="flat" cmpd="sng" algn="ctr">
-                      <a:solidFill>
-                        <a:srgbClr val="D8DEE4"/>
-                      </a:solidFill>
-                      <a:prstDash val="solid"/>
-                      <a:round/>
-                      <a:headEnd type="none" w="med" len="med"/>
-                      <a:tailEnd type="none" w="med" len="med"/>
-                    </a:lnT>
-                    <a:lnB w="6350" cap="flat" cmpd="sng" algn="ctr">
-                      <a:solidFill>
-                        <a:srgbClr val="D8DEE4"/>
-                      </a:solidFill>
-                      <a:prstDash val="solid"/>
-                      <a:round/>
-                      <a:headEnd type="none" w="med" len="med"/>
-                      <a:tailEnd type="none" w="med" len="med"/>
-                    </a:lnB>
-                    <a:solidFill>
-                      <a:srgbClr val="F2F7F5"/>
-                    </a:solidFill>
-                  </a:tcPr>
-                </a:tc>
-                <a:tc>
-                  <a:txBody>
-                    <a:bodyPr/>
-                    <a:lstStyle/>
-                    <a:p>
-                      <a:pPr indent="0" marL="0">
-                        <a:buNone/>
-                      </a:pPr>
-                      <a:r>
-                        <a:rPr lang="en-US" sz="1150" dirty="0">
-                          <a:solidFill>
-                            <a:srgbClr val="141821"/>
-                          </a:solidFill>
-                          <a:latin typeface="Calibri" pitchFamily="34" charset="0"/>
-                          <a:ea typeface="Calibri" pitchFamily="34" charset="-122"/>
-                          <a:cs typeface="Calibri" pitchFamily="34" charset="-120"/>
-                        </a:rPr>
-                        <a:t>PAN ₹1–3 · Aadhaar offline/DigiLocker · Exotel masking</a:t>
-                      </a:r>
-                      <a:endParaRPr lang="en-US" sz="1150" dirty="0">
-                        <a:latin typeface="Calibri" charset="0"/>
-                        <a:ea typeface="Calibri" charset="0"/>
-                        <a:cs typeface="Calibri" charset="0"/>
-                      </a:endParaRPr>
-                    </a:p>
-                  </a:txBody>
-                  <a:tcPr marL="91440" marR="91440" marT="45720" marB="45720" anchor="ctr">
-                    <a:lnL w="6350" cap="flat" cmpd="sng" algn="ctr">
-                      <a:solidFill>
-                        <a:srgbClr val="D8DEE4"/>
-                      </a:solidFill>
-                      <a:prstDash val="solid"/>
-                      <a:round/>
-                      <a:headEnd type="none" w="med" len="med"/>
-                      <a:tailEnd type="none" w="med" len="med"/>
-                    </a:lnL>
-                    <a:lnR w="6350" cap="flat" cmpd="sng" algn="ctr">
-                      <a:solidFill>
-                        <a:srgbClr val="D8DEE4"/>
-                      </a:solidFill>
-                      <a:prstDash val="solid"/>
-                      <a:round/>
-                      <a:headEnd type="none" w="med" len="med"/>
-                      <a:tailEnd type="none" w="med" len="med"/>
-                    </a:lnR>
-                    <a:lnT w="6350" cap="flat" cmpd="sng" algn="ctr">
-                      <a:solidFill>
-                        <a:srgbClr val="D8DEE4"/>
-                      </a:solidFill>
-                      <a:prstDash val="solid"/>
-                      <a:round/>
-                      <a:headEnd type="none" w="med" len="med"/>
-                      <a:tailEnd type="none" w="med" len="med"/>
-                    </a:lnT>
-                    <a:lnB w="6350" cap="flat" cmpd="sng" algn="ctr">
-                      <a:solidFill>
-                        <a:srgbClr val="D8DEE4"/>
-                      </a:solidFill>
-                      <a:prstDash val="solid"/>
-                      <a:round/>
-                      <a:headEnd type="none" w="med" len="med"/>
-                      <a:tailEnd type="none" w="med" len="med"/>
-                    </a:lnB>
-                    <a:solidFill>
-                      <a:srgbClr val="F2F7F5"/>
-                    </a:solidFill>
-                  </a:tcPr>
-                </a:tc>
-                <a:tc>
-                  <a:txBody>
-                    <a:bodyPr/>
-                    <a:lstStyle/>
-                    <a:p>
-                      <a:pPr indent="0" marL="0">
-                        <a:buNone/>
-                      </a:pPr>
-                      <a:r>
-                        <a:rPr lang="en-US" sz="1150" dirty="0">
-                          <a:solidFill>
-                            <a:srgbClr val="141821"/>
-                          </a:solidFill>
-                          <a:latin typeface="Calibri" pitchFamily="34" charset="0"/>
-                          <a:ea typeface="Calibri" pitchFamily="34" charset="-122"/>
-                          <a:cs typeface="Calibri" pitchFamily="34" charset="-120"/>
-                        </a:rPr>
-                        <a:t>The legal Aadhaar route — no direct eKYC</a:t>
-                      </a:r>
-                      <a:endParaRPr lang="en-US" sz="1150" dirty="0">
-                        <a:latin typeface="Calibri" charset="0"/>
-                        <a:ea typeface="Calibri" charset="0"/>
-                        <a:cs typeface="Calibri" charset="0"/>
-                      </a:endParaRPr>
-                    </a:p>
-                  </a:txBody>
-                  <a:tcPr marL="91440" marR="91440" marT="45720" marB="45720" anchor="ctr">
-                    <a:lnL w="6350" cap="flat" cmpd="sng" algn="ctr">
-                      <a:solidFill>
-                        <a:srgbClr val="D8DEE4"/>
-                      </a:solidFill>
-                      <a:prstDash val="solid"/>
-                      <a:round/>
-                      <a:headEnd type="none" w="med" len="med"/>
-                      <a:tailEnd type="none" w="med" len="med"/>
-                    </a:lnL>
-                    <a:lnR w="6350" cap="flat" cmpd="sng" algn="ctr">
-                      <a:solidFill>
-                        <a:srgbClr val="D8DEE4"/>
-                      </a:solidFill>
-                      <a:prstDash val="solid"/>
-                      <a:round/>
-                      <a:headEnd type="none" w="med" len="med"/>
-                      <a:tailEnd type="none" w="med" len="med"/>
-                    </a:lnR>
-                    <a:lnT w="6350" cap="flat" cmpd="sng" algn="ctr">
-                      <a:solidFill>
-                        <a:srgbClr val="D8DEE4"/>
-                      </a:solidFill>
-                      <a:prstDash val="solid"/>
-                      <a:round/>
-                      <a:headEnd type="none" w="med" len="med"/>
-                      <a:tailEnd type="none" w="med" len="med"/>
-                    </a:lnT>
-                    <a:lnB w="6350" cap="flat" cmpd="sng" algn="ctr">
-                      <a:solidFill>
-                        <a:srgbClr val="D8DEE4"/>
-                      </a:solidFill>
-                      <a:prstDash val="solid"/>
-                      <a:round/>
-                      <a:headEnd type="none" w="med" len="med"/>
-                      <a:tailEnd type="none" w="med" len="med"/>
-                    </a:lnB>
-                    <a:solidFill>
-                      <a:srgbClr val="F2F7F5"/>
-                    </a:solidFill>
-                  </a:tcPr>
-                </a:tc>
-              </a:tr>
-            </a:tbl>
-          </a:graphicData>
-        </a:graphic>
-      </p:graphicFrame>
-      <p:sp>
-        <p:nvSpPr>
-          <p:cNvPr id="5" name="Text 2"/>
-          <p:cNvSpPr/>
-          <p:nvPr/>
-        </p:nvSpPr>
-        <p:spPr>
-          <a:xfrm>
-            <a:off x="640080" y="5989320"/>
-            <a:ext cx="10972800" cy="502920"/>
-          </a:xfrm>
-          <a:prstGeom prst="rect">
-            <a:avLst/>
-          </a:prstGeom>
-          <a:noFill/>
-          <a:ln/>
-        </p:spPr>
-        <p:txBody>
-          <a:bodyPr wrap="square" rtlCol="0" anchor="ctr"/>
-          <a:lstStyle/>
-          <a:p>
-            <a:pPr indent="0" marL="0">
-              <a:buNone/>
-            </a:pPr>
-            <a:r>
-              <a:rPr lang="en-US" sz="1300" b="1" dirty="0">
-                <a:solidFill>
-                  <a:srgbClr val="0A4A3E"/>
-                </a:solidFill>
-                <a:latin typeface="Calibri" pitchFamily="34" charset="0"/>
-                <a:ea typeface="Calibri" pitchFamily="34" charset="-122"/>
-                <a:cs typeface="Calibri" pitchFamily="34" charset="-120"/>
-              </a:rPr>
-              <a:t>12-month build budget: ₹68L lean · ₹1.14 Cr base · ₹1.78 Cr comfortable — team of 5–6 + fractional roles, one-city MVP in 4 months.</a:t>
-            </a:r>
-            <a:endParaRPr lang="en-US" sz="1300" dirty="0"/>
           </a:p>
         </p:txBody>
       </p:sp>

</xml_diff>

<commit_message>
feat: add Trust pipeline slide; fix slide-partname collision on remove+add
python-pptx's slide-partname generator (_next_slide_partname) is a naive
len(sldIdLst)+1 counter with no uniqueness check. Removing the old combined
stack+budget slide from inside add_stack_slide (before later slides were
added) let a subsequent add_blank_slide reuse an already-used partname,
silently duplicating ppt/slides/slide12.xml and dropping the Stack slide's
content on save. Now the old slide is retired once, after all new slides
for this build are added.
</commit_message>
<xml_diff>
--- a/docs/PropWeb_Pitch_v2.pptx
+++ b/docs/PropWeb_Pitch_v2.pptx
@@ -16,6 +16,7 @@
     <p:sldId id="265" r:id="rId16"/>
     <p:sldId id="266" r:id="rId17"/>
     <p:sldId id="267" r:id="rId18"/>
+    <p:sldId id="268" r:id="rId19"/>
   </p:sldIdLst>
   <p:notesMasterIdLst>
     <p:notesMasterId r:id="rId11"/>
@@ -738,6 +739,76 @@
           <a:p>
             <a:r>
               <a:t>Don't read the table row by row — the room doesn't need to know what Typesense is. The only two numbers worth saying out loud are the Algolia cost comparison and the AWS Mumbai/DPDP compliance line, because those are the ones a CEO will actually remember and repeat to an investor.</a:t>
+            </a:r>
+          </a:p>
+        </p:txBody>
+      </p:sp>
+      <p:sp>
+        <p:nvSpPr>
+          <p:cNvPr id="4" name="Slide Number Placeholder 3"/>
+          <p:cNvSpPr>
+            <a:spLocks noGrp="1"/>
+          </p:cNvSpPr>
+          <p:nvPr>
+            <p:ph type="sldNum" idx="5" sz="quarter"/>
+          </p:nvPr>
+        </p:nvSpPr>
+        <p:spPr/>
+      </p:sp>
+    </p:spTree>
+  </p:cSld>
+  <p:clrMapOvr>
+    <a:masterClrMapping/>
+  </p:clrMapOvr>
+</p:notes>
+</file>
+
+<file path=ppt/notesSlides/notesSlide13.xml><?xml version="1.0" encoding="utf-8"?>
+<p:notes xmlns:a="http://schemas.openxmlformats.org/drawingml/2006/main" xmlns:p="http://schemas.openxmlformats.org/presentationml/2006/main" xmlns:r="http://schemas.openxmlformats.org/officeDocument/2006/relationships">
+  <p:cSld>
+    <p:spTree>
+      <p:nvGrpSpPr>
+        <p:cNvPr id="1" name=""/>
+        <p:cNvGrpSpPr/>
+        <p:nvPr/>
+      </p:nvGrpSpPr>
+      <p:grpSpPr>
+        <a:xfrm>
+          <a:off x="0" y="0"/>
+          <a:ext cx="0" cy="0"/>
+          <a:chOff x="0" y="0"/>
+          <a:chExt cx="0" cy="0"/>
+        </a:xfrm>
+      </p:grpSpPr>
+      <p:sp>
+        <p:nvSpPr>
+          <p:cNvPr id="2" name="Slide Image Placeholder 1"/>
+          <p:cNvSpPr>
+            <a:spLocks noGrp="1"/>
+          </p:cNvSpPr>
+          <p:nvPr>
+            <p:ph type="sldImg" idx="2"/>
+          </p:nvPr>
+        </p:nvSpPr>
+        <p:spPr/>
+      </p:sp>
+      <p:sp>
+        <p:nvSpPr>
+          <p:cNvPr id="3" name="Notes Placeholder 2"/>
+          <p:cNvSpPr>
+            <a:spLocks noGrp="1"/>
+          </p:cNvSpPr>
+          <p:nvPr>
+            <p:ph type="body" idx="3" sz="quarter"/>
+          </p:nvPr>
+        </p:nvSpPr>
+        <p:spPr/>
+        <p:txBody>
+          <a:bodyPr/>
+          <a:lstStyle/>
+          <a:p>
+            <a:r>
+              <a:t>This is the slide to slow down on — say the Puttaswamy line exactly as written on the box, word for word, because it's the one legal fact that must not be garbled on stage. If asked "so we can't use Aadhaar at all," the answer is we can, just not by calling the eKYC API directly — offline XML, DigiLocker, and licensed partners are all legal and all in this pipeline.</a:t>
             </a:r>
           </a:p>
         </p:txBody>
@@ -3932,6 +4003,902 @@
 </p:sld>
 </file>
 
+<file path=ppt/slides/slide13.xml><?xml version="1.0" encoding="utf-8"?>
+<p:sld xmlns:a="http://schemas.openxmlformats.org/drawingml/2006/main" xmlns:p="http://schemas.openxmlformats.org/presentationml/2006/main" xmlns:r="http://schemas.openxmlformats.org/officeDocument/2006/relationships">
+  <p:cSld>
+    <p:bg>
+      <p:bgPr>
+        <a:solidFill>
+          <a:srgbClr val="FFFFFF"/>
+        </a:solidFill>
+        <a:effectLst/>
+      </p:bgPr>
+    </p:bg>
+    <p:spTree>
+      <p:nvGrpSpPr>
+        <p:cNvPr id="1" name=""/>
+        <p:cNvGrpSpPr/>
+        <p:nvPr/>
+      </p:nvGrpSpPr>
+      <p:grpSpPr/>
+      <p:sp>
+        <p:nvSpPr>
+          <p:cNvPr id="2" name="TextBox 1"/>
+          <p:cNvSpPr txBox="1"/>
+          <p:nvPr/>
+        </p:nvSpPr>
+        <p:spPr>
+          <a:xfrm>
+            <a:off x="640080" y="502920"/>
+            <a:ext cx="7315200" cy="320040"/>
+          </a:xfrm>
+          <a:prstGeom prst="rect">
+            <a:avLst/>
+          </a:prstGeom>
+          <a:noFill/>
+        </p:spPr>
+        <p:txBody>
+          <a:bodyPr wrap="square" anchor="ctr">
+            <a:spAutoFit/>
+          </a:bodyPr>
+          <a:lstStyle/>
+          <a:p>
+            <a:pPr algn="l"/>
+            <a:r>
+              <a:rPr sz="1200" b="1" spc="300">
+                <a:solidFill>
+                  <a:srgbClr val="0E6E5C"/>
+                </a:solidFill>
+                <a:latin typeface="Calibri"/>
+              </a:rPr>
+              <a:t>THE TRUST PIPELINE</a:t>
+            </a:r>
+          </a:p>
+        </p:txBody>
+      </p:sp>
+      <p:sp>
+        <p:nvSpPr>
+          <p:cNvPr id="3" name="TextBox 2"/>
+          <p:cNvSpPr txBox="1"/>
+          <p:nvPr/>
+        </p:nvSpPr>
+        <p:spPr>
+          <a:xfrm>
+            <a:off x="640080" y="868680"/>
+            <a:ext cx="10881360" cy="777240"/>
+          </a:xfrm>
+          <a:prstGeom prst="rect">
+            <a:avLst/>
+          </a:prstGeom>
+          <a:noFill/>
+        </p:spPr>
+        <p:txBody>
+          <a:bodyPr wrap="square" anchor="ctr">
+            <a:spAutoFit/>
+          </a:bodyPr>
+          <a:lstStyle/>
+          <a:p>
+            <a:pPr algn="l"/>
+            <a:r>
+              <a:rPr sz="3000" b="1">
+                <a:solidFill>
+                  <a:srgbClr val="141821"/>
+                </a:solidFill>
+                <a:latin typeface="Calibri"/>
+              </a:rPr>
+              <a:t>Verification, the legal way.</a:t>
+            </a:r>
+          </a:p>
+        </p:txBody>
+      </p:sp>
+      <p:sp>
+        <p:nvSpPr>
+          <p:cNvPr id="4" name="Rounded Rectangle 3"/>
+          <p:cNvSpPr/>
+          <p:nvPr/>
+        </p:nvSpPr>
+        <p:spPr>
+          <a:xfrm>
+            <a:off x="640080" y="2103120"/>
+            <a:ext cx="2556510" cy="2827656"/>
+          </a:xfrm>
+          <a:prstGeom prst="roundRect">
+            <a:avLst>
+              <a:gd name="adj" fmla="val 6061"/>
+            </a:avLst>
+          </a:prstGeom>
+          <a:solidFill>
+            <a:srgbClr val="F2F7F5"/>
+          </a:solidFill>
+          <a:ln w="9525">
+            <a:solidFill>
+              <a:srgbClr val="D8DEE4"/>
+            </a:solidFill>
+          </a:ln>
+          <a:effectLst/>
+        </p:spPr>
+        <p:style>
+          <a:lnRef idx="1">
+            <a:schemeClr val="accent1"/>
+          </a:lnRef>
+          <a:fillRef idx="3">
+            <a:schemeClr val="accent1"/>
+          </a:fillRef>
+          <a:effectRef idx="2">
+            <a:schemeClr val="accent1"/>
+          </a:effectRef>
+          <a:fontRef idx="minor">
+            <a:schemeClr val="lt1"/>
+          </a:fontRef>
+        </p:style>
+        <p:txBody>
+          <a:bodyPr rtlCol="0" anchor="ctr"/>
+          <a:lstStyle/>
+          <a:p>
+            <a:pPr algn="ctr"/>
+          </a:p>
+        </p:txBody>
+      </p:sp>
+      <p:sp>
+        <p:nvSpPr>
+          <p:cNvPr id="5" name="TextBox 4"/>
+          <p:cNvSpPr txBox="1"/>
+          <p:nvPr/>
+        </p:nvSpPr>
+        <p:spPr>
+          <a:xfrm>
+            <a:off x="868680" y="2331720"/>
+            <a:ext cx="2099310" cy="320040"/>
+          </a:xfrm>
+          <a:prstGeom prst="rect">
+            <a:avLst/>
+          </a:prstGeom>
+          <a:noFill/>
+        </p:spPr>
+        <p:txBody>
+          <a:bodyPr wrap="square" anchor="ctr">
+            <a:spAutoFit/>
+          </a:bodyPr>
+          <a:lstStyle/>
+          <a:p>
+            <a:pPr algn="l"/>
+            <a:r>
+              <a:rPr sz="1200" b="1" spc="200">
+                <a:solidFill>
+                  <a:srgbClr val="0E6E5C"/>
+                </a:solidFill>
+                <a:latin typeface="Calibri"/>
+              </a:rPr>
+              <a:t>01 · IDENTITY</a:t>
+            </a:r>
+          </a:p>
+        </p:txBody>
+      </p:sp>
+      <p:sp>
+        <p:nvSpPr>
+          <p:cNvPr id="6" name="TextBox 5"/>
+          <p:cNvSpPr txBox="1"/>
+          <p:nvPr/>
+        </p:nvSpPr>
+        <p:spPr>
+          <a:xfrm>
+            <a:off x="868680" y="2743200"/>
+            <a:ext cx="2099310" cy="548640"/>
+          </a:xfrm>
+          <a:prstGeom prst="rect">
+            <a:avLst/>
+          </a:prstGeom>
+          <a:noFill/>
+        </p:spPr>
+        <p:txBody>
+          <a:bodyPr wrap="square" anchor="t">
+            <a:spAutoFit/>
+          </a:bodyPr>
+          <a:lstStyle/>
+          <a:p>
+            <a:pPr algn="l"/>
+            <a:r>
+              <a:rPr sz="1500" b="1">
+                <a:solidFill>
+                  <a:srgbClr val="141821"/>
+                </a:solidFill>
+                <a:latin typeface="Calibri"/>
+              </a:rPr>
+              <a:t>Aadhaar offline XML / DigiLocker</a:t>
+            </a:r>
+          </a:p>
+        </p:txBody>
+      </p:sp>
+      <p:sp>
+        <p:nvSpPr>
+          <p:cNvPr id="7" name="TextBox 6"/>
+          <p:cNvSpPr txBox="1"/>
+          <p:nvPr/>
+        </p:nvSpPr>
+        <p:spPr>
+          <a:xfrm>
+            <a:off x="868680" y="3383280"/>
+            <a:ext cx="2099310" cy="1318896"/>
+          </a:xfrm>
+          <a:prstGeom prst="rect">
+            <a:avLst/>
+          </a:prstGeom>
+          <a:noFill/>
+        </p:spPr>
+        <p:txBody>
+          <a:bodyPr wrap="square" anchor="t">
+            <a:spAutoFit/>
+          </a:bodyPr>
+          <a:lstStyle/>
+          <a:p>
+            <a:pPr algn="l"/>
+            <a:r>
+              <a:rPr sz="1200" b="0">
+                <a:solidFill>
+                  <a:srgbClr val="5A6270"/>
+                </a:solidFill>
+                <a:latin typeface="Calibri"/>
+              </a:rPr>
+              <a:t>Identity proof through the legal offline route — no direct Aadhaar eKYC call.</a:t>
+            </a:r>
+          </a:p>
+        </p:txBody>
+      </p:sp>
+      <p:sp>
+        <p:nvSpPr>
+          <p:cNvPr id="8" name="TextBox 7"/>
+          <p:cNvSpPr txBox="1"/>
+          <p:nvPr/>
+        </p:nvSpPr>
+        <p:spPr>
+          <a:xfrm>
+            <a:off x="3196590" y="3316948"/>
+            <a:ext cx="228600" cy="400000"/>
+          </a:xfrm>
+          <a:prstGeom prst="rect">
+            <a:avLst/>
+          </a:prstGeom>
+          <a:noFill/>
+        </p:spPr>
+        <p:txBody>
+          <a:bodyPr wrap="square" anchor="ctr">
+            <a:spAutoFit/>
+          </a:bodyPr>
+          <a:lstStyle/>
+          <a:p>
+            <a:pPr algn="ctr"/>
+            <a:r>
+              <a:rPr sz="2000" b="1">
+                <a:solidFill>
+                  <a:srgbClr val="0E6E5C"/>
+                </a:solidFill>
+                <a:latin typeface="Calibri"/>
+              </a:rPr>
+              <a:t>→</a:t>
+            </a:r>
+          </a:p>
+        </p:txBody>
+      </p:sp>
+      <p:sp>
+        <p:nvSpPr>
+          <p:cNvPr id="9" name="Rounded Rectangle 8"/>
+          <p:cNvSpPr/>
+          <p:nvPr/>
+        </p:nvSpPr>
+        <p:spPr>
+          <a:xfrm>
+            <a:off x="3425190" y="2103120"/>
+            <a:ext cx="2556510" cy="2827656"/>
+          </a:xfrm>
+          <a:prstGeom prst="roundRect">
+            <a:avLst>
+              <a:gd name="adj" fmla="val 6061"/>
+            </a:avLst>
+          </a:prstGeom>
+          <a:solidFill>
+            <a:srgbClr val="F2F7F5"/>
+          </a:solidFill>
+          <a:ln w="9525">
+            <a:solidFill>
+              <a:srgbClr val="D8DEE4"/>
+            </a:solidFill>
+          </a:ln>
+          <a:effectLst/>
+        </p:spPr>
+        <p:style>
+          <a:lnRef idx="1">
+            <a:schemeClr val="accent1"/>
+          </a:lnRef>
+          <a:fillRef idx="3">
+            <a:schemeClr val="accent1"/>
+          </a:fillRef>
+          <a:effectRef idx="2">
+            <a:schemeClr val="accent1"/>
+          </a:effectRef>
+          <a:fontRef idx="minor">
+            <a:schemeClr val="lt1"/>
+          </a:fontRef>
+        </p:style>
+        <p:txBody>
+          <a:bodyPr rtlCol="0" anchor="ctr"/>
+          <a:lstStyle/>
+          <a:p>
+            <a:pPr algn="ctr"/>
+          </a:p>
+        </p:txBody>
+      </p:sp>
+      <p:sp>
+        <p:nvSpPr>
+          <p:cNvPr id="10" name="TextBox 9"/>
+          <p:cNvSpPr txBox="1"/>
+          <p:nvPr/>
+        </p:nvSpPr>
+        <p:spPr>
+          <a:xfrm>
+            <a:off x="3653790" y="2331720"/>
+            <a:ext cx="2099310" cy="320040"/>
+          </a:xfrm>
+          <a:prstGeom prst="rect">
+            <a:avLst/>
+          </a:prstGeom>
+          <a:noFill/>
+        </p:spPr>
+        <p:txBody>
+          <a:bodyPr wrap="square" anchor="ctr">
+            <a:spAutoFit/>
+          </a:bodyPr>
+          <a:lstStyle/>
+          <a:p>
+            <a:pPr algn="l"/>
+            <a:r>
+              <a:rPr sz="1200" b="1" spc="200">
+                <a:solidFill>
+                  <a:srgbClr val="0E6E5C"/>
+                </a:solidFill>
+                <a:latin typeface="Calibri"/>
+              </a:rPr>
+              <a:t>02 · PAN CHECK</a:t>
+            </a:r>
+          </a:p>
+        </p:txBody>
+      </p:sp>
+      <p:sp>
+        <p:nvSpPr>
+          <p:cNvPr id="11" name="TextBox 10"/>
+          <p:cNvSpPr txBox="1"/>
+          <p:nvPr/>
+        </p:nvSpPr>
+        <p:spPr>
+          <a:xfrm>
+            <a:off x="3653790" y="2743200"/>
+            <a:ext cx="2099310" cy="548640"/>
+          </a:xfrm>
+          <a:prstGeom prst="rect">
+            <a:avLst/>
+          </a:prstGeom>
+          <a:noFill/>
+        </p:spPr>
+        <p:txBody>
+          <a:bodyPr wrap="square" anchor="t">
+            <a:spAutoFit/>
+          </a:bodyPr>
+          <a:lstStyle/>
+          <a:p>
+            <a:pPr algn="l"/>
+            <a:r>
+              <a:rPr sz="1500" b="1">
+                <a:solidFill>
+                  <a:srgbClr val="141821"/>
+                </a:solidFill>
+                <a:latin typeface="Calibri"/>
+              </a:rPr>
+              <a:t>PAN verification API</a:t>
+            </a:r>
+          </a:p>
+        </p:txBody>
+      </p:sp>
+      <p:sp>
+        <p:nvSpPr>
+          <p:cNvPr id="12" name="TextBox 11"/>
+          <p:cNvSpPr txBox="1"/>
+          <p:nvPr/>
+        </p:nvSpPr>
+        <p:spPr>
+          <a:xfrm>
+            <a:off x="3653790" y="3383280"/>
+            <a:ext cx="2099310" cy="1318896"/>
+          </a:xfrm>
+          <a:prstGeom prst="rect">
+            <a:avLst/>
+          </a:prstGeom>
+          <a:noFill/>
+        </p:spPr>
+        <p:txBody>
+          <a:bodyPr wrap="square" anchor="t">
+            <a:spAutoFit/>
+          </a:bodyPr>
+          <a:lstStyle/>
+          <a:p>
+            <a:pPr algn="l"/>
+            <a:r>
+              <a:rPr sz="1200" b="0">
+                <a:solidFill>
+                  <a:srgbClr val="5A6270"/>
+                </a:solidFill>
+                <a:latin typeface="Calibri"/>
+              </a:rPr>
+              <a:t>₹1–3 per check via a licensed KYC API partner.</a:t>
+            </a:r>
+          </a:p>
+        </p:txBody>
+      </p:sp>
+      <p:sp>
+        <p:nvSpPr>
+          <p:cNvPr id="13" name="TextBox 12"/>
+          <p:cNvSpPr txBox="1"/>
+          <p:nvPr/>
+        </p:nvSpPr>
+        <p:spPr>
+          <a:xfrm>
+            <a:off x="5981700" y="3316948"/>
+            <a:ext cx="228600" cy="400000"/>
+          </a:xfrm>
+          <a:prstGeom prst="rect">
+            <a:avLst/>
+          </a:prstGeom>
+          <a:noFill/>
+        </p:spPr>
+        <p:txBody>
+          <a:bodyPr wrap="square" anchor="ctr">
+            <a:spAutoFit/>
+          </a:bodyPr>
+          <a:lstStyle/>
+          <a:p>
+            <a:pPr algn="ctr"/>
+            <a:r>
+              <a:rPr sz="2000" b="1">
+                <a:solidFill>
+                  <a:srgbClr val="0E6E5C"/>
+                </a:solidFill>
+                <a:latin typeface="Calibri"/>
+              </a:rPr>
+              <a:t>→</a:t>
+            </a:r>
+          </a:p>
+        </p:txBody>
+      </p:sp>
+      <p:sp>
+        <p:nvSpPr>
+          <p:cNvPr id="14" name="Rounded Rectangle 13"/>
+          <p:cNvSpPr/>
+          <p:nvPr/>
+        </p:nvSpPr>
+        <p:spPr>
+          <a:xfrm>
+            <a:off x="6210300" y="2103120"/>
+            <a:ext cx="2556510" cy="2827656"/>
+          </a:xfrm>
+          <a:prstGeom prst="roundRect">
+            <a:avLst>
+              <a:gd name="adj" fmla="val 6061"/>
+            </a:avLst>
+          </a:prstGeom>
+          <a:solidFill>
+            <a:srgbClr val="F2F7F5"/>
+          </a:solidFill>
+          <a:ln w="9525">
+            <a:solidFill>
+              <a:srgbClr val="D8DEE4"/>
+            </a:solidFill>
+          </a:ln>
+          <a:effectLst/>
+        </p:spPr>
+        <p:style>
+          <a:lnRef idx="1">
+            <a:schemeClr val="accent1"/>
+          </a:lnRef>
+          <a:fillRef idx="3">
+            <a:schemeClr val="accent1"/>
+          </a:fillRef>
+          <a:effectRef idx="2">
+            <a:schemeClr val="accent1"/>
+          </a:effectRef>
+          <a:fontRef idx="minor">
+            <a:schemeClr val="lt1"/>
+          </a:fontRef>
+        </p:style>
+        <p:txBody>
+          <a:bodyPr rtlCol="0" anchor="ctr"/>
+          <a:lstStyle/>
+          <a:p>
+            <a:pPr algn="ctr"/>
+          </a:p>
+        </p:txBody>
+      </p:sp>
+      <p:sp>
+        <p:nvSpPr>
+          <p:cNvPr id="15" name="TextBox 14"/>
+          <p:cNvSpPr txBox="1"/>
+          <p:nvPr/>
+        </p:nvSpPr>
+        <p:spPr>
+          <a:xfrm>
+            <a:off x="6438900" y="2331720"/>
+            <a:ext cx="2099310" cy="320040"/>
+          </a:xfrm>
+          <a:prstGeom prst="rect">
+            <a:avLst/>
+          </a:prstGeom>
+          <a:noFill/>
+        </p:spPr>
+        <p:txBody>
+          <a:bodyPr wrap="square" anchor="ctr">
+            <a:spAutoFit/>
+          </a:bodyPr>
+          <a:lstStyle/>
+          <a:p>
+            <a:pPr algn="l"/>
+            <a:r>
+              <a:rPr sz="1200" b="1" spc="200">
+                <a:solidFill>
+                  <a:srgbClr val="0E6E5C"/>
+                </a:solidFill>
+                <a:latin typeface="Calibri"/>
+              </a:rPr>
+              <a:t>03 · OWNERSHIP</a:t>
+            </a:r>
+          </a:p>
+        </p:txBody>
+      </p:sp>
+      <p:sp>
+        <p:nvSpPr>
+          <p:cNvPr id="16" name="TextBox 15"/>
+          <p:cNvSpPr txBox="1"/>
+          <p:nvPr/>
+        </p:nvSpPr>
+        <p:spPr>
+          <a:xfrm>
+            <a:off x="6438900" y="2743200"/>
+            <a:ext cx="2099310" cy="548640"/>
+          </a:xfrm>
+          <a:prstGeom prst="rect">
+            <a:avLst/>
+          </a:prstGeom>
+          <a:noFill/>
+        </p:spPr>
+        <p:txBody>
+          <a:bodyPr wrap="square" anchor="t">
+            <a:spAutoFit/>
+          </a:bodyPr>
+          <a:lstStyle/>
+          <a:p>
+            <a:pPr algn="l"/>
+            <a:r>
+              <a:rPr sz="1500" b="1">
+                <a:solidFill>
+                  <a:srgbClr val="141821"/>
+                </a:solidFill>
+                <a:latin typeface="Calibri"/>
+              </a:rPr>
+              <a:t>Ownership-proof review</a:t>
+            </a:r>
+          </a:p>
+        </p:txBody>
+      </p:sp>
+      <p:sp>
+        <p:nvSpPr>
+          <p:cNvPr id="17" name="TextBox 16"/>
+          <p:cNvSpPr txBox="1"/>
+          <p:nvPr/>
+        </p:nvSpPr>
+        <p:spPr>
+          <a:xfrm>
+            <a:off x="6438900" y="3383280"/>
+            <a:ext cx="2099310" cy="1318896"/>
+          </a:xfrm>
+          <a:prstGeom prst="rect">
+            <a:avLst/>
+          </a:prstGeom>
+          <a:noFill/>
+        </p:spPr>
+        <p:txBody>
+          <a:bodyPr wrap="square" anchor="t">
+            <a:spAutoFit/>
+          </a:bodyPr>
+          <a:lstStyle/>
+          <a:p>
+            <a:pPr algn="l"/>
+            <a:r>
+              <a:rPr sz="1200" b="0">
+                <a:solidFill>
+                  <a:srgbClr val="5A6270"/>
+                </a:solidFill>
+                <a:latin typeface="Calibri"/>
+              </a:rPr>
+              <a:t>Property tax receipt, electricity bill or sale deed — manual review.</a:t>
+            </a:r>
+          </a:p>
+        </p:txBody>
+      </p:sp>
+      <p:sp>
+        <p:nvSpPr>
+          <p:cNvPr id="18" name="TextBox 17"/>
+          <p:cNvSpPr txBox="1"/>
+          <p:nvPr/>
+        </p:nvSpPr>
+        <p:spPr>
+          <a:xfrm>
+            <a:off x="8766810" y="3316948"/>
+            <a:ext cx="228600" cy="400000"/>
+          </a:xfrm>
+          <a:prstGeom prst="rect">
+            <a:avLst/>
+          </a:prstGeom>
+          <a:noFill/>
+        </p:spPr>
+        <p:txBody>
+          <a:bodyPr wrap="square" anchor="ctr">
+            <a:spAutoFit/>
+          </a:bodyPr>
+          <a:lstStyle/>
+          <a:p>
+            <a:pPr algn="ctr"/>
+            <a:r>
+              <a:rPr sz="2000" b="1">
+                <a:solidFill>
+                  <a:srgbClr val="0E6E5C"/>
+                </a:solidFill>
+                <a:latin typeface="Calibri"/>
+              </a:rPr>
+              <a:t>→</a:t>
+            </a:r>
+          </a:p>
+        </p:txBody>
+      </p:sp>
+      <p:sp>
+        <p:nvSpPr>
+          <p:cNvPr id="19" name="Rounded Rectangle 18"/>
+          <p:cNvSpPr/>
+          <p:nvPr/>
+        </p:nvSpPr>
+        <p:spPr>
+          <a:xfrm>
+            <a:off x="8995410" y="2103120"/>
+            <a:ext cx="2556510" cy="2827656"/>
+          </a:xfrm>
+          <a:prstGeom prst="roundRect">
+            <a:avLst>
+              <a:gd name="adj" fmla="val 6061"/>
+            </a:avLst>
+          </a:prstGeom>
+          <a:solidFill>
+            <a:srgbClr val="F2F7F5"/>
+          </a:solidFill>
+          <a:ln w="9525">
+            <a:solidFill>
+              <a:srgbClr val="D8DEE4"/>
+            </a:solidFill>
+          </a:ln>
+          <a:effectLst/>
+        </p:spPr>
+        <p:style>
+          <a:lnRef idx="1">
+            <a:schemeClr val="accent1"/>
+          </a:lnRef>
+          <a:fillRef idx="3">
+            <a:schemeClr val="accent1"/>
+          </a:fillRef>
+          <a:effectRef idx="2">
+            <a:schemeClr val="accent1"/>
+          </a:effectRef>
+          <a:fontRef idx="minor">
+            <a:schemeClr val="lt1"/>
+          </a:fontRef>
+        </p:style>
+        <p:txBody>
+          <a:bodyPr rtlCol="0" anchor="ctr"/>
+          <a:lstStyle/>
+          <a:p>
+            <a:pPr algn="ctr"/>
+          </a:p>
+        </p:txBody>
+      </p:sp>
+      <p:sp>
+        <p:nvSpPr>
+          <p:cNvPr id="20" name="TextBox 19"/>
+          <p:cNvSpPr txBox="1"/>
+          <p:nvPr/>
+        </p:nvSpPr>
+        <p:spPr>
+          <a:xfrm>
+            <a:off x="9224010" y="2331720"/>
+            <a:ext cx="2099310" cy="320040"/>
+          </a:xfrm>
+          <a:prstGeom prst="rect">
+            <a:avLst/>
+          </a:prstGeom>
+          <a:noFill/>
+        </p:spPr>
+        <p:txBody>
+          <a:bodyPr wrap="square" anchor="ctr">
+            <a:spAutoFit/>
+          </a:bodyPr>
+          <a:lstStyle/>
+          <a:p>
+            <a:pPr algn="l"/>
+            <a:r>
+              <a:rPr sz="1200" b="1" spc="200">
+                <a:solidFill>
+                  <a:srgbClr val="0E6E5C"/>
+                </a:solidFill>
+                <a:latin typeface="Calibri"/>
+              </a:rPr>
+              <a:t>04 · BADGE</a:t>
+            </a:r>
+          </a:p>
+        </p:txBody>
+      </p:sp>
+      <p:sp>
+        <p:nvSpPr>
+          <p:cNvPr id="21" name="TextBox 20"/>
+          <p:cNvSpPr txBox="1"/>
+          <p:nvPr/>
+        </p:nvSpPr>
+        <p:spPr>
+          <a:xfrm>
+            <a:off x="9224010" y="2743200"/>
+            <a:ext cx="2099310" cy="548640"/>
+          </a:xfrm>
+          <a:prstGeom prst="rect">
+            <a:avLst/>
+          </a:prstGeom>
+          <a:noFill/>
+        </p:spPr>
+        <p:txBody>
+          <a:bodyPr wrap="square" anchor="t">
+            <a:spAutoFit/>
+          </a:bodyPr>
+          <a:lstStyle/>
+          <a:p>
+            <a:pPr algn="l"/>
+            <a:r>
+              <a:rPr sz="1500" b="1">
+                <a:solidFill>
+                  <a:srgbClr val="141821"/>
+                </a:solidFill>
+                <a:latin typeface="Calibri"/>
+              </a:rPr>
+              <a:t>Badge issued</a:t>
+            </a:r>
+          </a:p>
+        </p:txBody>
+      </p:sp>
+      <p:sp>
+        <p:nvSpPr>
+          <p:cNvPr id="22" name="TextBox 21"/>
+          <p:cNvSpPr txBox="1"/>
+          <p:nvPr/>
+        </p:nvSpPr>
+        <p:spPr>
+          <a:xfrm>
+            <a:off x="9224010" y="3383280"/>
+            <a:ext cx="2099310" cy="1318896"/>
+          </a:xfrm>
+          <a:prstGeom prst="rect">
+            <a:avLst/>
+          </a:prstGeom>
+          <a:noFill/>
+        </p:spPr>
+        <p:txBody>
+          <a:bodyPr wrap="square" anchor="t">
+            <a:spAutoFit/>
+          </a:bodyPr>
+          <a:lstStyle/>
+          <a:p>
+            <a:pPr algn="l"/>
+            <a:r>
+              <a:rPr sz="1200" b="0">
+                <a:solidFill>
+                  <a:srgbClr val="5A6270"/>
+                </a:solidFill>
+                <a:latin typeface="Calibri"/>
+              </a:rPr>
+              <a:t>Verified Owner / Verified Tenant mark goes live on the profile and every listing.</a:t>
+            </a:r>
+          </a:p>
+        </p:txBody>
+      </p:sp>
+      <p:sp>
+        <p:nvSpPr>
+          <p:cNvPr id="23" name="Rounded Rectangle 22"/>
+          <p:cNvSpPr/>
+          <p:nvPr/>
+        </p:nvSpPr>
+        <p:spPr>
+          <a:xfrm>
+            <a:off x="640080" y="4892040"/>
+            <a:ext cx="10911840" cy="1280160"/>
+          </a:xfrm>
+          <a:prstGeom prst="roundRect">
+            <a:avLst>
+              <a:gd name="adj" fmla="val 1500"/>
+            </a:avLst>
+          </a:prstGeom>
+          <a:solidFill>
+            <a:srgbClr val="FFFFFF"/>
+          </a:solidFill>
+          <a:ln w="19050">
+            <a:solidFill>
+              <a:srgbClr val="E8A13D"/>
+            </a:solidFill>
+          </a:ln>
+          <a:effectLst/>
+        </p:spPr>
+        <p:style>
+          <a:lnRef idx="1">
+            <a:schemeClr val="accent1"/>
+          </a:lnRef>
+          <a:fillRef idx="3">
+            <a:schemeClr val="accent1"/>
+          </a:fillRef>
+          <a:effectRef idx="2">
+            <a:schemeClr val="accent1"/>
+          </a:effectRef>
+          <a:fontRef idx="minor">
+            <a:schemeClr val="lt1"/>
+          </a:fontRef>
+        </p:style>
+        <p:txBody>
+          <a:bodyPr rtlCol="0" anchor="ctr"/>
+          <a:lstStyle/>
+          <a:p>
+            <a:pPr algn="ctr"/>
+          </a:p>
+        </p:txBody>
+      </p:sp>
+      <p:sp>
+        <p:nvSpPr>
+          <p:cNvPr id="24" name="TextBox 23"/>
+          <p:cNvSpPr txBox="1"/>
+          <p:nvPr/>
+        </p:nvSpPr>
+        <p:spPr>
+          <a:xfrm>
+            <a:off x="868680" y="4938840"/>
+            <a:ext cx="10454640" cy="1188720"/>
+          </a:xfrm>
+          <a:prstGeom prst="rect">
+            <a:avLst/>
+          </a:prstGeom>
+          <a:noFill/>
+        </p:spPr>
+        <p:txBody>
+          <a:bodyPr wrap="square" anchor="ctr">
+            <a:spAutoFit/>
+          </a:bodyPr>
+          <a:lstStyle/>
+          <a:p>
+            <a:pPr algn="l"/>
+            <a:r>
+              <a:rPr sz="1300" b="0">
+                <a:solidFill>
+                  <a:srgbClr val="141821"/>
+                </a:solidFill>
+                <a:latin typeface="Calibri"/>
+              </a:rPr>
+              <a:t>The one legal fact that must not be gotten wrong on stage: private companies cannot call Aadhaar eKYC APIs directly (Supreme Court, Puttaswamy 2018). PropWeb verifies identity only through the legal routes — Aadhaar offline XML, DigiLocker, or a licensed KYC partner.</a:t>
+            </a:r>
+          </a:p>
+        </p:txBody>
+      </p:sp>
+    </p:spTree>
+  </p:cSld>
+  <p:clrMapOvr>
+    <a:masterClrMapping/>
+  </p:clrMapOvr>
+</p:sld>
+</file>
+
 <file path=ppt/slides/slide2.xml><?xml version="1.0" encoding="utf-8"?>
 <p:sld xmlns:a="http://schemas.openxmlformats.org/drawingml/2006/main" xmlns:r="http://schemas.openxmlformats.org/officeDocument/2006/relationships" xmlns:p="http://schemas.openxmlformats.org/presentationml/2006/main">
   <p:cSld name="Slide 2">

</xml_diff>

<commit_message>
feat: add Build phases roadmap slide
</commit_message>
<xml_diff>
--- a/docs/PropWeb_Pitch_v2.pptx
+++ b/docs/PropWeb_Pitch_v2.pptx
@@ -17,6 +17,7 @@
     <p:sldId id="266" r:id="rId17"/>
     <p:sldId id="267" r:id="rId18"/>
     <p:sldId id="268" r:id="rId19"/>
+    <p:sldId id="269" r:id="rId20"/>
   </p:sldIdLst>
   <p:notesMasterIdLst>
     <p:notesMasterId r:id="rId11"/>
@@ -809,6 +810,76 @@
           <a:p>
             <a:r>
               <a:t>This is the slide to slow down on — say the Puttaswamy line exactly as written on the box, word for word, because it's the one legal fact that must not be garbled on stage. If asked "so we can't use Aadhaar at all," the answer is we can, just not by calling the eKYC API directly — offline XML, DigiLocker, and licensed partners are all legal and all in this pipeline.</a:t>
+            </a:r>
+          </a:p>
+        </p:txBody>
+      </p:sp>
+      <p:sp>
+        <p:nvSpPr>
+          <p:cNvPr id="4" name="Slide Number Placeholder 3"/>
+          <p:cNvSpPr>
+            <a:spLocks noGrp="1"/>
+          </p:cNvSpPr>
+          <p:nvPr>
+            <p:ph type="sldNum" idx="5" sz="quarter"/>
+          </p:nvPr>
+        </p:nvSpPr>
+        <p:spPr/>
+      </p:sp>
+    </p:spTree>
+  </p:cSld>
+  <p:clrMapOvr>
+    <a:masterClrMapping/>
+  </p:clrMapOvr>
+</p:notes>
+</file>
+
+<file path=ppt/notesSlides/notesSlide14.xml><?xml version="1.0" encoding="utf-8"?>
+<p:notes xmlns:a="http://schemas.openxmlformats.org/drawingml/2006/main" xmlns:p="http://schemas.openxmlformats.org/presentationml/2006/main" xmlns:r="http://schemas.openxmlformats.org/officeDocument/2006/relationships">
+  <p:cSld>
+    <p:spTree>
+      <p:nvGrpSpPr>
+        <p:cNvPr id="1" name=""/>
+        <p:cNvGrpSpPr/>
+        <p:nvPr/>
+      </p:nvGrpSpPr>
+      <p:grpSpPr>
+        <a:xfrm>
+          <a:off x="0" y="0"/>
+          <a:ext cx="0" cy="0"/>
+          <a:chOff x="0" y="0"/>
+          <a:chExt cx="0" cy="0"/>
+        </a:xfrm>
+      </p:grpSpPr>
+      <p:sp>
+        <p:nvSpPr>
+          <p:cNvPr id="2" name="Slide Image Placeholder 1"/>
+          <p:cNvSpPr>
+            <a:spLocks noGrp="1"/>
+          </p:cNvSpPr>
+          <p:nvPr>
+            <p:ph type="sldImg" idx="2"/>
+          </p:nvPr>
+        </p:nvSpPr>
+        <p:spPr/>
+      </p:sp>
+      <p:sp>
+        <p:nvSpPr>
+          <p:cNvPr id="3" name="Notes Placeholder 2"/>
+          <p:cNvSpPr>
+            <a:spLocks noGrp="1"/>
+          </p:cNvSpPr>
+          <p:nvPr>
+            <p:ph type="body" idx="3" sz="quarter"/>
+          </p:nvPr>
+        </p:nvSpPr>
+        <p:spPr/>
+        <p:txBody>
+          <a:bodyPr/>
+          <a:lstStyle/>
+          <a:p>
+            <a:r>
+              <a:t>Anchor the room on the one-city, four-month MVP commitment — that's the number a CEO will hold you to, so say "4 months to a working one-city product" explicitly rather than letting the phase labels speak for themselves.</a:t>
             </a:r>
           </a:p>
         </p:txBody>
@@ -4899,6 +4970,819 @@
 </p:sld>
 </file>
 
+<file path=ppt/slides/slide14.xml><?xml version="1.0" encoding="utf-8"?>
+<p:sld xmlns:a="http://schemas.openxmlformats.org/drawingml/2006/main" xmlns:p="http://schemas.openxmlformats.org/presentationml/2006/main" xmlns:r="http://schemas.openxmlformats.org/officeDocument/2006/relationships">
+  <p:cSld>
+    <p:bg>
+      <p:bgPr>
+        <a:solidFill>
+          <a:srgbClr val="FFFFFF"/>
+        </a:solidFill>
+        <a:effectLst/>
+      </p:bgPr>
+    </p:bg>
+    <p:spTree>
+      <p:nvGrpSpPr>
+        <p:cNvPr id="1" name=""/>
+        <p:cNvGrpSpPr/>
+        <p:nvPr/>
+      </p:nvGrpSpPr>
+      <p:grpSpPr/>
+      <p:sp>
+        <p:nvSpPr>
+          <p:cNvPr id="2" name="TextBox 1"/>
+          <p:cNvSpPr txBox="1"/>
+          <p:nvPr/>
+        </p:nvSpPr>
+        <p:spPr>
+          <a:xfrm>
+            <a:off x="640080" y="502920"/>
+            <a:ext cx="7315200" cy="320040"/>
+          </a:xfrm>
+          <a:prstGeom prst="rect">
+            <a:avLst/>
+          </a:prstGeom>
+          <a:noFill/>
+        </p:spPr>
+        <p:txBody>
+          <a:bodyPr wrap="square" anchor="ctr">
+            <a:spAutoFit/>
+          </a:bodyPr>
+          <a:lstStyle/>
+          <a:p>
+            <a:pPr algn="l"/>
+            <a:r>
+              <a:rPr sz="1200" b="1" spc="300">
+                <a:solidFill>
+                  <a:srgbClr val="0E6E5C"/>
+                </a:solidFill>
+                <a:latin typeface="Calibri"/>
+              </a:rPr>
+              <a:t>ROADMAP</a:t>
+            </a:r>
+          </a:p>
+        </p:txBody>
+      </p:sp>
+      <p:sp>
+        <p:nvSpPr>
+          <p:cNvPr id="3" name="TextBox 2"/>
+          <p:cNvSpPr txBox="1"/>
+          <p:nvPr/>
+        </p:nvSpPr>
+        <p:spPr>
+          <a:xfrm>
+            <a:off x="640080" y="868680"/>
+            <a:ext cx="10881360" cy="777240"/>
+          </a:xfrm>
+          <a:prstGeom prst="rect">
+            <a:avLst/>
+          </a:prstGeom>
+          <a:noFill/>
+        </p:spPr>
+        <p:txBody>
+          <a:bodyPr wrap="square" anchor="ctr">
+            <a:spAutoFit/>
+          </a:bodyPr>
+          <a:lstStyle/>
+          <a:p>
+            <a:pPr algn="l"/>
+            <a:r>
+              <a:rPr sz="3000" b="1">
+                <a:solidFill>
+                  <a:srgbClr val="141821"/>
+                </a:solidFill>
+                <a:latin typeface="Calibri"/>
+              </a:rPr>
+              <a:t>Four phases, one city first.</a:t>
+            </a:r>
+          </a:p>
+        </p:txBody>
+      </p:sp>
+      <p:sp>
+        <p:nvSpPr>
+          <p:cNvPr id="4" name="Rounded Rectangle 3"/>
+          <p:cNvSpPr/>
+          <p:nvPr/>
+        </p:nvSpPr>
+        <p:spPr>
+          <a:xfrm>
+            <a:off x="640080" y="2103120"/>
+            <a:ext cx="2556510" cy="2827656"/>
+          </a:xfrm>
+          <a:prstGeom prst="roundRect">
+            <a:avLst>
+              <a:gd name="adj" fmla="val 6061"/>
+            </a:avLst>
+          </a:prstGeom>
+          <a:solidFill>
+            <a:srgbClr val="F2F7F5"/>
+          </a:solidFill>
+          <a:ln w="9525">
+            <a:solidFill>
+              <a:srgbClr val="D8DEE4"/>
+            </a:solidFill>
+          </a:ln>
+          <a:effectLst/>
+        </p:spPr>
+        <p:style>
+          <a:lnRef idx="1">
+            <a:schemeClr val="accent1"/>
+          </a:lnRef>
+          <a:fillRef idx="3">
+            <a:schemeClr val="accent1"/>
+          </a:fillRef>
+          <a:effectRef idx="2">
+            <a:schemeClr val="accent1"/>
+          </a:effectRef>
+          <a:fontRef idx="minor">
+            <a:schemeClr val="lt1"/>
+          </a:fontRef>
+        </p:style>
+        <p:txBody>
+          <a:bodyPr rtlCol="0" anchor="ctr"/>
+          <a:lstStyle/>
+          <a:p>
+            <a:pPr algn="ctr"/>
+          </a:p>
+        </p:txBody>
+      </p:sp>
+      <p:sp>
+        <p:nvSpPr>
+          <p:cNvPr id="5" name="TextBox 4"/>
+          <p:cNvSpPr txBox="1"/>
+          <p:nvPr/>
+        </p:nvSpPr>
+        <p:spPr>
+          <a:xfrm>
+            <a:off x="868680" y="2331720"/>
+            <a:ext cx="2099310" cy="320040"/>
+          </a:xfrm>
+          <a:prstGeom prst="rect">
+            <a:avLst/>
+          </a:prstGeom>
+          <a:noFill/>
+        </p:spPr>
+        <p:txBody>
+          <a:bodyPr wrap="square" anchor="ctr">
+            <a:spAutoFit/>
+          </a:bodyPr>
+          <a:lstStyle/>
+          <a:p>
+            <a:pPr algn="l"/>
+            <a:r>
+              <a:rPr sz="1200" b="1" spc="200">
+                <a:solidFill>
+                  <a:srgbClr val="0E6E5C"/>
+                </a:solidFill>
+                <a:latin typeface="Calibri"/>
+              </a:rPr>
+              <a:t>PHASE 0 · weeks 0–4</a:t>
+            </a:r>
+          </a:p>
+        </p:txBody>
+      </p:sp>
+      <p:sp>
+        <p:nvSpPr>
+          <p:cNvPr id="6" name="TextBox 5"/>
+          <p:cNvSpPr txBox="1"/>
+          <p:nvPr/>
+        </p:nvSpPr>
+        <p:spPr>
+          <a:xfrm>
+            <a:off x="868680" y="2743200"/>
+            <a:ext cx="2099310" cy="548640"/>
+          </a:xfrm>
+          <a:prstGeom prst="rect">
+            <a:avLst/>
+          </a:prstGeom>
+          <a:noFill/>
+        </p:spPr>
+        <p:txBody>
+          <a:bodyPr wrap="square" anchor="t">
+            <a:spAutoFit/>
+          </a:bodyPr>
+          <a:lstStyle/>
+          <a:p>
+            <a:pPr algn="l"/>
+            <a:r>
+              <a:rPr sz="1500" b="1">
+                <a:solidFill>
+                  <a:srgbClr val="141821"/>
+                </a:solidFill>
+                <a:latin typeface="Calibri"/>
+              </a:rPr>
+              <a:t>Setup</a:t>
+            </a:r>
+          </a:p>
+        </p:txBody>
+      </p:sp>
+      <p:sp>
+        <p:nvSpPr>
+          <p:cNvPr id="7" name="TextBox 6"/>
+          <p:cNvSpPr txBox="1"/>
+          <p:nvPr/>
+        </p:nvSpPr>
+        <p:spPr>
+          <a:xfrm>
+            <a:off x="868680" y="3383280"/>
+            <a:ext cx="2099310" cy="1318896"/>
+          </a:xfrm>
+          <a:prstGeom prst="rect">
+            <a:avLst/>
+          </a:prstGeom>
+          <a:noFill/>
+        </p:spPr>
+        <p:txBody>
+          <a:bodyPr wrap="square" anchor="t">
+            <a:spAutoFit/>
+          </a:bodyPr>
+          <a:lstStyle/>
+          <a:p>
+            <a:pPr algn="l"/>
+            <a:r>
+              <a:rPr sz="1200" b="0">
+                <a:solidFill>
+                  <a:srgbClr val="5A6270"/>
+                </a:solidFill>
+                <a:latin typeface="Calibri"/>
+              </a:rPr>
+              <a:t>Team hiring starts, tooling and accounts provisioned, design system finalized.</a:t>
+            </a:r>
+          </a:p>
+        </p:txBody>
+      </p:sp>
+      <p:sp>
+        <p:nvSpPr>
+          <p:cNvPr id="8" name="TextBox 7"/>
+          <p:cNvSpPr txBox="1"/>
+          <p:nvPr/>
+        </p:nvSpPr>
+        <p:spPr>
+          <a:xfrm>
+            <a:off x="3196590" y="3316948"/>
+            <a:ext cx="228600" cy="400000"/>
+          </a:xfrm>
+          <a:prstGeom prst="rect">
+            <a:avLst/>
+          </a:prstGeom>
+          <a:noFill/>
+        </p:spPr>
+        <p:txBody>
+          <a:bodyPr wrap="square" anchor="ctr">
+            <a:spAutoFit/>
+          </a:bodyPr>
+          <a:lstStyle/>
+          <a:p>
+            <a:pPr algn="ctr"/>
+            <a:r>
+              <a:rPr sz="2000" b="1">
+                <a:solidFill>
+                  <a:srgbClr val="0E6E5C"/>
+                </a:solidFill>
+                <a:latin typeface="Calibri"/>
+              </a:rPr>
+              <a:t>→</a:t>
+            </a:r>
+          </a:p>
+        </p:txBody>
+      </p:sp>
+      <p:sp>
+        <p:nvSpPr>
+          <p:cNvPr id="9" name="Rounded Rectangle 8"/>
+          <p:cNvSpPr/>
+          <p:nvPr/>
+        </p:nvSpPr>
+        <p:spPr>
+          <a:xfrm>
+            <a:off x="3425190" y="2103120"/>
+            <a:ext cx="2556510" cy="2827656"/>
+          </a:xfrm>
+          <a:prstGeom prst="roundRect">
+            <a:avLst>
+              <a:gd name="adj" fmla="val 6061"/>
+            </a:avLst>
+          </a:prstGeom>
+          <a:solidFill>
+            <a:srgbClr val="F2F7F5"/>
+          </a:solidFill>
+          <a:ln w="9525">
+            <a:solidFill>
+              <a:srgbClr val="D8DEE4"/>
+            </a:solidFill>
+          </a:ln>
+          <a:effectLst/>
+        </p:spPr>
+        <p:style>
+          <a:lnRef idx="1">
+            <a:schemeClr val="accent1"/>
+          </a:lnRef>
+          <a:fillRef idx="3">
+            <a:schemeClr val="accent1"/>
+          </a:fillRef>
+          <a:effectRef idx="2">
+            <a:schemeClr val="accent1"/>
+          </a:effectRef>
+          <a:fontRef idx="minor">
+            <a:schemeClr val="lt1"/>
+          </a:fontRef>
+        </p:style>
+        <p:txBody>
+          <a:bodyPr rtlCol="0" anchor="ctr"/>
+          <a:lstStyle/>
+          <a:p>
+            <a:pPr algn="ctr"/>
+          </a:p>
+        </p:txBody>
+      </p:sp>
+      <p:sp>
+        <p:nvSpPr>
+          <p:cNvPr id="10" name="TextBox 9"/>
+          <p:cNvSpPr txBox="1"/>
+          <p:nvPr/>
+        </p:nvSpPr>
+        <p:spPr>
+          <a:xfrm>
+            <a:off x="3653790" y="2331720"/>
+            <a:ext cx="2099310" cy="320040"/>
+          </a:xfrm>
+          <a:prstGeom prst="rect">
+            <a:avLst/>
+          </a:prstGeom>
+          <a:noFill/>
+        </p:spPr>
+        <p:txBody>
+          <a:bodyPr wrap="square" anchor="ctr">
+            <a:spAutoFit/>
+          </a:bodyPr>
+          <a:lstStyle/>
+          <a:p>
+            <a:pPr algn="l"/>
+            <a:r>
+              <a:rPr sz="1200" b="1" spc="200">
+                <a:solidFill>
+                  <a:srgbClr val="0E6E5C"/>
+                </a:solidFill>
+                <a:latin typeface="Calibri"/>
+              </a:rPr>
+              <a:t>PHASE 1 · months 1–4</a:t>
+            </a:r>
+          </a:p>
+        </p:txBody>
+      </p:sp>
+      <p:sp>
+        <p:nvSpPr>
+          <p:cNvPr id="11" name="TextBox 10"/>
+          <p:cNvSpPr txBox="1"/>
+          <p:nvPr/>
+        </p:nvSpPr>
+        <p:spPr>
+          <a:xfrm>
+            <a:off x="3653790" y="2743200"/>
+            <a:ext cx="2099310" cy="548640"/>
+          </a:xfrm>
+          <a:prstGeom prst="rect">
+            <a:avLst/>
+          </a:prstGeom>
+          <a:noFill/>
+        </p:spPr>
+        <p:txBody>
+          <a:bodyPr wrap="square" anchor="t">
+            <a:spAutoFit/>
+          </a:bodyPr>
+          <a:lstStyle/>
+          <a:p>
+            <a:pPr algn="l"/>
+            <a:r>
+              <a:rPr sz="1500" b="1">
+                <a:solidFill>
+                  <a:srgbClr val="141821"/>
+                </a:solidFill>
+                <a:latin typeface="Calibri"/>
+              </a:rPr>
+              <a:t>MVP, one city</a:t>
+            </a:r>
+          </a:p>
+        </p:txBody>
+      </p:sp>
+      <p:sp>
+        <p:nvSpPr>
+          <p:cNvPr id="12" name="TextBox 11"/>
+          <p:cNvSpPr txBox="1"/>
+          <p:nvPr/>
+        </p:nvSpPr>
+        <p:spPr>
+          <a:xfrm>
+            <a:off x="3653790" y="3383280"/>
+            <a:ext cx="2099310" cy="1318896"/>
+          </a:xfrm>
+          <a:prstGeom prst="rect">
+            <a:avLst/>
+          </a:prstGeom>
+          <a:noFill/>
+        </p:spPr>
+        <p:txBody>
+          <a:bodyPr wrap="square" anchor="t">
+            <a:spAutoFit/>
+          </a:bodyPr>
+          <a:lstStyle/>
+          <a:p>
+            <a:pPr algn="l"/>
+            <a:r>
+              <a:rPr sz="1200" b="0">
+                <a:solidFill>
+                  <a:srgbClr val="5A6270"/>
+                </a:solidFill>
+                <a:latin typeface="Calibri"/>
+              </a:rPr>
+              <a:t>Bengaluru launch: search, listings, trust badges, pay-to-connect live.</a:t>
+            </a:r>
+          </a:p>
+        </p:txBody>
+      </p:sp>
+      <p:sp>
+        <p:nvSpPr>
+          <p:cNvPr id="13" name="TextBox 12"/>
+          <p:cNvSpPr txBox="1"/>
+          <p:nvPr/>
+        </p:nvSpPr>
+        <p:spPr>
+          <a:xfrm>
+            <a:off x="5981700" y="3316948"/>
+            <a:ext cx="228600" cy="400000"/>
+          </a:xfrm>
+          <a:prstGeom prst="rect">
+            <a:avLst/>
+          </a:prstGeom>
+          <a:noFill/>
+        </p:spPr>
+        <p:txBody>
+          <a:bodyPr wrap="square" anchor="ctr">
+            <a:spAutoFit/>
+          </a:bodyPr>
+          <a:lstStyle/>
+          <a:p>
+            <a:pPr algn="ctr"/>
+            <a:r>
+              <a:rPr sz="2000" b="1">
+                <a:solidFill>
+                  <a:srgbClr val="0E6E5C"/>
+                </a:solidFill>
+                <a:latin typeface="Calibri"/>
+              </a:rPr>
+              <a:t>→</a:t>
+            </a:r>
+          </a:p>
+        </p:txBody>
+      </p:sp>
+      <p:sp>
+        <p:nvSpPr>
+          <p:cNvPr id="14" name="Rounded Rectangle 13"/>
+          <p:cNvSpPr/>
+          <p:nvPr/>
+        </p:nvSpPr>
+        <p:spPr>
+          <a:xfrm>
+            <a:off x="6210300" y="2103120"/>
+            <a:ext cx="2556510" cy="2827656"/>
+          </a:xfrm>
+          <a:prstGeom prst="roundRect">
+            <a:avLst>
+              <a:gd name="adj" fmla="val 6061"/>
+            </a:avLst>
+          </a:prstGeom>
+          <a:solidFill>
+            <a:srgbClr val="F2F7F5"/>
+          </a:solidFill>
+          <a:ln w="9525">
+            <a:solidFill>
+              <a:srgbClr val="D8DEE4"/>
+            </a:solidFill>
+          </a:ln>
+          <a:effectLst/>
+        </p:spPr>
+        <p:style>
+          <a:lnRef idx="1">
+            <a:schemeClr val="accent1"/>
+          </a:lnRef>
+          <a:fillRef idx="3">
+            <a:schemeClr val="accent1"/>
+          </a:fillRef>
+          <a:effectRef idx="2">
+            <a:schemeClr val="accent1"/>
+          </a:effectRef>
+          <a:fontRef idx="minor">
+            <a:schemeClr val="lt1"/>
+          </a:fontRef>
+        </p:style>
+        <p:txBody>
+          <a:bodyPr rtlCol="0" anchor="ctr"/>
+          <a:lstStyle/>
+          <a:p>
+            <a:pPr algn="ctr"/>
+          </a:p>
+        </p:txBody>
+      </p:sp>
+      <p:sp>
+        <p:nvSpPr>
+          <p:cNvPr id="15" name="TextBox 14"/>
+          <p:cNvSpPr txBox="1"/>
+          <p:nvPr/>
+        </p:nvSpPr>
+        <p:spPr>
+          <a:xfrm>
+            <a:off x="6438900" y="2331720"/>
+            <a:ext cx="2099310" cy="320040"/>
+          </a:xfrm>
+          <a:prstGeom prst="rect">
+            <a:avLst/>
+          </a:prstGeom>
+          <a:noFill/>
+        </p:spPr>
+        <p:txBody>
+          <a:bodyPr wrap="square" anchor="ctr">
+            <a:spAutoFit/>
+          </a:bodyPr>
+          <a:lstStyle/>
+          <a:p>
+            <a:pPr algn="l"/>
+            <a:r>
+              <a:rPr sz="1200" b="1" spc="200">
+                <a:solidFill>
+                  <a:srgbClr val="0E6E5C"/>
+                </a:solidFill>
+                <a:latin typeface="Calibri"/>
+              </a:rPr>
+              <a:t>PHASE 2 · months 4–9</a:t>
+            </a:r>
+          </a:p>
+        </p:txBody>
+      </p:sp>
+      <p:sp>
+        <p:nvSpPr>
+          <p:cNvPr id="16" name="TextBox 15"/>
+          <p:cNvSpPr txBox="1"/>
+          <p:nvPr/>
+        </p:nvSpPr>
+        <p:spPr>
+          <a:xfrm>
+            <a:off x="6438900" y="2743200"/>
+            <a:ext cx="2099310" cy="548640"/>
+          </a:xfrm>
+          <a:prstGeom prst="rect">
+            <a:avLst/>
+          </a:prstGeom>
+          <a:noFill/>
+        </p:spPr>
+        <p:txBody>
+          <a:bodyPr wrap="square" anchor="t">
+            <a:spAutoFit/>
+          </a:bodyPr>
+          <a:lstStyle/>
+          <a:p>
+            <a:pPr algn="l"/>
+            <a:r>
+              <a:rPr sz="1500" b="1">
+                <a:solidFill>
+                  <a:srgbClr val="141821"/>
+                </a:solidFill>
+                <a:latin typeface="Calibri"/>
+              </a:rPr>
+              <a:t>Depth</a:t>
+            </a:r>
+          </a:p>
+        </p:txBody>
+      </p:sp>
+      <p:sp>
+        <p:nvSpPr>
+          <p:cNvPr id="17" name="TextBox 16"/>
+          <p:cNvSpPr txBox="1"/>
+          <p:nvPr/>
+        </p:nvSpPr>
+        <p:spPr>
+          <a:xfrm>
+            <a:off x="6438900" y="3383280"/>
+            <a:ext cx="2099310" cy="1318896"/>
+          </a:xfrm>
+          <a:prstGeom prst="rect">
+            <a:avLst/>
+          </a:prstGeom>
+          <a:noFill/>
+        </p:spPr>
+        <p:txBody>
+          <a:bodyPr wrap="square" anchor="t">
+            <a:spAutoFit/>
+          </a:bodyPr>
+          <a:lstStyle/>
+          <a:p>
+            <a:pPr algn="l"/>
+            <a:r>
+              <a:rPr sz="1200" b="0">
+                <a:solidFill>
+                  <a:srgbClr val="5A6270"/>
+                </a:solidFill>
+                <a:latin typeface="Calibri"/>
+              </a:rPr>
+              <a:t>AI Match Score, digital rent agreements, fraud/broker detection.</a:t>
+            </a:r>
+          </a:p>
+        </p:txBody>
+      </p:sp>
+      <p:sp>
+        <p:nvSpPr>
+          <p:cNvPr id="18" name="TextBox 17"/>
+          <p:cNvSpPr txBox="1"/>
+          <p:nvPr/>
+        </p:nvSpPr>
+        <p:spPr>
+          <a:xfrm>
+            <a:off x="8766810" y="3316948"/>
+            <a:ext cx="228600" cy="400000"/>
+          </a:xfrm>
+          <a:prstGeom prst="rect">
+            <a:avLst/>
+          </a:prstGeom>
+          <a:noFill/>
+        </p:spPr>
+        <p:txBody>
+          <a:bodyPr wrap="square" anchor="ctr">
+            <a:spAutoFit/>
+          </a:bodyPr>
+          <a:lstStyle/>
+          <a:p>
+            <a:pPr algn="ctr"/>
+            <a:r>
+              <a:rPr sz="2000" b="1">
+                <a:solidFill>
+                  <a:srgbClr val="0E6E5C"/>
+                </a:solidFill>
+                <a:latin typeface="Calibri"/>
+              </a:rPr>
+              <a:t>→</a:t>
+            </a:r>
+          </a:p>
+        </p:txBody>
+      </p:sp>
+      <p:sp>
+        <p:nvSpPr>
+          <p:cNvPr id="19" name="Rounded Rectangle 18"/>
+          <p:cNvSpPr/>
+          <p:nvPr/>
+        </p:nvSpPr>
+        <p:spPr>
+          <a:xfrm>
+            <a:off x="8995410" y="2103120"/>
+            <a:ext cx="2556510" cy="2827656"/>
+          </a:xfrm>
+          <a:prstGeom prst="roundRect">
+            <a:avLst>
+              <a:gd name="adj" fmla="val 6061"/>
+            </a:avLst>
+          </a:prstGeom>
+          <a:solidFill>
+            <a:srgbClr val="F2F7F5"/>
+          </a:solidFill>
+          <a:ln w="9525">
+            <a:solidFill>
+              <a:srgbClr val="D8DEE4"/>
+            </a:solidFill>
+          </a:ln>
+          <a:effectLst/>
+        </p:spPr>
+        <p:style>
+          <a:lnRef idx="1">
+            <a:schemeClr val="accent1"/>
+          </a:lnRef>
+          <a:fillRef idx="3">
+            <a:schemeClr val="accent1"/>
+          </a:fillRef>
+          <a:effectRef idx="2">
+            <a:schemeClr val="accent1"/>
+          </a:effectRef>
+          <a:fontRef idx="minor">
+            <a:schemeClr val="lt1"/>
+          </a:fontRef>
+        </p:style>
+        <p:txBody>
+          <a:bodyPr rtlCol="0" anchor="ctr"/>
+          <a:lstStyle/>
+          <a:p>
+            <a:pPr algn="ctr"/>
+          </a:p>
+        </p:txBody>
+      </p:sp>
+      <p:sp>
+        <p:nvSpPr>
+          <p:cNvPr id="20" name="TextBox 19"/>
+          <p:cNvSpPr txBox="1"/>
+          <p:nvPr/>
+        </p:nvSpPr>
+        <p:spPr>
+          <a:xfrm>
+            <a:off x="9224010" y="2331720"/>
+            <a:ext cx="2099310" cy="320040"/>
+          </a:xfrm>
+          <a:prstGeom prst="rect">
+            <a:avLst/>
+          </a:prstGeom>
+          <a:noFill/>
+        </p:spPr>
+        <p:txBody>
+          <a:bodyPr wrap="square" anchor="ctr">
+            <a:spAutoFit/>
+          </a:bodyPr>
+          <a:lstStyle/>
+          <a:p>
+            <a:pPr algn="l"/>
+            <a:r>
+              <a:rPr sz="1200" b="1" spc="200">
+                <a:solidFill>
+                  <a:srgbClr val="0E6E5C"/>
+                </a:solidFill>
+                <a:latin typeface="Calibri"/>
+              </a:rPr>
+              <a:t>PHASE 3 · months 9–15</a:t>
+            </a:r>
+          </a:p>
+        </p:txBody>
+      </p:sp>
+      <p:sp>
+        <p:nvSpPr>
+          <p:cNvPr id="21" name="TextBox 20"/>
+          <p:cNvSpPr txBox="1"/>
+          <p:nvPr/>
+        </p:nvSpPr>
+        <p:spPr>
+          <a:xfrm>
+            <a:off x="9224010" y="2743200"/>
+            <a:ext cx="2099310" cy="548640"/>
+          </a:xfrm>
+          <a:prstGeom prst="rect">
+            <a:avLst/>
+          </a:prstGeom>
+          <a:noFill/>
+        </p:spPr>
+        <p:txBody>
+          <a:bodyPr wrap="square" anchor="t">
+            <a:spAutoFit/>
+          </a:bodyPr>
+          <a:lstStyle/>
+          <a:p>
+            <a:pPr algn="l"/>
+            <a:r>
+              <a:rPr sz="1500" b="1">
+                <a:solidFill>
+                  <a:srgbClr val="141821"/>
+                </a:solidFill>
+                <a:latin typeface="Calibri"/>
+              </a:rPr>
+              <a:t>Services + multi-city</a:t>
+            </a:r>
+          </a:p>
+        </p:txBody>
+      </p:sp>
+      <p:sp>
+        <p:nvSpPr>
+          <p:cNvPr id="22" name="TextBox 21"/>
+          <p:cNvSpPr txBox="1"/>
+          <p:nvPr/>
+        </p:nvSpPr>
+        <p:spPr>
+          <a:xfrm>
+            <a:off x="9224010" y="3383280"/>
+            <a:ext cx="2099310" cy="1318896"/>
+          </a:xfrm>
+          <a:prstGeom prst="rect">
+            <a:avLst/>
+          </a:prstGeom>
+          <a:noFill/>
+        </p:spPr>
+        <p:txBody>
+          <a:bodyPr wrap="square" anchor="t">
+            <a:spAutoFit/>
+          </a:bodyPr>
+          <a:lstStyle/>
+          <a:p>
+            <a:pPr algn="l"/>
+            <a:r>
+              <a:rPr sz="1200" b="0">
+                <a:solidFill>
+                  <a:srgbClr val="5A6270"/>
+                </a:solidFill>
+                <a:latin typeface="Calibri"/>
+              </a:rPr>
+              <a:t>Affiliate services marketplace launches; expansion beyond Bengaluru.</a:t>
+            </a:r>
+          </a:p>
+        </p:txBody>
+      </p:sp>
+    </p:spTree>
+  </p:cSld>
+  <p:clrMapOvr>
+    <a:masterClrMapping/>
+  </p:clrMapOvr>
+</p:sld>
+</file>
+
 <file path=ppt/slides/slide2.xml><?xml version="1.0" encoding="utf-8"?>
 <p:sld xmlns:a="http://schemas.openxmlformats.org/drawingml/2006/main" xmlns:r="http://schemas.openxmlformats.org/officeDocument/2006/relationships" xmlns:p="http://schemas.openxmlformats.org/presentationml/2006/main">
   <p:cSld name="Slide 2">

</xml_diff>

<commit_message>
feat: add Team plan slide
Added Task 8 slide showing sequenced 12-month team hiring plan with salary
breakpoints (₹2.75L, ₹5.35L, ₹6.65L per month) and total payroll estimate
(₹55–65 lakh). Uses add_flow_steps to show hiring phases with explanatory
notes. Inserted before 'BUILT TO SCALE' removal to avoid partition corruption.

Co-Authored-By: Claude Sonnet 5 <noreply@anthropic.com>
</commit_message>
<xml_diff>
--- a/docs/PropWeb_Pitch_v2.pptx
+++ b/docs/PropWeb_Pitch_v2.pptx
@@ -18,6 +18,7 @@
     <p:sldId id="267" r:id="rId18"/>
     <p:sldId id="268" r:id="rId19"/>
     <p:sldId id="269" r:id="rId20"/>
+    <p:sldId id="270" r:id="rId21"/>
   </p:sldIdLst>
   <p:notesMasterIdLst>
     <p:notesMasterId r:id="rId11"/>
@@ -880,6 +881,76 @@
           <a:p>
             <a:r>
               <a:t>Anchor the room on the one-city, four-month MVP commitment — that's the number a CEO will hold you to, so say "4 months to a working one-city product" explicitly rather than letting the phase labels speak for themselves.</a:t>
+            </a:r>
+          </a:p>
+        </p:txBody>
+      </p:sp>
+      <p:sp>
+        <p:nvSpPr>
+          <p:cNvPr id="4" name="Slide Number Placeholder 3"/>
+          <p:cNvSpPr>
+            <a:spLocks noGrp="1"/>
+          </p:cNvSpPr>
+          <p:nvPr>
+            <p:ph type="sldNum" idx="5" sz="quarter"/>
+          </p:nvPr>
+        </p:nvSpPr>
+        <p:spPr/>
+      </p:sp>
+    </p:spTree>
+  </p:cSld>
+  <p:clrMapOvr>
+    <a:masterClrMapping/>
+  </p:clrMapOvr>
+</p:notes>
+</file>
+
+<file path=ppt/notesSlides/notesSlide15.xml><?xml version="1.0" encoding="utf-8"?>
+<p:notes xmlns:a="http://schemas.openxmlformats.org/drawingml/2006/main" xmlns:p="http://schemas.openxmlformats.org/presentationml/2006/main" xmlns:r="http://schemas.openxmlformats.org/officeDocument/2006/relationships">
+  <p:cSld>
+    <p:spTree>
+      <p:nvGrpSpPr>
+        <p:cNvPr id="1" name=""/>
+        <p:cNvGrpSpPr/>
+        <p:nvPr/>
+      </p:nvGrpSpPr>
+      <p:grpSpPr>
+        <a:xfrm>
+          <a:off x="0" y="0"/>
+          <a:ext cx="0" cy="0"/>
+          <a:chOff x="0" y="0"/>
+          <a:chExt cx="0" cy="0"/>
+        </a:xfrm>
+      </p:grpSpPr>
+      <p:sp>
+        <p:nvSpPr>
+          <p:cNvPr id="2" name="Slide Image Placeholder 1"/>
+          <p:cNvSpPr>
+            <a:spLocks noGrp="1"/>
+          </p:cNvSpPr>
+          <p:nvPr>
+            <p:ph type="sldImg" idx="2"/>
+          </p:nvPr>
+        </p:nvSpPr>
+        <p:spPr/>
+      </p:sp>
+      <p:sp>
+        <p:nvSpPr>
+          <p:cNvPr id="3" name="Notes Placeholder 2"/>
+          <p:cNvSpPr>
+            <a:spLocks noGrp="1"/>
+          </p:cNvSpPr>
+          <p:nvPr>
+            <p:ph type="body" idx="3" sz="quarter"/>
+          </p:nvPr>
+        </p:nvSpPr>
+        <p:spPr/>
+        <p:txBody>
+          <a:bodyPr/>
+          <a:lstStyle/>
+          <a:p>
+            <a:r>
+              <a:t>The headline is "small team, sequenced hiring" — resist the urge to justify each hire individually. If asked why the founding engineer comes before a designer, the honest answer is that the demo app already exists as proof the frontend/product work doesn't block on that hire yet.</a:t>
             </a:r>
           </a:p>
         </p:txBody>
@@ -5783,6 +5854,666 @@
 </p:sld>
 </file>
 
+<file path=ppt/slides/slide15.xml><?xml version="1.0" encoding="utf-8"?>
+<p:sld xmlns:a="http://schemas.openxmlformats.org/drawingml/2006/main" xmlns:p="http://schemas.openxmlformats.org/presentationml/2006/main" xmlns:r="http://schemas.openxmlformats.org/officeDocument/2006/relationships">
+  <p:cSld>
+    <p:bg>
+      <p:bgPr>
+        <a:solidFill>
+          <a:srgbClr val="FFFFFF"/>
+        </a:solidFill>
+        <a:effectLst/>
+      </p:bgPr>
+    </p:bg>
+    <p:spTree>
+      <p:nvGrpSpPr>
+        <p:cNvPr id="1" name=""/>
+        <p:cNvGrpSpPr/>
+        <p:nvPr/>
+      </p:nvGrpSpPr>
+      <p:grpSpPr/>
+      <p:sp>
+        <p:nvSpPr>
+          <p:cNvPr id="2" name="TextBox 1"/>
+          <p:cNvSpPr txBox="1"/>
+          <p:nvPr/>
+        </p:nvSpPr>
+        <p:spPr>
+          <a:xfrm>
+            <a:off x="640080" y="502920"/>
+            <a:ext cx="7315200" cy="320040"/>
+          </a:xfrm>
+          <a:prstGeom prst="rect">
+            <a:avLst/>
+          </a:prstGeom>
+          <a:noFill/>
+        </p:spPr>
+        <p:txBody>
+          <a:bodyPr wrap="square" anchor="ctr">
+            <a:spAutoFit/>
+          </a:bodyPr>
+          <a:lstStyle/>
+          <a:p>
+            <a:pPr algn="l"/>
+            <a:r>
+              <a:rPr sz="1200" b="1" spc="300">
+                <a:solidFill>
+                  <a:srgbClr val="0E6E5C"/>
+                </a:solidFill>
+                <a:latin typeface="Calibri"/>
+              </a:rPr>
+              <a:t>TEAM</a:t>
+            </a:r>
+          </a:p>
+        </p:txBody>
+      </p:sp>
+      <p:sp>
+        <p:nvSpPr>
+          <p:cNvPr id="3" name="TextBox 2"/>
+          <p:cNvSpPr txBox="1"/>
+          <p:nvPr/>
+        </p:nvSpPr>
+        <p:spPr>
+          <a:xfrm>
+            <a:off x="640080" y="868680"/>
+            <a:ext cx="10881360" cy="777240"/>
+          </a:xfrm>
+          <a:prstGeom prst="rect">
+            <a:avLst/>
+          </a:prstGeom>
+          <a:noFill/>
+        </p:spPr>
+        <p:txBody>
+          <a:bodyPr wrap="square" anchor="ctr">
+            <a:spAutoFit/>
+          </a:bodyPr>
+          <a:lstStyle/>
+          <a:p>
+            <a:pPr algn="l"/>
+            <a:r>
+              <a:rPr sz="3000" b="1">
+                <a:solidFill>
+                  <a:srgbClr val="141821"/>
+                </a:solidFill>
+                <a:latin typeface="Calibri"/>
+              </a:rPr>
+              <a:t>Small team, sequenced hiring.</a:t>
+            </a:r>
+          </a:p>
+        </p:txBody>
+      </p:sp>
+      <p:sp>
+        <p:nvSpPr>
+          <p:cNvPr id="4" name="Rounded Rectangle 3"/>
+          <p:cNvSpPr/>
+          <p:nvPr/>
+        </p:nvSpPr>
+        <p:spPr>
+          <a:xfrm>
+            <a:off x="640080" y="2103120"/>
+            <a:ext cx="3484880" cy="2827656"/>
+          </a:xfrm>
+          <a:prstGeom prst="roundRect">
+            <a:avLst>
+              <a:gd name="adj" fmla="val 6061"/>
+            </a:avLst>
+          </a:prstGeom>
+          <a:solidFill>
+            <a:srgbClr val="F2F7F5"/>
+          </a:solidFill>
+          <a:ln w="9525">
+            <a:solidFill>
+              <a:srgbClr val="D8DEE4"/>
+            </a:solidFill>
+          </a:ln>
+          <a:effectLst/>
+        </p:spPr>
+        <p:style>
+          <a:lnRef idx="1">
+            <a:schemeClr val="accent1"/>
+          </a:lnRef>
+          <a:fillRef idx="3">
+            <a:schemeClr val="accent1"/>
+          </a:fillRef>
+          <a:effectRef idx="2">
+            <a:schemeClr val="accent1"/>
+          </a:effectRef>
+          <a:fontRef idx="minor">
+            <a:schemeClr val="lt1"/>
+          </a:fontRef>
+        </p:style>
+        <p:txBody>
+          <a:bodyPr rtlCol="0" anchor="ctr"/>
+          <a:lstStyle/>
+          <a:p>
+            <a:pPr algn="ctr"/>
+          </a:p>
+        </p:txBody>
+      </p:sp>
+      <p:sp>
+        <p:nvSpPr>
+          <p:cNvPr id="5" name="TextBox 4"/>
+          <p:cNvSpPr txBox="1"/>
+          <p:nvPr/>
+        </p:nvSpPr>
+        <p:spPr>
+          <a:xfrm>
+            <a:off x="868680" y="2331720"/>
+            <a:ext cx="3027680" cy="320040"/>
+          </a:xfrm>
+          <a:prstGeom prst="rect">
+            <a:avLst/>
+          </a:prstGeom>
+          <a:noFill/>
+        </p:spPr>
+        <p:txBody>
+          <a:bodyPr wrap="square" anchor="ctr">
+            <a:spAutoFit/>
+          </a:bodyPr>
+          <a:lstStyle/>
+          <a:p>
+            <a:pPr algn="l"/>
+            <a:r>
+              <a:rPr sz="1200" b="1" spc="200">
+                <a:solidFill>
+                  <a:srgbClr val="0E6E5C"/>
+                </a:solidFill>
+                <a:latin typeface="Calibri"/>
+              </a:rPr>
+              <a:t>MONTHS 1–3</a:t>
+            </a:r>
+          </a:p>
+        </p:txBody>
+      </p:sp>
+      <p:sp>
+        <p:nvSpPr>
+          <p:cNvPr id="6" name="TextBox 5"/>
+          <p:cNvSpPr txBox="1"/>
+          <p:nvPr/>
+        </p:nvSpPr>
+        <p:spPr>
+          <a:xfrm>
+            <a:off x="868680" y="2743200"/>
+            <a:ext cx="3027680" cy="548640"/>
+          </a:xfrm>
+          <a:prstGeom prst="rect">
+            <a:avLst/>
+          </a:prstGeom>
+          <a:noFill/>
+        </p:spPr>
+        <p:txBody>
+          <a:bodyPr wrap="square" anchor="t">
+            <a:spAutoFit/>
+          </a:bodyPr>
+          <a:lstStyle/>
+          <a:p>
+            <a:pPr algn="l"/>
+            <a:r>
+              <a:rPr sz="1500" b="1">
+                <a:solidFill>
+                  <a:srgbClr val="141821"/>
+                </a:solidFill>
+                <a:latin typeface="Calibri"/>
+              </a:rPr>
+              <a:t>₹2.75L / month</a:t>
+            </a:r>
+          </a:p>
+        </p:txBody>
+      </p:sp>
+      <p:sp>
+        <p:nvSpPr>
+          <p:cNvPr id="7" name="TextBox 6"/>
+          <p:cNvSpPr txBox="1"/>
+          <p:nvPr/>
+        </p:nvSpPr>
+        <p:spPr>
+          <a:xfrm>
+            <a:off x="868680" y="3383280"/>
+            <a:ext cx="3027680" cy="1318896"/>
+          </a:xfrm>
+          <a:prstGeom prst="rect">
+            <a:avLst/>
+          </a:prstGeom>
+          <a:noFill/>
+        </p:spPr>
+        <p:txBody>
+          <a:bodyPr wrap="square" anchor="t">
+            <a:spAutoFit/>
+          </a:bodyPr>
+          <a:lstStyle/>
+          <a:p>
+            <a:pPr algn="l"/>
+            <a:r>
+              <a:rPr sz="1200" b="0">
+                <a:solidFill>
+                  <a:srgbClr val="5A6270"/>
+                </a:solidFill>
+                <a:latin typeface="Calibri"/>
+              </a:rPr>
+              <a:t>Founding full-stack engineer (₹2L/mo) + contract designer (₹75k/mo).</a:t>
+            </a:r>
+          </a:p>
+        </p:txBody>
+      </p:sp>
+      <p:sp>
+        <p:nvSpPr>
+          <p:cNvPr id="8" name="TextBox 7"/>
+          <p:cNvSpPr txBox="1"/>
+          <p:nvPr/>
+        </p:nvSpPr>
+        <p:spPr>
+          <a:xfrm>
+            <a:off x="4124960" y="3316948"/>
+            <a:ext cx="228600" cy="400000"/>
+          </a:xfrm>
+          <a:prstGeom prst="rect">
+            <a:avLst/>
+          </a:prstGeom>
+          <a:noFill/>
+        </p:spPr>
+        <p:txBody>
+          <a:bodyPr wrap="square" anchor="ctr">
+            <a:spAutoFit/>
+          </a:bodyPr>
+          <a:lstStyle/>
+          <a:p>
+            <a:pPr algn="ctr"/>
+            <a:r>
+              <a:rPr sz="2000" b="1">
+                <a:solidFill>
+                  <a:srgbClr val="0E6E5C"/>
+                </a:solidFill>
+                <a:latin typeface="Calibri"/>
+              </a:rPr>
+              <a:t>→</a:t>
+            </a:r>
+          </a:p>
+        </p:txBody>
+      </p:sp>
+      <p:sp>
+        <p:nvSpPr>
+          <p:cNvPr id="9" name="Rounded Rectangle 8"/>
+          <p:cNvSpPr/>
+          <p:nvPr/>
+        </p:nvSpPr>
+        <p:spPr>
+          <a:xfrm>
+            <a:off x="4353560" y="2103120"/>
+            <a:ext cx="3484880" cy="2827656"/>
+          </a:xfrm>
+          <a:prstGeom prst="roundRect">
+            <a:avLst>
+              <a:gd name="adj" fmla="val 6061"/>
+            </a:avLst>
+          </a:prstGeom>
+          <a:solidFill>
+            <a:srgbClr val="F2F7F5"/>
+          </a:solidFill>
+          <a:ln w="9525">
+            <a:solidFill>
+              <a:srgbClr val="D8DEE4"/>
+            </a:solidFill>
+          </a:ln>
+          <a:effectLst/>
+        </p:spPr>
+        <p:style>
+          <a:lnRef idx="1">
+            <a:schemeClr val="accent1"/>
+          </a:lnRef>
+          <a:fillRef idx="3">
+            <a:schemeClr val="accent1"/>
+          </a:fillRef>
+          <a:effectRef idx="2">
+            <a:schemeClr val="accent1"/>
+          </a:effectRef>
+          <a:fontRef idx="minor">
+            <a:schemeClr val="lt1"/>
+          </a:fontRef>
+        </p:style>
+        <p:txBody>
+          <a:bodyPr rtlCol="0" anchor="ctr"/>
+          <a:lstStyle/>
+          <a:p>
+            <a:pPr algn="ctr"/>
+          </a:p>
+        </p:txBody>
+      </p:sp>
+      <p:sp>
+        <p:nvSpPr>
+          <p:cNvPr id="10" name="TextBox 9"/>
+          <p:cNvSpPr txBox="1"/>
+          <p:nvPr/>
+        </p:nvSpPr>
+        <p:spPr>
+          <a:xfrm>
+            <a:off x="4582160" y="2331720"/>
+            <a:ext cx="3027680" cy="320040"/>
+          </a:xfrm>
+          <a:prstGeom prst="rect">
+            <a:avLst/>
+          </a:prstGeom>
+          <a:noFill/>
+        </p:spPr>
+        <p:txBody>
+          <a:bodyPr wrap="square" anchor="ctr">
+            <a:spAutoFit/>
+          </a:bodyPr>
+          <a:lstStyle/>
+          <a:p>
+            <a:pPr algn="l"/>
+            <a:r>
+              <a:rPr sz="1200" b="1" spc="200">
+                <a:solidFill>
+                  <a:srgbClr val="0E6E5C"/>
+                </a:solidFill>
+                <a:latin typeface="Calibri"/>
+              </a:rPr>
+              <a:t>MONTHS 4–6</a:t>
+            </a:r>
+          </a:p>
+        </p:txBody>
+      </p:sp>
+      <p:sp>
+        <p:nvSpPr>
+          <p:cNvPr id="11" name="TextBox 10"/>
+          <p:cNvSpPr txBox="1"/>
+          <p:nvPr/>
+        </p:nvSpPr>
+        <p:spPr>
+          <a:xfrm>
+            <a:off x="4582160" y="2743200"/>
+            <a:ext cx="3027680" cy="548640"/>
+          </a:xfrm>
+          <a:prstGeom prst="rect">
+            <a:avLst/>
+          </a:prstGeom>
+          <a:noFill/>
+        </p:spPr>
+        <p:txBody>
+          <a:bodyPr wrap="square" anchor="t">
+            <a:spAutoFit/>
+          </a:bodyPr>
+          <a:lstStyle/>
+          <a:p>
+            <a:pPr algn="l"/>
+            <a:r>
+              <a:rPr sz="1500" b="1">
+                <a:solidFill>
+                  <a:srgbClr val="141821"/>
+                </a:solidFill>
+                <a:latin typeface="Calibri"/>
+              </a:rPr>
+              <a:t>₹5.35L / month</a:t>
+            </a:r>
+          </a:p>
+        </p:txBody>
+      </p:sp>
+      <p:sp>
+        <p:nvSpPr>
+          <p:cNvPr id="12" name="TextBox 11"/>
+          <p:cNvSpPr txBox="1"/>
+          <p:nvPr/>
+        </p:nvSpPr>
+        <p:spPr>
+          <a:xfrm>
+            <a:off x="4582160" y="3383280"/>
+            <a:ext cx="3027680" cy="1318896"/>
+          </a:xfrm>
+          <a:prstGeom prst="rect">
+            <a:avLst/>
+          </a:prstGeom>
+          <a:noFill/>
+        </p:spPr>
+        <p:txBody>
+          <a:bodyPr wrap="square" anchor="t">
+            <a:spAutoFit/>
+          </a:bodyPr>
+          <a:lstStyle/>
+          <a:p>
+            <a:pPr algn="l"/>
+            <a:r>
+              <a:rPr sz="1200" b="0">
+                <a:solidFill>
+                  <a:srgbClr val="5A6270"/>
+                </a:solidFill>
+                <a:latin typeface="Calibri"/>
+              </a:rPr>
+              <a:t>+ Backend engineer (₹1.6L/mo) + frontend engineer (₹1L/mo).</a:t>
+            </a:r>
+          </a:p>
+        </p:txBody>
+      </p:sp>
+      <p:sp>
+        <p:nvSpPr>
+          <p:cNvPr id="13" name="TextBox 12"/>
+          <p:cNvSpPr txBox="1"/>
+          <p:nvPr/>
+        </p:nvSpPr>
+        <p:spPr>
+          <a:xfrm>
+            <a:off x="7838440" y="3316948"/>
+            <a:ext cx="228600" cy="400000"/>
+          </a:xfrm>
+          <a:prstGeom prst="rect">
+            <a:avLst/>
+          </a:prstGeom>
+          <a:noFill/>
+        </p:spPr>
+        <p:txBody>
+          <a:bodyPr wrap="square" anchor="ctr">
+            <a:spAutoFit/>
+          </a:bodyPr>
+          <a:lstStyle/>
+          <a:p>
+            <a:pPr algn="ctr"/>
+            <a:r>
+              <a:rPr sz="2000" b="1">
+                <a:solidFill>
+                  <a:srgbClr val="0E6E5C"/>
+                </a:solidFill>
+                <a:latin typeface="Calibri"/>
+              </a:rPr>
+              <a:t>→</a:t>
+            </a:r>
+          </a:p>
+        </p:txBody>
+      </p:sp>
+      <p:sp>
+        <p:nvSpPr>
+          <p:cNvPr id="14" name="Rounded Rectangle 13"/>
+          <p:cNvSpPr/>
+          <p:nvPr/>
+        </p:nvSpPr>
+        <p:spPr>
+          <a:xfrm>
+            <a:off x="8067040" y="2103120"/>
+            <a:ext cx="3484880" cy="2827656"/>
+          </a:xfrm>
+          <a:prstGeom prst="roundRect">
+            <a:avLst>
+              <a:gd name="adj" fmla="val 6061"/>
+            </a:avLst>
+          </a:prstGeom>
+          <a:solidFill>
+            <a:srgbClr val="F2F7F5"/>
+          </a:solidFill>
+          <a:ln w="9525">
+            <a:solidFill>
+              <a:srgbClr val="D8DEE4"/>
+            </a:solidFill>
+          </a:ln>
+          <a:effectLst/>
+        </p:spPr>
+        <p:style>
+          <a:lnRef idx="1">
+            <a:schemeClr val="accent1"/>
+          </a:lnRef>
+          <a:fillRef idx="3">
+            <a:schemeClr val="accent1"/>
+          </a:fillRef>
+          <a:effectRef idx="2">
+            <a:schemeClr val="accent1"/>
+          </a:effectRef>
+          <a:fontRef idx="minor">
+            <a:schemeClr val="lt1"/>
+          </a:fontRef>
+        </p:style>
+        <p:txBody>
+          <a:bodyPr rtlCol="0" anchor="ctr"/>
+          <a:lstStyle/>
+          <a:p>
+            <a:pPr algn="ctr"/>
+          </a:p>
+        </p:txBody>
+      </p:sp>
+      <p:sp>
+        <p:nvSpPr>
+          <p:cNvPr id="15" name="TextBox 14"/>
+          <p:cNvSpPr txBox="1"/>
+          <p:nvPr/>
+        </p:nvSpPr>
+        <p:spPr>
+          <a:xfrm>
+            <a:off x="8295640" y="2331720"/>
+            <a:ext cx="3027680" cy="320040"/>
+          </a:xfrm>
+          <a:prstGeom prst="rect">
+            <a:avLst/>
+          </a:prstGeom>
+          <a:noFill/>
+        </p:spPr>
+        <p:txBody>
+          <a:bodyPr wrap="square" anchor="ctr">
+            <a:spAutoFit/>
+          </a:bodyPr>
+          <a:lstStyle/>
+          <a:p>
+            <a:pPr algn="l"/>
+            <a:r>
+              <a:rPr sz="1200" b="1" spc="200">
+                <a:solidFill>
+                  <a:srgbClr val="0E6E5C"/>
+                </a:solidFill>
+                <a:latin typeface="Calibri"/>
+              </a:rPr>
+              <a:t>MONTHS 7–12</a:t>
+            </a:r>
+          </a:p>
+        </p:txBody>
+      </p:sp>
+      <p:sp>
+        <p:nvSpPr>
+          <p:cNvPr id="16" name="TextBox 15"/>
+          <p:cNvSpPr txBox="1"/>
+          <p:nvPr/>
+        </p:nvSpPr>
+        <p:spPr>
+          <a:xfrm>
+            <a:off x="8295640" y="2743200"/>
+            <a:ext cx="3027680" cy="548640"/>
+          </a:xfrm>
+          <a:prstGeom prst="rect">
+            <a:avLst/>
+          </a:prstGeom>
+          <a:noFill/>
+        </p:spPr>
+        <p:txBody>
+          <a:bodyPr wrap="square" anchor="t">
+            <a:spAutoFit/>
+          </a:bodyPr>
+          <a:lstStyle/>
+          <a:p>
+            <a:pPr algn="l"/>
+            <a:r>
+              <a:rPr sz="1500" b="1">
+                <a:solidFill>
+                  <a:srgbClr val="141821"/>
+                </a:solidFill>
+                <a:latin typeface="Calibri"/>
+              </a:rPr>
+              <a:t>₹6.65L / month</a:t>
+            </a:r>
+          </a:p>
+        </p:txBody>
+      </p:sp>
+      <p:sp>
+        <p:nvSpPr>
+          <p:cNvPr id="17" name="TextBox 16"/>
+          <p:cNvSpPr txBox="1"/>
+          <p:nvPr/>
+        </p:nvSpPr>
+        <p:spPr>
+          <a:xfrm>
+            <a:off x="8295640" y="3383280"/>
+            <a:ext cx="3027680" cy="1318896"/>
+          </a:xfrm>
+          <a:prstGeom prst="rect">
+            <a:avLst/>
+          </a:prstGeom>
+          <a:noFill/>
+        </p:spPr>
+        <p:txBody>
+          <a:bodyPr wrap="square" anchor="t">
+            <a:spAutoFit/>
+          </a:bodyPr>
+          <a:lstStyle/>
+          <a:p>
+            <a:pPr algn="l"/>
+            <a:r>
+              <a:rPr sz="1200" b="0">
+                <a:solidFill>
+                  <a:srgbClr val="5A6270"/>
+                </a:solidFill>
+                <a:latin typeface="Calibri"/>
+              </a:rPr>
+              <a:t>+ QA/ops (₹70k/mo) + fractional DevOps (₹60k/mo).</a:t>
+            </a:r>
+          </a:p>
+        </p:txBody>
+      </p:sp>
+      <p:sp>
+        <p:nvSpPr>
+          <p:cNvPr id="18" name="TextBox 17"/>
+          <p:cNvSpPr txBox="1"/>
+          <p:nvPr/>
+        </p:nvSpPr>
+        <p:spPr>
+          <a:xfrm>
+            <a:off x="640080" y="5400000"/>
+            <a:ext cx="10911840" cy="500000"/>
+          </a:xfrm>
+          <a:prstGeom prst="rect">
+            <a:avLst/>
+          </a:prstGeom>
+          <a:noFill/>
+        </p:spPr>
+        <p:txBody>
+          <a:bodyPr wrap="square" anchor="ctr">
+            <a:spAutoFit/>
+          </a:bodyPr>
+          <a:lstStyle/>
+          <a:p>
+            <a:pPr algn="l"/>
+            <a:r>
+              <a:rPr sz="1600" b="1">
+                <a:solidFill>
+                  <a:srgbClr val="0E6E5C"/>
+                </a:solidFill>
+                <a:latin typeface="Calibri"/>
+              </a:rPr>
+              <a:t>12-month engineering payroll: ₹55–65 lakh.</a:t>
+            </a:r>
+          </a:p>
+        </p:txBody>
+      </p:sp>
+    </p:spTree>
+  </p:cSld>
+  <p:clrMapOvr>
+    <a:masterClrMapping/>
+  </p:clrMapOvr>
+</p:sld>
+</file>
+
 <file path=ppt/slides/slide2.xml><?xml version="1.0" encoding="utf-8"?>
 <p:sld xmlns:a="http://schemas.openxmlformats.org/drawingml/2006/main" xmlns:r="http://schemas.openxmlformats.org/officeDocument/2006/relationships" xmlns:p="http://schemas.openxmlformats.org/presentationml/2006/main">
   <p:cSld name="Slide 2">

</xml_diff>

<commit_message>
feat: add Budget slide (3 scenarios, Brief section 7.1)
Co-Authored-By: Claude Sonnet 5 <noreply@anthropic.com>
</commit_message>
<xml_diff>
--- a/docs/PropWeb_Pitch_v2.pptx
+++ b/docs/PropWeb_Pitch_v2.pptx
@@ -19,6 +19,7 @@
     <p:sldId id="268" r:id="rId19"/>
     <p:sldId id="269" r:id="rId20"/>
     <p:sldId id="270" r:id="rId21"/>
+    <p:sldId id="271" r:id="rId22"/>
   </p:sldIdLst>
   <p:notesMasterIdLst>
     <p:notesMasterId r:id="rId11"/>
@@ -951,6 +952,76 @@
           <a:p>
             <a:r>
               <a:t>The headline is "small team, sequenced hiring" — resist the urge to justify each hire individually. If asked why the founding engineer comes before a designer, the honest answer is that the demo app already exists as proof the frontend/product work doesn't block on that hire yet.</a:t>
+            </a:r>
+          </a:p>
+        </p:txBody>
+      </p:sp>
+      <p:sp>
+        <p:nvSpPr>
+          <p:cNvPr id="4" name="Slide Number Placeholder 3"/>
+          <p:cNvSpPr>
+            <a:spLocks noGrp="1"/>
+          </p:cNvSpPr>
+          <p:nvPr>
+            <p:ph type="sldNum" idx="5" sz="quarter"/>
+          </p:nvPr>
+        </p:nvSpPr>
+        <p:spPr/>
+      </p:sp>
+    </p:spTree>
+  </p:cSld>
+  <p:clrMapOvr>
+    <a:masterClrMapping/>
+  </p:clrMapOvr>
+</p:notes>
+</file>
+
+<file path=ppt/notesSlides/notesSlide16.xml><?xml version="1.0" encoding="utf-8"?>
+<p:notes xmlns:a="http://schemas.openxmlformats.org/drawingml/2006/main" xmlns:p="http://schemas.openxmlformats.org/presentationml/2006/main" xmlns:r="http://schemas.openxmlformats.org/officeDocument/2006/relationships">
+  <p:cSld>
+    <p:spTree>
+      <p:nvGrpSpPr>
+        <p:cNvPr id="1" name=""/>
+        <p:cNvGrpSpPr/>
+        <p:nvPr/>
+      </p:nvGrpSpPr>
+      <p:grpSpPr>
+        <a:xfrm>
+          <a:off x="0" y="0"/>
+          <a:ext cx="0" cy="0"/>
+          <a:chOff x="0" y="0"/>
+          <a:chExt cx="0" cy="0"/>
+        </a:xfrm>
+      </p:grpSpPr>
+      <p:sp>
+        <p:nvSpPr>
+          <p:cNvPr id="2" name="Slide Image Placeholder 1"/>
+          <p:cNvSpPr>
+            <a:spLocks noGrp="1"/>
+          </p:cNvSpPr>
+          <p:nvPr>
+            <p:ph type="sldImg" idx="2"/>
+          </p:nvPr>
+        </p:nvSpPr>
+        <p:spPr/>
+      </p:sp>
+      <p:sp>
+        <p:nvSpPr>
+          <p:cNvPr id="3" name="Notes Placeholder 2"/>
+          <p:cNvSpPr>
+            <a:spLocks noGrp="1"/>
+          </p:cNvSpPr>
+          <p:nvPr>
+            <p:ph type="body" idx="3" sz="quarter"/>
+          </p:nvPr>
+        </p:nvSpPr>
+        <p:spPr/>
+        <p:txBody>
+          <a:bodyPr/>
+          <a:lstStyle/>
+          <a:p>
+            <a:r>
+              <a:t>Present all three scenarios before anyone asks which one to pick — this is a menu, not a recommendation, and the ask on the next slide is a decision between them, not an approval of a single number. If pressed for a personal recommendation, Base is the defensible middle: it funds the full hiring sequence without the Lean scenario's slack risk.</a:t>
             </a:r>
           </a:p>
         </p:txBody>
@@ -6514,6 +6585,885 @@
 </p:sld>
 </file>
 
+<file path=ppt/slides/slide16.xml><?xml version="1.0" encoding="utf-8"?>
+<p:sld xmlns:a="http://schemas.openxmlformats.org/drawingml/2006/main" xmlns:p="http://schemas.openxmlformats.org/presentationml/2006/main" xmlns:r="http://schemas.openxmlformats.org/officeDocument/2006/relationships">
+  <p:cSld>
+    <p:bg>
+      <p:bgPr>
+        <a:solidFill>
+          <a:srgbClr val="FFFFFF"/>
+        </a:solidFill>
+        <a:effectLst/>
+      </p:bgPr>
+    </p:bg>
+    <p:spTree>
+      <p:nvGrpSpPr>
+        <p:cNvPr id="1" name=""/>
+        <p:cNvGrpSpPr/>
+        <p:nvPr/>
+      </p:nvGrpSpPr>
+      <p:grpSpPr/>
+      <p:sp>
+        <p:nvSpPr>
+          <p:cNvPr id="2" name="TextBox 1"/>
+          <p:cNvSpPr txBox="1"/>
+          <p:nvPr/>
+        </p:nvSpPr>
+        <p:spPr>
+          <a:xfrm>
+            <a:off x="640080" y="502920"/>
+            <a:ext cx="7315200" cy="320040"/>
+          </a:xfrm>
+          <a:prstGeom prst="rect">
+            <a:avLst/>
+          </a:prstGeom>
+          <a:noFill/>
+        </p:spPr>
+        <p:txBody>
+          <a:bodyPr wrap="square" anchor="ctr">
+            <a:spAutoFit/>
+          </a:bodyPr>
+          <a:lstStyle/>
+          <a:p>
+            <a:pPr algn="l"/>
+            <a:r>
+              <a:rPr sz="1200" b="1" spc="300">
+                <a:solidFill>
+                  <a:srgbClr val="0E6E5C"/>
+                </a:solidFill>
+                <a:latin typeface="Calibri"/>
+              </a:rPr>
+              <a:t>BUDGET</a:t>
+            </a:r>
+          </a:p>
+        </p:txBody>
+      </p:sp>
+      <p:sp>
+        <p:nvSpPr>
+          <p:cNvPr id="3" name="TextBox 2"/>
+          <p:cNvSpPr txBox="1"/>
+          <p:nvPr/>
+        </p:nvSpPr>
+        <p:spPr>
+          <a:xfrm>
+            <a:off x="640080" y="868680"/>
+            <a:ext cx="10881360" cy="777240"/>
+          </a:xfrm>
+          <a:prstGeom prst="rect">
+            <a:avLst/>
+          </a:prstGeom>
+          <a:noFill/>
+        </p:spPr>
+        <p:txBody>
+          <a:bodyPr wrap="square" anchor="ctr">
+            <a:spAutoFit/>
+          </a:bodyPr>
+          <a:lstStyle/>
+          <a:p>
+            <a:pPr algn="l"/>
+            <a:r>
+              <a:rPr sz="3000" b="1">
+                <a:solidFill>
+                  <a:srgbClr val="141821"/>
+                </a:solidFill>
+                <a:latin typeface="Calibri"/>
+              </a:rPr>
+              <a:t>Three scenarios, months 0–12.</a:t>
+            </a:r>
+          </a:p>
+        </p:txBody>
+      </p:sp>
+      <p:graphicFrame>
+        <p:nvGraphicFramePr>
+          <p:cNvPr id="4" name="Table 3"/>
+          <p:cNvGraphicFramePr>
+            <a:graphicFrameLocks noGrp="1"/>
+          </p:cNvGraphicFramePr>
+          <p:nvPr/>
+        </p:nvGraphicFramePr>
+        <p:xfrm>
+          <a:off x="640080" y="2103120"/>
+          <a:ext cx="10911840" cy="3800000"/>
+        </p:xfrm>
+        <a:graphic>
+          <a:graphicData uri="http://schemas.openxmlformats.org/drawingml/2006/table">
+            <a:tbl>
+              <a:tblPr firstRow="1" bandRow="1">
+                <a:tableStyleId>{5C22544A-7EE6-4342-B048-85BDC9FD1C3A}</a:tableStyleId>
+              </a:tblPr>
+              <a:tblGrid>
+                <a:gridCol w="4200000"/>
+                <a:gridCol w="2237280"/>
+                <a:gridCol w="2237280"/>
+                <a:gridCol w="2237280"/>
+              </a:tblGrid>
+              <a:tr h="475000">
+                <a:tc>
+                  <a:txBody>
+                    <a:bodyPr/>
+                    <a:lstStyle/>
+                    <a:p>
+                      <a:r>
+                        <a:rPr sz="1250" b="1">
+                          <a:solidFill>
+                            <a:srgbClr val="141821"/>
+                          </a:solidFill>
+                          <a:latin typeface="Calibri"/>
+                        </a:rPr>
+                        <a:t>Cost line</a:t>
+                      </a:r>
+                    </a:p>
+                  </a:txBody>
+                  <a:tcPr>
+                    <a:solidFill>
+                      <a:srgbClr val="F2F7F5"/>
+                    </a:solidFill>
+                  </a:tcPr>
+                </a:tc>
+                <a:tc>
+                  <a:txBody>
+                    <a:bodyPr/>
+                    <a:lstStyle/>
+                    <a:p>
+                      <a:r>
+                        <a:rPr sz="1250" b="1">
+                          <a:solidFill>
+                            <a:srgbClr val="141821"/>
+                          </a:solidFill>
+                          <a:latin typeface="Calibri"/>
+                        </a:rPr>
+                        <a:t>Lean</a:t>
+                      </a:r>
+                    </a:p>
+                  </a:txBody>
+                  <a:tcPr>
+                    <a:solidFill>
+                      <a:srgbClr val="F2F7F5"/>
+                    </a:solidFill>
+                  </a:tcPr>
+                </a:tc>
+                <a:tc>
+                  <a:txBody>
+                    <a:bodyPr/>
+                    <a:lstStyle/>
+                    <a:p>
+                      <a:r>
+                        <a:rPr sz="1250" b="1">
+                          <a:solidFill>
+                            <a:srgbClr val="141821"/>
+                          </a:solidFill>
+                          <a:latin typeface="Calibri"/>
+                        </a:rPr>
+                        <a:t>Base</a:t>
+                      </a:r>
+                    </a:p>
+                  </a:txBody>
+                  <a:tcPr>
+                    <a:solidFill>
+                      <a:srgbClr val="F2F7F5"/>
+                    </a:solidFill>
+                  </a:tcPr>
+                </a:tc>
+                <a:tc>
+                  <a:txBody>
+                    <a:bodyPr/>
+                    <a:lstStyle/>
+                    <a:p>
+                      <a:r>
+                        <a:rPr sz="1250" b="1">
+                          <a:solidFill>
+                            <a:srgbClr val="141821"/>
+                          </a:solidFill>
+                          <a:latin typeface="Calibri"/>
+                        </a:rPr>
+                        <a:t>Comfortable</a:t>
+                      </a:r>
+                    </a:p>
+                  </a:txBody>
+                  <a:tcPr>
+                    <a:solidFill>
+                      <a:srgbClr val="F2F7F5"/>
+                    </a:solidFill>
+                  </a:tcPr>
+                </a:tc>
+              </a:tr>
+              <a:tr h="475000">
+                <a:tc>
+                  <a:txBody>
+                    <a:bodyPr/>
+                    <a:lstStyle/>
+                    <a:p>
+                      <a:r>
+                        <a:rPr sz="1200" b="0">
+                          <a:solidFill>
+                            <a:srgbClr val="5A6270"/>
+                          </a:solidFill>
+                          <a:latin typeface="Calibri"/>
+                        </a:rPr>
+                        <a:t>Engineering payroll</a:t>
+                      </a:r>
+                    </a:p>
+                  </a:txBody>
+                  <a:tcPr>
+                    <a:solidFill>
+                      <a:srgbClr val="FFFFFF"/>
+                    </a:solidFill>
+                  </a:tcPr>
+                </a:tc>
+                <a:tc>
+                  <a:txBody>
+                    <a:bodyPr/>
+                    <a:lstStyle/>
+                    <a:p>
+                      <a:r>
+                        <a:rPr sz="1200" b="0">
+                          <a:solidFill>
+                            <a:srgbClr val="5A6270"/>
+                          </a:solidFill>
+                          <a:latin typeface="Calibri"/>
+                        </a:rPr>
+                        <a:t>₹40L</a:t>
+                      </a:r>
+                    </a:p>
+                  </a:txBody>
+                  <a:tcPr>
+                    <a:solidFill>
+                      <a:srgbClr val="FFFFFF"/>
+                    </a:solidFill>
+                  </a:tcPr>
+                </a:tc>
+                <a:tc>
+                  <a:txBody>
+                    <a:bodyPr/>
+                    <a:lstStyle/>
+                    <a:p>
+                      <a:r>
+                        <a:rPr sz="1200" b="0">
+                          <a:solidFill>
+                            <a:srgbClr val="5A6270"/>
+                          </a:solidFill>
+                          <a:latin typeface="Calibri"/>
+                        </a:rPr>
+                        <a:t>₹60L</a:t>
+                      </a:r>
+                    </a:p>
+                  </a:txBody>
+                  <a:tcPr>
+                    <a:solidFill>
+                      <a:srgbClr val="FFFFFF"/>
+                    </a:solidFill>
+                  </a:tcPr>
+                </a:tc>
+                <a:tc>
+                  <a:txBody>
+                    <a:bodyPr/>
+                    <a:lstStyle/>
+                    <a:p>
+                      <a:r>
+                        <a:rPr sz="1200" b="0">
+                          <a:solidFill>
+                            <a:srgbClr val="5A6270"/>
+                          </a:solidFill>
+                          <a:latin typeface="Calibri"/>
+                        </a:rPr>
+                        <a:t>₹90L</a:t>
+                      </a:r>
+                    </a:p>
+                  </a:txBody>
+                  <a:tcPr>
+                    <a:solidFill>
+                      <a:srgbClr val="FFFFFF"/>
+                    </a:solidFill>
+                  </a:tcPr>
+                </a:tc>
+              </a:tr>
+              <a:tr h="475000">
+                <a:tc>
+                  <a:txBody>
+                    <a:bodyPr/>
+                    <a:lstStyle/>
+                    <a:p>
+                      <a:r>
+                        <a:rPr sz="1200" b="0">
+                          <a:solidFill>
+                            <a:srgbClr val="5A6270"/>
+                          </a:solidFill>
+                          <a:latin typeface="Calibri"/>
+                        </a:rPr>
+                        <a:t>CTO+CPO cash (reduced)</a:t>
+                      </a:r>
+                    </a:p>
+                  </a:txBody>
+                  <a:tcPr>
+                    <a:solidFill>
+                      <a:srgbClr val="F2F7F5"/>
+                    </a:solidFill>
+                  </a:tcPr>
+                </a:tc>
+                <a:tc>
+                  <a:txBody>
+                    <a:bodyPr/>
+                    <a:lstStyle/>
+                    <a:p>
+                      <a:r>
+                        <a:rPr sz="1200" b="0">
+                          <a:solidFill>
+                            <a:srgbClr val="5A6270"/>
+                          </a:solidFill>
+                          <a:latin typeface="Calibri"/>
+                        </a:rPr>
+                        <a:t>₹12L</a:t>
+                      </a:r>
+                    </a:p>
+                  </a:txBody>
+                  <a:tcPr>
+                    <a:solidFill>
+                      <a:srgbClr val="F2F7F5"/>
+                    </a:solidFill>
+                  </a:tcPr>
+                </a:tc>
+                <a:tc>
+                  <a:txBody>
+                    <a:bodyPr/>
+                    <a:lstStyle/>
+                    <a:p>
+                      <a:r>
+                        <a:rPr sz="1200" b="0">
+                          <a:solidFill>
+                            <a:srgbClr val="5A6270"/>
+                          </a:solidFill>
+                          <a:latin typeface="Calibri"/>
+                        </a:rPr>
+                        <a:t>₹24L</a:t>
+                      </a:r>
+                    </a:p>
+                  </a:txBody>
+                  <a:tcPr>
+                    <a:solidFill>
+                      <a:srgbClr val="F2F7F5"/>
+                    </a:solidFill>
+                  </a:tcPr>
+                </a:tc>
+                <a:tc>
+                  <a:txBody>
+                    <a:bodyPr/>
+                    <a:lstStyle/>
+                    <a:p>
+                      <a:r>
+                        <a:rPr sz="1200" b="0">
+                          <a:solidFill>
+                            <a:srgbClr val="5A6270"/>
+                          </a:solidFill>
+                          <a:latin typeface="Calibri"/>
+                        </a:rPr>
+                        <a:t>₹36L</a:t>
+                      </a:r>
+                    </a:p>
+                  </a:txBody>
+                  <a:tcPr>
+                    <a:solidFill>
+                      <a:srgbClr val="F2F7F5"/>
+                    </a:solidFill>
+                  </a:tcPr>
+                </a:tc>
+              </a:tr>
+              <a:tr h="475000">
+                <a:tc>
+                  <a:txBody>
+                    <a:bodyPr/>
+                    <a:lstStyle/>
+                    <a:p>
+                      <a:r>
+                        <a:rPr sz="1200" b="0">
+                          <a:solidFill>
+                            <a:srgbClr val="5A6270"/>
+                          </a:solidFill>
+                          <a:latin typeface="Calibri"/>
+                        </a:rPr>
+                        <a:t>Cloud &amp; infrastructure</a:t>
+                      </a:r>
+                    </a:p>
+                  </a:txBody>
+                  <a:tcPr>
+                    <a:solidFill>
+                      <a:srgbClr val="FFFFFF"/>
+                    </a:solidFill>
+                  </a:tcPr>
+                </a:tc>
+                <a:tc>
+                  <a:txBody>
+                    <a:bodyPr/>
+                    <a:lstStyle/>
+                    <a:p>
+                      <a:r>
+                        <a:rPr sz="1200" b="0">
+                          <a:solidFill>
+                            <a:srgbClr val="5A6270"/>
+                          </a:solidFill>
+                          <a:latin typeface="Calibri"/>
+                        </a:rPr>
+                        <a:t>₹3L</a:t>
+                      </a:r>
+                    </a:p>
+                  </a:txBody>
+                  <a:tcPr>
+                    <a:solidFill>
+                      <a:srgbClr val="FFFFFF"/>
+                    </a:solidFill>
+                  </a:tcPr>
+                </a:tc>
+                <a:tc>
+                  <a:txBody>
+                    <a:bodyPr/>
+                    <a:lstStyle/>
+                    <a:p>
+                      <a:r>
+                        <a:rPr sz="1200" b="0">
+                          <a:solidFill>
+                            <a:srgbClr val="5A6270"/>
+                          </a:solidFill>
+                          <a:latin typeface="Calibri"/>
+                        </a:rPr>
+                        <a:t>₹6L</a:t>
+                      </a:r>
+                    </a:p>
+                  </a:txBody>
+                  <a:tcPr>
+                    <a:solidFill>
+                      <a:srgbClr val="FFFFFF"/>
+                    </a:solidFill>
+                  </a:tcPr>
+                </a:tc>
+                <a:tc>
+                  <a:txBody>
+                    <a:bodyPr/>
+                    <a:lstStyle/>
+                    <a:p>
+                      <a:r>
+                        <a:rPr sz="1200" b="0">
+                          <a:solidFill>
+                            <a:srgbClr val="5A6270"/>
+                          </a:solidFill>
+                          <a:latin typeface="Calibri"/>
+                        </a:rPr>
+                        <a:t>₹12L</a:t>
+                      </a:r>
+                    </a:p>
+                  </a:txBody>
+                  <a:tcPr>
+                    <a:solidFill>
+                      <a:srgbClr val="FFFFFF"/>
+                    </a:solidFill>
+                  </a:tcPr>
+                </a:tc>
+              </a:tr>
+              <a:tr h="475000">
+                <a:tc>
+                  <a:txBody>
+                    <a:bodyPr/>
+                    <a:lstStyle/>
+                    <a:p>
+                      <a:r>
+                        <a:rPr sz="1200" b="0">
+                          <a:solidFill>
+                            <a:srgbClr val="5A6270"/>
+                          </a:solidFill>
+                          <a:latin typeface="Calibri"/>
+                        </a:rPr>
+                        <a:t>Third-party APIs</a:t>
+                      </a:r>
+                    </a:p>
+                  </a:txBody>
+                  <a:tcPr>
+                    <a:solidFill>
+                      <a:srgbClr val="F2F7F5"/>
+                    </a:solidFill>
+                  </a:tcPr>
+                </a:tc>
+                <a:tc>
+                  <a:txBody>
+                    <a:bodyPr/>
+                    <a:lstStyle/>
+                    <a:p>
+                      <a:r>
+                        <a:rPr sz="1200" b="0">
+                          <a:solidFill>
+                            <a:srgbClr val="5A6270"/>
+                          </a:solidFill>
+                          <a:latin typeface="Calibri"/>
+                        </a:rPr>
+                        <a:t>₹3L</a:t>
+                      </a:r>
+                    </a:p>
+                  </a:txBody>
+                  <a:tcPr>
+                    <a:solidFill>
+                      <a:srgbClr val="F2F7F5"/>
+                    </a:solidFill>
+                  </a:tcPr>
+                </a:tc>
+                <a:tc>
+                  <a:txBody>
+                    <a:bodyPr/>
+                    <a:lstStyle/>
+                    <a:p>
+                      <a:r>
+                        <a:rPr sz="1200" b="0">
+                          <a:solidFill>
+                            <a:srgbClr val="5A6270"/>
+                          </a:solidFill>
+                          <a:latin typeface="Calibri"/>
+                        </a:rPr>
+                        <a:t>₹6L</a:t>
+                      </a:r>
+                    </a:p>
+                  </a:txBody>
+                  <a:tcPr>
+                    <a:solidFill>
+                      <a:srgbClr val="F2F7F5"/>
+                    </a:solidFill>
+                  </a:tcPr>
+                </a:tc>
+                <a:tc>
+                  <a:txBody>
+                    <a:bodyPr/>
+                    <a:lstStyle/>
+                    <a:p>
+                      <a:r>
+                        <a:rPr sz="1200" b="0">
+                          <a:solidFill>
+                            <a:srgbClr val="5A6270"/>
+                          </a:solidFill>
+                          <a:latin typeface="Calibri"/>
+                        </a:rPr>
+                        <a:t>₹12L</a:t>
+                      </a:r>
+                    </a:p>
+                  </a:txBody>
+                  <a:tcPr>
+                    <a:solidFill>
+                      <a:srgbClr val="F2F7F5"/>
+                    </a:solidFill>
+                  </a:tcPr>
+                </a:tc>
+              </a:tr>
+              <a:tr h="475000">
+                <a:tc>
+                  <a:txBody>
+                    <a:bodyPr/>
+                    <a:lstStyle/>
+                    <a:p>
+                      <a:r>
+                        <a:rPr sz="1200" b="0">
+                          <a:solidFill>
+                            <a:srgbClr val="5A6270"/>
+                          </a:solidFill>
+                          <a:latin typeface="Calibri"/>
+                        </a:rPr>
+                        <a:t>Tools &amp; licenses</a:t>
+                      </a:r>
+                    </a:p>
+                  </a:txBody>
+                  <a:tcPr>
+                    <a:solidFill>
+                      <a:srgbClr val="FFFFFF"/>
+                    </a:solidFill>
+                  </a:tcPr>
+                </a:tc>
+                <a:tc>
+                  <a:txBody>
+                    <a:bodyPr/>
+                    <a:lstStyle/>
+                    <a:p>
+                      <a:r>
+                        <a:rPr sz="1200" b="0">
+                          <a:solidFill>
+                            <a:srgbClr val="5A6270"/>
+                          </a:solidFill>
+                          <a:latin typeface="Calibri"/>
+                        </a:rPr>
+                        <a:t>₹1.5L</a:t>
+                      </a:r>
+                    </a:p>
+                  </a:txBody>
+                  <a:tcPr>
+                    <a:solidFill>
+                      <a:srgbClr val="FFFFFF"/>
+                    </a:solidFill>
+                  </a:tcPr>
+                </a:tc>
+                <a:tc>
+                  <a:txBody>
+                    <a:bodyPr/>
+                    <a:lstStyle/>
+                    <a:p>
+                      <a:r>
+                        <a:rPr sz="1200" b="0">
+                          <a:solidFill>
+                            <a:srgbClr val="5A6270"/>
+                          </a:solidFill>
+                          <a:latin typeface="Calibri"/>
+                        </a:rPr>
+                        <a:t>₹3L</a:t>
+                      </a:r>
+                    </a:p>
+                  </a:txBody>
+                  <a:tcPr>
+                    <a:solidFill>
+                      <a:srgbClr val="FFFFFF"/>
+                    </a:solidFill>
+                  </a:tcPr>
+                </a:tc>
+                <a:tc>
+                  <a:txBody>
+                    <a:bodyPr/>
+                    <a:lstStyle/>
+                    <a:p>
+                      <a:r>
+                        <a:rPr sz="1200" b="0">
+                          <a:solidFill>
+                            <a:srgbClr val="5A6270"/>
+                          </a:solidFill>
+                          <a:latin typeface="Calibri"/>
+                        </a:rPr>
+                        <a:t>₹5L</a:t>
+                      </a:r>
+                    </a:p>
+                  </a:txBody>
+                  <a:tcPr>
+                    <a:solidFill>
+                      <a:srgbClr val="FFFFFF"/>
+                    </a:solidFill>
+                  </a:tcPr>
+                </a:tc>
+              </a:tr>
+              <a:tr h="475000">
+                <a:tc>
+                  <a:txBody>
+                    <a:bodyPr/>
+                    <a:lstStyle/>
+                    <a:p>
+                      <a:r>
+                        <a:rPr sz="1200" b="0">
+                          <a:solidFill>
+                            <a:srgbClr val="5A6270"/>
+                          </a:solidFill>
+                          <a:latin typeface="Calibri"/>
+                        </a:rPr>
+                        <a:t>Contingency (~15%)</a:t>
+                      </a:r>
+                    </a:p>
+                  </a:txBody>
+                  <a:tcPr>
+                    <a:solidFill>
+                      <a:srgbClr val="F2F7F5"/>
+                    </a:solidFill>
+                  </a:tcPr>
+                </a:tc>
+                <a:tc>
+                  <a:txBody>
+                    <a:bodyPr/>
+                    <a:lstStyle/>
+                    <a:p>
+                      <a:r>
+                        <a:rPr sz="1200" b="0">
+                          <a:solidFill>
+                            <a:srgbClr val="5A6270"/>
+                          </a:solidFill>
+                          <a:latin typeface="Calibri"/>
+                        </a:rPr>
+                        <a:t>₹9L</a:t>
+                      </a:r>
+                    </a:p>
+                  </a:txBody>
+                  <a:tcPr>
+                    <a:solidFill>
+                      <a:srgbClr val="F2F7F5"/>
+                    </a:solidFill>
+                  </a:tcPr>
+                </a:tc>
+                <a:tc>
+                  <a:txBody>
+                    <a:bodyPr/>
+                    <a:lstStyle/>
+                    <a:p>
+                      <a:r>
+                        <a:rPr sz="1200" b="0">
+                          <a:solidFill>
+                            <a:srgbClr val="5A6270"/>
+                          </a:solidFill>
+                          <a:latin typeface="Calibri"/>
+                        </a:rPr>
+                        <a:t>₹15L</a:t>
+                      </a:r>
+                    </a:p>
+                  </a:txBody>
+                  <a:tcPr>
+                    <a:solidFill>
+                      <a:srgbClr val="F2F7F5"/>
+                    </a:solidFill>
+                  </a:tcPr>
+                </a:tc>
+                <a:tc>
+                  <a:txBody>
+                    <a:bodyPr/>
+                    <a:lstStyle/>
+                    <a:p>
+                      <a:r>
+                        <a:rPr sz="1200" b="0">
+                          <a:solidFill>
+                            <a:srgbClr val="5A6270"/>
+                          </a:solidFill>
+                          <a:latin typeface="Calibri"/>
+                        </a:rPr>
+                        <a:t>₹23L</a:t>
+                      </a:r>
+                    </a:p>
+                  </a:txBody>
+                  <a:tcPr>
+                    <a:solidFill>
+                      <a:srgbClr val="F2F7F5"/>
+                    </a:solidFill>
+                  </a:tcPr>
+                </a:tc>
+              </a:tr>
+              <a:tr h="475000">
+                <a:tc>
+                  <a:txBody>
+                    <a:bodyPr/>
+                    <a:lstStyle/>
+                    <a:p>
+                      <a:r>
+                        <a:rPr sz="1200" b="0">
+                          <a:solidFill>
+                            <a:srgbClr val="5A6270"/>
+                          </a:solidFill>
+                          <a:latin typeface="Calibri"/>
+                        </a:rPr>
+                        <a:t>TOTAL (0–12 months)</a:t>
+                      </a:r>
+                    </a:p>
+                  </a:txBody>
+                  <a:tcPr>
+                    <a:solidFill>
+                      <a:srgbClr val="FFFFFF"/>
+                    </a:solidFill>
+                  </a:tcPr>
+                </a:tc>
+                <a:tc>
+                  <a:txBody>
+                    <a:bodyPr/>
+                    <a:lstStyle/>
+                    <a:p>
+                      <a:r>
+                        <a:rPr sz="1200" b="0">
+                          <a:solidFill>
+                            <a:srgbClr val="5A6270"/>
+                          </a:solidFill>
+                          <a:latin typeface="Calibri"/>
+                        </a:rPr>
+                        <a:t>≈₹68L</a:t>
+                      </a:r>
+                    </a:p>
+                  </a:txBody>
+                  <a:tcPr>
+                    <a:solidFill>
+                      <a:srgbClr val="FFFFFF"/>
+                    </a:solidFill>
+                  </a:tcPr>
+                </a:tc>
+                <a:tc>
+                  <a:txBody>
+                    <a:bodyPr/>
+                    <a:lstStyle/>
+                    <a:p>
+                      <a:r>
+                        <a:rPr sz="1200" b="0">
+                          <a:solidFill>
+                            <a:srgbClr val="5A6270"/>
+                          </a:solidFill>
+                          <a:latin typeface="Calibri"/>
+                        </a:rPr>
+                        <a:t>≈₹1.14 Cr</a:t>
+                      </a:r>
+                    </a:p>
+                  </a:txBody>
+                  <a:tcPr>
+                    <a:solidFill>
+                      <a:srgbClr val="FFFFFF"/>
+                    </a:solidFill>
+                  </a:tcPr>
+                </a:tc>
+                <a:tc>
+                  <a:txBody>
+                    <a:bodyPr/>
+                    <a:lstStyle/>
+                    <a:p>
+                      <a:r>
+                        <a:rPr sz="1200" b="0">
+                          <a:solidFill>
+                            <a:srgbClr val="5A6270"/>
+                          </a:solidFill>
+                          <a:latin typeface="Calibri"/>
+                        </a:rPr>
+                        <a:t>≈₹1.78 Cr</a:t>
+                      </a:r>
+                    </a:p>
+                  </a:txBody>
+                  <a:tcPr>
+                    <a:solidFill>
+                      <a:srgbClr val="FFFFFF"/>
+                    </a:solidFill>
+                  </a:tcPr>
+                </a:tc>
+              </a:tr>
+            </a:tbl>
+          </a:graphicData>
+        </a:graphic>
+      </p:graphicFrame>
+      <p:sp>
+        <p:nvSpPr>
+          <p:cNvPr id="5" name="TextBox 4"/>
+          <p:cNvSpPr txBox="1"/>
+          <p:nvPr/>
+        </p:nvSpPr>
+        <p:spPr>
+          <a:xfrm>
+            <a:off x="640080" y="6100000"/>
+            <a:ext cx="10911840" cy="500000"/>
+          </a:xfrm>
+          <a:prstGeom prst="rect">
+            <a:avLst/>
+          </a:prstGeom>
+          <a:noFill/>
+        </p:spPr>
+        <p:txBody>
+          <a:bodyPr wrap="square" anchor="ctr">
+            <a:spAutoFit/>
+          </a:bodyPr>
+          <a:lstStyle/>
+          <a:p>
+            <a:pPr algn="l"/>
+            <a:r>
+              <a:rPr sz="1300" b="0">
+                <a:solidFill>
+                  <a:srgbClr val="5A6270"/>
+                </a:solidFill>
+                <a:latin typeface="Calibri"/>
+              </a:rPr>
+              <a:t>Team of 5–6 + fractional roles; one-city MVP achievable in 4 months.</a:t>
+            </a:r>
+          </a:p>
+        </p:txBody>
+      </p:sp>
+    </p:spTree>
+  </p:cSld>
+  <p:clrMapOvr>
+    <a:masterClrMapping/>
+  </p:clrMapOvr>
+</p:sld>
+</file>
+
 <file path=ppt/slides/slide2.xml><?xml version="1.0" encoding="utf-8"?>
 <p:sld xmlns:a="http://schemas.openxmlformats.org/drawingml/2006/main" xmlns:r="http://schemas.openxmlformats.org/officeDocument/2006/relationships" xmlns:p="http://schemas.openxmlformats.org/presentationml/2006/main">
   <p:cSld name="Slide 2">

</xml_diff>

<commit_message>
feat: add Ask and close slide
</commit_message>
<xml_diff>
--- a/docs/PropWeb_Pitch_v2.pptx
+++ b/docs/PropWeb_Pitch_v2.pptx
@@ -20,6 +20,7 @@
     <p:sldId id="269" r:id="rId20"/>
     <p:sldId id="270" r:id="rId21"/>
     <p:sldId id="271" r:id="rId22"/>
+    <p:sldId id="272" r:id="rId23"/>
   </p:sldIdLst>
   <p:notesMasterIdLst>
     <p:notesMasterId r:id="rId11"/>
@@ -1022,6 +1023,76 @@
           <a:p>
             <a:r>
               <a:t>Present all three scenarios before anyone asks which one to pick — this is a menu, not a recommendation, and the ask on the next slide is a decision between them, not an approval of a single number. If pressed for a personal recommendation, Base is the defensible middle: it funds the full hiring sequence without the Lean scenario's slack risk.</a:t>
+            </a:r>
+          </a:p>
+        </p:txBody>
+      </p:sp>
+      <p:sp>
+        <p:nvSpPr>
+          <p:cNvPr id="4" name="Slide Number Placeholder 3"/>
+          <p:cNvSpPr>
+            <a:spLocks noGrp="1"/>
+          </p:cNvSpPr>
+          <p:nvPr>
+            <p:ph type="sldNum" idx="5" sz="quarter"/>
+          </p:nvPr>
+        </p:nvSpPr>
+        <p:spPr/>
+      </p:sp>
+    </p:spTree>
+  </p:cSld>
+  <p:clrMapOvr>
+    <a:masterClrMapping/>
+  </p:clrMapOvr>
+</p:notes>
+</file>
+
+<file path=ppt/notesSlides/notesSlide17.xml><?xml version="1.0" encoding="utf-8"?>
+<p:notes xmlns:a="http://schemas.openxmlformats.org/drawingml/2006/main" xmlns:p="http://schemas.openxmlformats.org/presentationml/2006/main" xmlns:r="http://schemas.openxmlformats.org/officeDocument/2006/relationships">
+  <p:cSld>
+    <p:spTree>
+      <p:nvGrpSpPr>
+        <p:cNvPr id="1" name=""/>
+        <p:cNvGrpSpPr/>
+        <p:nvPr/>
+      </p:nvGrpSpPr>
+      <p:grpSpPr>
+        <a:xfrm>
+          <a:off x="0" y="0"/>
+          <a:ext cx="0" cy="0"/>
+          <a:chOff x="0" y="0"/>
+          <a:chExt cx="0" cy="0"/>
+        </a:xfrm>
+      </p:grpSpPr>
+      <p:sp>
+        <p:nvSpPr>
+          <p:cNvPr id="2" name="Slide Image Placeholder 1"/>
+          <p:cNvSpPr>
+            <a:spLocks noGrp="1"/>
+          </p:cNvSpPr>
+          <p:nvPr>
+            <p:ph type="sldImg" idx="2"/>
+          </p:nvPr>
+        </p:nvSpPr>
+        <p:spPr/>
+      </p:sp>
+      <p:sp>
+        <p:nvSpPr>
+          <p:cNvPr id="3" name="Notes Placeholder 2"/>
+          <p:cNvSpPr>
+            <a:spLocks noGrp="1"/>
+          </p:cNvSpPr>
+          <p:nvPr>
+            <p:ph type="body" idx="3" sz="quarter"/>
+          </p:nvPr>
+        </p:nvSpPr>
+        <p:spPr/>
+        <p:txBody>
+          <a:bodyPr/>
+          <a:lstStyle/>
+          <a:p>
+            <a:r>
+              <a:t>This is the actual decision slide — say the ask in one sentence before showing the success metrics: "we need a budget scenario approved and a start date for the founding engineer hire." The month-12 metrics exist to answer "how will we know this worked," not to be read verbatim.</a:t>
             </a:r>
           </a:p>
         </p:txBody>
@@ -7464,6 +7535,373 @@
 </p:sld>
 </file>
 
+<file path=ppt/slides/slide17.xml><?xml version="1.0" encoding="utf-8"?>
+<p:sld xmlns:a="http://schemas.openxmlformats.org/drawingml/2006/main" xmlns:p="http://schemas.openxmlformats.org/presentationml/2006/main" xmlns:r="http://schemas.openxmlformats.org/officeDocument/2006/relationships">
+  <p:cSld>
+    <p:bg>
+      <p:bgPr>
+        <a:solidFill>
+          <a:srgbClr val="FFFFFF"/>
+        </a:solidFill>
+        <a:effectLst/>
+      </p:bgPr>
+    </p:bg>
+    <p:spTree>
+      <p:nvGrpSpPr>
+        <p:cNvPr id="1" name=""/>
+        <p:cNvGrpSpPr/>
+        <p:nvPr/>
+      </p:nvGrpSpPr>
+      <p:grpSpPr/>
+      <p:sp>
+        <p:nvSpPr>
+          <p:cNvPr id="2" name="TextBox 1"/>
+          <p:cNvSpPr txBox="1"/>
+          <p:nvPr/>
+        </p:nvSpPr>
+        <p:spPr>
+          <a:xfrm>
+            <a:off x="640080" y="502920"/>
+            <a:ext cx="7315200" cy="320040"/>
+          </a:xfrm>
+          <a:prstGeom prst="rect">
+            <a:avLst/>
+          </a:prstGeom>
+          <a:noFill/>
+        </p:spPr>
+        <p:txBody>
+          <a:bodyPr wrap="square" anchor="ctr">
+            <a:spAutoFit/>
+          </a:bodyPr>
+          <a:lstStyle/>
+          <a:p>
+            <a:pPr algn="l"/>
+            <a:r>
+              <a:rPr sz="1200" b="1" spc="300">
+                <a:solidFill>
+                  <a:srgbClr val="0E6E5C"/>
+                </a:solidFill>
+                <a:latin typeface="Calibri"/>
+              </a:rPr>
+              <a:t>THE ASK</a:t>
+            </a:r>
+          </a:p>
+        </p:txBody>
+      </p:sp>
+      <p:sp>
+        <p:nvSpPr>
+          <p:cNvPr id="3" name="TextBox 2"/>
+          <p:cNvSpPr txBox="1"/>
+          <p:nvPr/>
+        </p:nvSpPr>
+        <p:spPr>
+          <a:xfrm>
+            <a:off x="640080" y="868680"/>
+            <a:ext cx="10881360" cy="777240"/>
+          </a:xfrm>
+          <a:prstGeom prst="rect">
+            <a:avLst/>
+          </a:prstGeom>
+          <a:noFill/>
+        </p:spPr>
+        <p:txBody>
+          <a:bodyPr wrap="square" anchor="ctr">
+            <a:spAutoFit/>
+          </a:bodyPr>
+          <a:lstStyle/>
+          <a:p>
+            <a:pPr algn="l"/>
+            <a:r>
+              <a:rPr sz="3000" b="1">
+                <a:solidFill>
+                  <a:srgbClr val="141821"/>
+                </a:solidFill>
+                <a:latin typeface="Calibri"/>
+              </a:rPr>
+              <a:t>What we need from you, next 90 days.</a:t>
+            </a:r>
+          </a:p>
+        </p:txBody>
+      </p:sp>
+      <p:sp>
+        <p:nvSpPr>
+          <p:cNvPr id="4" name="TextBox 3"/>
+          <p:cNvSpPr txBox="1"/>
+          <p:nvPr/>
+        </p:nvSpPr>
+        <p:spPr>
+          <a:xfrm>
+            <a:off x="640080" y="2103120"/>
+            <a:ext cx="10911840" cy="640080"/>
+          </a:xfrm>
+          <a:prstGeom prst="rect">
+            <a:avLst/>
+          </a:prstGeom>
+          <a:noFill/>
+        </p:spPr>
+        <p:txBody>
+          <a:bodyPr wrap="square" anchor="t">
+            <a:spAutoFit/>
+          </a:bodyPr>
+          <a:lstStyle/>
+          <a:p>
+            <a:pPr algn="l"/>
+            <a:r>
+              <a:rPr sz="1500" b="1">
+                <a:solidFill>
+                  <a:srgbClr val="141821"/>
+                </a:solidFill>
+                <a:latin typeface="Calibri"/>
+              </a:rPr>
+              <a:t>The decision: approve one budget scenario (Lean / Base / Comfortable) and a start date for the founding engineer hire.</a:t>
+            </a:r>
+          </a:p>
+        </p:txBody>
+      </p:sp>
+      <p:sp>
+        <p:nvSpPr>
+          <p:cNvPr id="5" name="Rounded Rectangle 4"/>
+          <p:cNvSpPr/>
+          <p:nvPr/>
+        </p:nvSpPr>
+        <p:spPr>
+          <a:xfrm>
+            <a:off x="640080" y="2960000"/>
+            <a:ext cx="10911840" cy="1600000"/>
+          </a:xfrm>
+          <a:prstGeom prst="roundRect">
+            <a:avLst>
+              <a:gd name="adj" fmla="val 3000"/>
+            </a:avLst>
+          </a:prstGeom>
+          <a:solidFill>
+            <a:srgbClr val="F2F7F5"/>
+          </a:solidFill>
+          <a:ln w="9525">
+            <a:solidFill>
+              <a:srgbClr val="D8DEE4"/>
+            </a:solidFill>
+          </a:ln>
+          <a:effectLst/>
+        </p:spPr>
+        <p:style>
+          <a:lnRef idx="1">
+            <a:schemeClr val="accent1"/>
+          </a:lnRef>
+          <a:fillRef idx="3">
+            <a:schemeClr val="accent1"/>
+          </a:fillRef>
+          <a:effectRef idx="2">
+            <a:schemeClr val="accent1"/>
+          </a:effectRef>
+          <a:fontRef idx="minor">
+            <a:schemeClr val="lt1"/>
+          </a:fontRef>
+        </p:style>
+        <p:txBody>
+          <a:bodyPr rtlCol="0" anchor="ctr"/>
+          <a:lstStyle/>
+          <a:p>
+            <a:pPr algn="ctr"/>
+          </a:p>
+        </p:txBody>
+      </p:sp>
+      <p:sp>
+        <p:nvSpPr>
+          <p:cNvPr id="6" name="TextBox 5"/>
+          <p:cNvSpPr txBox="1"/>
+          <p:nvPr/>
+        </p:nvSpPr>
+        <p:spPr>
+          <a:xfrm>
+            <a:off x="868680" y="3050000"/>
+            <a:ext cx="10454640" cy="365760"/>
+          </a:xfrm>
+          <a:prstGeom prst="rect">
+            <a:avLst/>
+          </a:prstGeom>
+          <a:noFill/>
+        </p:spPr>
+        <p:txBody>
+          <a:bodyPr wrap="square" anchor="ctr">
+            <a:spAutoFit/>
+          </a:bodyPr>
+          <a:lstStyle/>
+          <a:p>
+            <a:pPr algn="l"/>
+            <a:r>
+              <a:rPr sz="1500" b="1">
+                <a:solidFill>
+                  <a:srgbClr val="0E6E5C"/>
+                </a:solidFill>
+                <a:latin typeface="Calibri"/>
+              </a:rPr>
+              <a:t>Next 90 days</a:t>
+            </a:r>
+          </a:p>
+        </p:txBody>
+      </p:sp>
+      <p:sp>
+        <p:nvSpPr>
+          <p:cNvPr id="7" name="TextBox 6"/>
+          <p:cNvSpPr txBox="1"/>
+          <p:nvPr/>
+        </p:nvSpPr>
+        <p:spPr>
+          <a:xfrm>
+            <a:off x="868680" y="3450000"/>
+            <a:ext cx="10454640" cy="1000000"/>
+          </a:xfrm>
+          <a:prstGeom prst="rect">
+            <a:avLst/>
+          </a:prstGeom>
+          <a:noFill/>
+        </p:spPr>
+        <p:txBody>
+          <a:bodyPr wrap="square" anchor="t">
+            <a:spAutoFit/>
+          </a:bodyPr>
+          <a:lstStyle/>
+          <a:p>
+            <a:pPr algn="l"/>
+            <a:r>
+              <a:rPr sz="1300" b="0">
+                <a:solidFill>
+                  <a:srgbClr val="5A6270"/>
+                </a:solidFill>
+                <a:latin typeface="Calibri"/>
+              </a:rPr>
+              <a:t>Phase 0 setup (weeks 0–4) → founding engineer hired and Phase 1 MVP build under way, targeting the one-city Bengaluru launch inside 4 months.</a:t>
+            </a:r>
+          </a:p>
+        </p:txBody>
+      </p:sp>
+      <p:sp>
+        <p:nvSpPr>
+          <p:cNvPr id="8" name="Rounded Rectangle 7"/>
+          <p:cNvSpPr/>
+          <p:nvPr/>
+        </p:nvSpPr>
+        <p:spPr>
+          <a:xfrm>
+            <a:off x="640080" y="4740000"/>
+            <a:ext cx="10911840" cy="1750000"/>
+          </a:xfrm>
+          <a:prstGeom prst="roundRect">
+            <a:avLst>
+              <a:gd name="adj" fmla="val 3000"/>
+            </a:avLst>
+          </a:prstGeom>
+          <a:solidFill>
+            <a:srgbClr val="FFFFFF"/>
+          </a:solidFill>
+          <a:ln w="9525">
+            <a:solidFill>
+              <a:srgbClr val="D8DEE4"/>
+            </a:solidFill>
+          </a:ln>
+          <a:effectLst/>
+        </p:spPr>
+        <p:style>
+          <a:lnRef idx="1">
+            <a:schemeClr val="accent1"/>
+          </a:lnRef>
+          <a:fillRef idx="3">
+            <a:schemeClr val="accent1"/>
+          </a:fillRef>
+          <a:effectRef idx="2">
+            <a:schemeClr val="accent1"/>
+          </a:effectRef>
+          <a:fontRef idx="minor">
+            <a:schemeClr val="lt1"/>
+          </a:fontRef>
+        </p:style>
+        <p:txBody>
+          <a:bodyPr rtlCol="0" anchor="ctr"/>
+          <a:lstStyle/>
+          <a:p>
+            <a:pPr algn="ctr"/>
+          </a:p>
+        </p:txBody>
+      </p:sp>
+      <p:sp>
+        <p:nvSpPr>
+          <p:cNvPr id="9" name="TextBox 8"/>
+          <p:cNvSpPr txBox="1"/>
+          <p:nvPr/>
+        </p:nvSpPr>
+        <p:spPr>
+          <a:xfrm>
+            <a:off x="868680" y="4830000"/>
+            <a:ext cx="10454640" cy="365760"/>
+          </a:xfrm>
+          <a:prstGeom prst="rect">
+            <a:avLst/>
+          </a:prstGeom>
+          <a:noFill/>
+        </p:spPr>
+        <p:txBody>
+          <a:bodyPr wrap="square" anchor="ctr">
+            <a:spAutoFit/>
+          </a:bodyPr>
+          <a:lstStyle/>
+          <a:p>
+            <a:pPr algn="l"/>
+            <a:r>
+              <a:rPr sz="1500" b="1">
+                <a:solidFill>
+                  <a:srgbClr val="0E6E5C"/>
+                </a:solidFill>
+                <a:latin typeface="Calibri"/>
+              </a:rPr>
+              <a:t>What success looks like at month 12</a:t>
+            </a:r>
+          </a:p>
+        </p:txBody>
+      </p:sp>
+      <p:sp>
+        <p:nvSpPr>
+          <p:cNvPr id="10" name="TextBox 9"/>
+          <p:cNvSpPr txBox="1"/>
+          <p:nvPr/>
+        </p:nvSpPr>
+        <p:spPr>
+          <a:xfrm>
+            <a:off x="868680" y="5230000"/>
+            <a:ext cx="10454640" cy="1200000"/>
+          </a:xfrm>
+          <a:prstGeom prst="rect">
+            <a:avLst/>
+          </a:prstGeom>
+          <a:noFill/>
+        </p:spPr>
+        <p:txBody>
+          <a:bodyPr wrap="square" anchor="t">
+            <a:spAutoFit/>
+          </a:bodyPr>
+          <a:lstStyle/>
+          <a:p>
+            <a:pPr algn="l"/>
+            <a:r>
+              <a:rPr sz="1300" b="0">
+                <a:solidFill>
+                  <a:srgbClr val="5A6270"/>
+                </a:solidFill>
+                <a:latin typeface="Calibri"/>
+              </a:rPr>
+              <a:t>200+ verified owner listings per launch locality  ·  &gt;8% free-to-paid connect conversion  ·  &gt;40% contact-to-visit rate  ·  &gt;70% of live inventory verified.</a:t>
+            </a:r>
+          </a:p>
+        </p:txBody>
+      </p:sp>
+    </p:spTree>
+  </p:cSld>
+  <p:clrMapOvr>
+    <a:masterClrMapping/>
+  </p:clrMapOvr>
+</p:sld>
+</file>
+
 <file path=ppt/slides/slide2.xml><?xml version="1.0" encoding="utf-8"?>
 <p:sld xmlns:a="http://schemas.openxmlformats.org/drawingml/2006/main" xmlns:r="http://schemas.openxmlformats.org/officeDocument/2006/relationships" xmlns:p="http://schemas.openxmlformats.org/presentationml/2006/main">
   <p:cSld name="Slide 2">

</xml_diff>

<commit_message>
feat: reorder deck into final 16-slide Act 1/Act 2 sequence, complete pitch deck deliverable
Adds reorder_slides helper, wires FINAL_ORDER_MARKERS into build(), and adds
check_task11 as the full-deck acceptance check (slide count, exact order,
presenter notes, canvas bounds, round-trip load). All 11 check groups pass.
</commit_message>
<xml_diff>
--- a/docs/PropWeb_Pitch_v2.pptx
+++ b/docs/PropWeb_Pitch_v2.pptx
@@ -8,12 +8,11 @@
     <p:sldId id="256" r:id="rId2"/>
     <p:sldId id="257" r:id="rId3"/>
     <p:sldId id="258" r:id="rId4"/>
+    <p:sldId id="265" r:id="rId16"/>
     <p:sldId id="259" r:id="rId5"/>
     <p:sldId id="260" r:id="rId6"/>
     <p:sldId id="261" r:id="rId7"/>
     <p:sldId id="262" r:id="rId8"/>
-    <p:sldId id="264" r:id="rId10"/>
-    <p:sldId id="265" r:id="rId16"/>
     <p:sldId id="266" r:id="rId17"/>
     <p:sldId id="267" r:id="rId18"/>
     <p:sldId id="268" r:id="rId19"/>
@@ -21,6 +20,7 @@
     <p:sldId id="270" r:id="rId21"/>
     <p:sldId id="271" r:id="rId22"/>
     <p:sldId id="272" r:id="rId23"/>
+    <p:sldId id="264" r:id="rId10"/>
   </p:sldIdLst>
   <p:notesMasterIdLst>
     <p:notesMasterId r:id="rId11"/>

</xml_diff>